<commit_message>
Add appendix slides (cases, client process, prioritization engine, MVP brief & adaptive questionnaire) and MVP design doc
</commit_message>
<xml_diff>
--- a/quantum-service-competitor-analysis/Анализ-конкурентов-Q-Scope.pptx
+++ b/quantum-service-competitor-analysis/Анализ-конкурентов-Q-Scope.pptx
@@ -10,6 +10,11 @@
     <p:sldId id="258" r:id="rId9"/>
     <p:sldId id="259" r:id="rId10"/>
     <p:sldId id="260" r:id="rId11"/>
+    <p:sldId id="261" r:id="rId12"/>
+    <p:sldId id="262" r:id="rId13"/>
+    <p:sldId id="263" r:id="rId14"/>
+    <p:sldId id="264" r:id="rId15"/>
+    <p:sldId id="265" r:id="rId16"/>
   </p:sldIdLst>
   <p:sldSz cx="12191695" cy="6858000" type="screen4x3"/>
   <p:notesSz cx="6858000" cy="9144000"/>
@@ -3464,6 +3469,891 @@
 </p:sld>
 </file>
 
+<file path=ppt/slides/slide10.xml><?xml version="1.0" encoding="utf-8"?>
+<p:sld xmlns:a="http://schemas.openxmlformats.org/drawingml/2006/main" xmlns:p="http://schemas.openxmlformats.org/presentationml/2006/main" xmlns:r="http://schemas.openxmlformats.org/officeDocument/2006/relationships">
+  <p:cSld>
+    <p:bg>
+      <p:bgPr>
+        <a:solidFill>
+          <a:srgbClr val="FFFFFF"/>
+        </a:solidFill>
+        <a:effectLst/>
+      </p:bgPr>
+    </p:bg>
+    <p:spTree>
+      <p:nvGrpSpPr>
+        <p:cNvPr id="1" name=""/>
+        <p:cNvGrpSpPr/>
+        <p:nvPr/>
+      </p:nvGrpSpPr>
+      <p:grpSpPr/>
+      <p:sp>
+        <p:nvSpPr>
+          <p:cNvPr id="2" name="Rectangle 1"/>
+          <p:cNvSpPr/>
+          <p:nvPr/>
+        </p:nvSpPr>
+        <p:spPr>
+          <a:xfrm>
+            <a:off x="548640" y="502920"/>
+            <a:ext cx="109728" cy="868680"/>
+          </a:xfrm>
+          <a:prstGeom prst="rect">
+            <a:avLst/>
+          </a:prstGeom>
+          <a:solidFill>
+            <a:srgbClr val="2D6CDF"/>
+          </a:solidFill>
+          <a:ln>
+            <a:noFill/>
+          </a:ln>
+          <a:effectLst/>
+        </p:spPr>
+        <p:style>
+          <a:lnRef idx="1">
+            <a:schemeClr val="accent1"/>
+          </a:lnRef>
+          <a:fillRef idx="3">
+            <a:schemeClr val="accent1"/>
+          </a:fillRef>
+          <a:effectRef idx="2">
+            <a:schemeClr val="accent1"/>
+          </a:effectRef>
+          <a:fontRef idx="minor">
+            <a:schemeClr val="lt1"/>
+          </a:fontRef>
+        </p:style>
+        <p:txBody>
+          <a:bodyPr rtlCol="0" anchor="ctr"/>
+          <a:lstStyle/>
+          <a:p>
+            <a:pPr algn="ctr"/>
+          </a:p>
+        </p:txBody>
+      </p:sp>
+      <p:sp>
+        <p:nvSpPr>
+          <p:cNvPr id="3" name="TextBox 2"/>
+          <p:cNvSpPr txBox="1"/>
+          <p:nvPr/>
+        </p:nvSpPr>
+        <p:spPr>
+          <a:xfrm>
+            <a:off x="841248" y="457200"/>
+            <a:ext cx="10424160" cy="1005840"/>
+          </a:xfrm>
+          <a:prstGeom prst="rect">
+            <a:avLst/>
+          </a:prstGeom>
+          <a:noFill/>
+        </p:spPr>
+        <p:txBody>
+          <a:bodyPr wrap="square" anchor="t" lIns="0" rIns="0" tIns="0" bIns="0">
+            <a:spAutoFit/>
+          </a:bodyPr>
+          <a:lstStyle/>
+          <a:p>
+            <a:r>
+              <a:rPr sz="1200" b="1" i="0">
+                <a:solidFill>
+                  <a:srgbClr val="2D6CDF"/>
+                </a:solidFill>
+                <a:latin typeface="Calibri"/>
+              </a:rPr>
+              <a:t>ПРИЛОЖЕНИЕ · MVP</a:t>
+            </a:r>
+          </a:p>
+          <a:p>
+            <a:pPr>
+              <a:spcBef>
+                <a:spcPts val="200"/>
+              </a:spcBef>
+            </a:pPr>
+            <a:r>
+              <a:rPr sz="2600" b="1" i="0">
+                <a:solidFill>
+                  <a:srgbClr val="1A3E8C"/>
+                </a:solidFill>
+                <a:latin typeface="Calibri"/>
+              </a:rPr>
+              <a:t>Адаптивная анкета без брифа (чат-бот «Акинатор»)</a:t>
+            </a:r>
+          </a:p>
+        </p:txBody>
+      </p:sp>
+      <p:sp>
+        <p:nvSpPr>
+          <p:cNvPr id="4" name="Rectangle 3"/>
+          <p:cNvSpPr/>
+          <p:nvPr/>
+        </p:nvSpPr>
+        <p:spPr>
+          <a:xfrm>
+            <a:off x="548640" y="1481328"/>
+            <a:ext cx="11091672" cy="17780"/>
+          </a:xfrm>
+          <a:prstGeom prst="rect">
+            <a:avLst/>
+          </a:prstGeom>
+          <a:solidFill>
+            <a:srgbClr val="D9E1F2"/>
+          </a:solidFill>
+          <a:ln>
+            <a:noFill/>
+          </a:ln>
+          <a:effectLst/>
+        </p:spPr>
+        <p:style>
+          <a:lnRef idx="1">
+            <a:schemeClr val="accent1"/>
+          </a:lnRef>
+          <a:fillRef idx="3">
+            <a:schemeClr val="accent1"/>
+          </a:fillRef>
+          <a:effectRef idx="2">
+            <a:schemeClr val="accent1"/>
+          </a:effectRef>
+          <a:fontRef idx="minor">
+            <a:schemeClr val="lt1"/>
+          </a:fontRef>
+        </p:style>
+        <p:txBody>
+          <a:bodyPr rtlCol="0" anchor="ctr"/>
+          <a:lstStyle/>
+          <a:p>
+            <a:pPr algn="ctr"/>
+          </a:p>
+        </p:txBody>
+      </p:sp>
+      <p:sp>
+        <p:nvSpPr>
+          <p:cNvPr id="5" name="TextBox 4"/>
+          <p:cNvSpPr txBox="1"/>
+          <p:nvPr/>
+        </p:nvSpPr>
+        <p:spPr>
+          <a:xfrm>
+            <a:off x="11338560" y="6355080"/>
+            <a:ext cx="548640" cy="365760"/>
+          </a:xfrm>
+          <a:prstGeom prst="rect">
+            <a:avLst/>
+          </a:prstGeom>
+          <a:noFill/>
+        </p:spPr>
+        <p:txBody>
+          <a:bodyPr wrap="square" anchor="t" lIns="0" rIns="0" tIns="0" bIns="0">
+            <a:spAutoFit/>
+          </a:bodyPr>
+          <a:lstStyle/>
+          <a:p>
+            <a:pPr algn="r"/>
+            <a:r>
+              <a:rPr sz="1000" b="0" i="0">
+                <a:solidFill>
+                  <a:srgbClr val="666666"/>
+                </a:solidFill>
+                <a:latin typeface="Calibri"/>
+              </a:rPr>
+              <a:t>10 / 10</a:t>
+            </a:r>
+          </a:p>
+        </p:txBody>
+      </p:sp>
+      <p:sp>
+        <p:nvSpPr>
+          <p:cNvPr id="6" name="Rounded Rectangle 5"/>
+          <p:cNvSpPr/>
+          <p:nvPr/>
+        </p:nvSpPr>
+        <p:spPr>
+          <a:xfrm>
+            <a:off x="548640" y="1783080"/>
+            <a:ext cx="6766560" cy="548640"/>
+          </a:xfrm>
+          <a:prstGeom prst="roundRect">
+            <a:avLst/>
+          </a:prstGeom>
+          <a:solidFill>
+            <a:srgbClr val="ECF1FB"/>
+          </a:solidFill>
+          <a:ln w="12700">
+            <a:solidFill>
+              <a:srgbClr val="D9E1F2"/>
+            </a:solidFill>
+          </a:ln>
+          <a:effectLst/>
+        </p:spPr>
+        <p:style>
+          <a:lnRef idx="1">
+            <a:schemeClr val="accent1"/>
+          </a:lnRef>
+          <a:fillRef idx="3">
+            <a:schemeClr val="accent1"/>
+          </a:fillRef>
+          <a:effectRef idx="2">
+            <a:schemeClr val="accent1"/>
+          </a:effectRef>
+          <a:fontRef idx="minor">
+            <a:schemeClr val="lt1"/>
+          </a:fontRef>
+        </p:style>
+        <p:txBody>
+          <a:bodyPr rtlCol="0" anchor="ctr" wrap="square" lIns="128016" tIns="18288" bIns="18288"/>
+          <a:lstStyle/>
+          <a:p>
+            <a:pPr algn="ctr"/>
+            <a:r>
+              <a:rPr sz="1050" b="1" i="0">
+                <a:solidFill>
+                  <a:srgbClr val="2D6CDF"/>
+                </a:solidFill>
+                <a:latin typeface="Calibri"/>
+              </a:rPr>
+              <a:t>Уровень 0:  </a:t>
+            </a:r>
+            <a:r>
+              <a:rPr sz="1000" b="0" i="0">
+                <a:solidFill>
+                  <a:srgbClr val="2B2B2B"/>
+                </a:solidFill>
+                <a:latin typeface="Calibri"/>
+              </a:rPr>
+              <a:t>Отрасль и роль</a:t>
+            </a:r>
+          </a:p>
+        </p:txBody>
+      </p:sp>
+      <p:sp>
+        <p:nvSpPr>
+          <p:cNvPr id="7" name="Rounded Rectangle 6"/>
+          <p:cNvSpPr/>
+          <p:nvPr/>
+        </p:nvSpPr>
+        <p:spPr>
+          <a:xfrm>
+            <a:off x="548640" y="2404872"/>
+            <a:ext cx="6766560" cy="548640"/>
+          </a:xfrm>
+          <a:prstGeom prst="roundRect">
+            <a:avLst/>
+          </a:prstGeom>
+          <a:solidFill>
+            <a:srgbClr val="FFFFFF"/>
+          </a:solidFill>
+          <a:ln w="12700">
+            <a:solidFill>
+              <a:srgbClr val="D9E1F2"/>
+            </a:solidFill>
+          </a:ln>
+          <a:effectLst/>
+        </p:spPr>
+        <p:style>
+          <a:lnRef idx="1">
+            <a:schemeClr val="accent1"/>
+          </a:lnRef>
+          <a:fillRef idx="3">
+            <a:schemeClr val="accent1"/>
+          </a:fillRef>
+          <a:effectRef idx="2">
+            <a:schemeClr val="accent1"/>
+          </a:effectRef>
+          <a:fontRef idx="minor">
+            <a:schemeClr val="lt1"/>
+          </a:fontRef>
+        </p:style>
+        <p:txBody>
+          <a:bodyPr rtlCol="0" anchor="ctr" wrap="square" lIns="128016" tIns="18288" bIns="18288"/>
+          <a:lstStyle/>
+          <a:p>
+            <a:pPr algn="ctr"/>
+            <a:r>
+              <a:rPr sz="1050" b="1" i="0">
+                <a:solidFill>
+                  <a:srgbClr val="2D6CDF"/>
+                </a:solidFill>
+                <a:latin typeface="Calibri"/>
+              </a:rPr>
+              <a:t>Уровень 1:  </a:t>
+            </a:r>
+            <a:r>
+              <a:rPr sz="1000" b="0" i="0">
+                <a:solidFill>
+                  <a:srgbClr val="2B2B2B"/>
+                </a:solidFill>
+                <a:latin typeface="Calibri"/>
+              </a:rPr>
+              <a:t>Тип задачи → архетип: оптимизация / симуляция / сэмплинг / ML</a:t>
+            </a:r>
+          </a:p>
+        </p:txBody>
+      </p:sp>
+      <p:sp>
+        <p:nvSpPr>
+          <p:cNvPr id="8" name="Rounded Rectangle 7"/>
+          <p:cNvSpPr/>
+          <p:nvPr/>
+        </p:nvSpPr>
+        <p:spPr>
+          <a:xfrm>
+            <a:off x="548640" y="3026664"/>
+            <a:ext cx="6766560" cy="548640"/>
+          </a:xfrm>
+          <a:prstGeom prst="roundRect">
+            <a:avLst/>
+          </a:prstGeom>
+          <a:solidFill>
+            <a:srgbClr val="ECF1FB"/>
+          </a:solidFill>
+          <a:ln w="12700">
+            <a:solidFill>
+              <a:srgbClr val="D9E1F2"/>
+            </a:solidFill>
+          </a:ln>
+          <a:effectLst/>
+        </p:spPr>
+        <p:style>
+          <a:lnRef idx="1">
+            <a:schemeClr val="accent1"/>
+          </a:lnRef>
+          <a:fillRef idx="3">
+            <a:schemeClr val="accent1"/>
+          </a:fillRef>
+          <a:effectRef idx="2">
+            <a:schemeClr val="accent1"/>
+          </a:effectRef>
+          <a:fontRef idx="minor">
+            <a:schemeClr val="lt1"/>
+          </a:fontRef>
+        </p:style>
+        <p:txBody>
+          <a:bodyPr rtlCol="0" anchor="ctr" wrap="square" lIns="128016" tIns="18288" bIns="18288"/>
+          <a:lstStyle/>
+          <a:p>
+            <a:pPr algn="ctr"/>
+            <a:r>
+              <a:rPr sz="1050" b="1" i="0">
+                <a:solidFill>
+                  <a:srgbClr val="2D6CDF"/>
+                </a:solidFill>
+                <a:latin typeface="Calibri"/>
+              </a:rPr>
+              <a:t>Уровень 2:  </a:t>
+            </a:r>
+            <a:r>
+              <a:rPr sz="1000" b="0" i="0">
+                <a:solidFill>
+                  <a:srgbClr val="2B2B2B"/>
+                </a:solidFill>
+                <a:latin typeface="Calibri"/>
+              </a:rPr>
+              <a:t>Признаки комбинаторного взрыва и боль классики (gate G1)</a:t>
+            </a:r>
+          </a:p>
+        </p:txBody>
+      </p:sp>
+      <p:sp>
+        <p:nvSpPr>
+          <p:cNvPr id="9" name="Rounded Rectangle 8"/>
+          <p:cNvSpPr/>
+          <p:nvPr/>
+        </p:nvSpPr>
+        <p:spPr>
+          <a:xfrm>
+            <a:off x="548640" y="3648456"/>
+            <a:ext cx="6766560" cy="548640"/>
+          </a:xfrm>
+          <a:prstGeom prst="roundRect">
+            <a:avLst/>
+          </a:prstGeom>
+          <a:solidFill>
+            <a:srgbClr val="FFFFFF"/>
+          </a:solidFill>
+          <a:ln w="12700">
+            <a:solidFill>
+              <a:srgbClr val="D9E1F2"/>
+            </a:solidFill>
+          </a:ln>
+          <a:effectLst/>
+        </p:spPr>
+        <p:style>
+          <a:lnRef idx="1">
+            <a:schemeClr val="accent1"/>
+          </a:lnRef>
+          <a:fillRef idx="3">
+            <a:schemeClr val="accent1"/>
+          </a:fillRef>
+          <a:effectRef idx="2">
+            <a:schemeClr val="accent1"/>
+          </a:effectRef>
+          <a:fontRef idx="minor">
+            <a:schemeClr val="lt1"/>
+          </a:fontRef>
+        </p:style>
+        <p:txBody>
+          <a:bodyPr rtlCol="0" anchor="ctr" wrap="square" lIns="128016" tIns="18288" bIns="18288"/>
+          <a:lstStyle/>
+          <a:p>
+            <a:pPr algn="ctr"/>
+            <a:r>
+              <a:rPr sz="1050" b="1" i="0">
+                <a:solidFill>
+                  <a:srgbClr val="2D6CDF"/>
+                </a:solidFill>
+                <a:latin typeface="Calibri"/>
+              </a:rPr>
+              <a:t>Уровень 3:  </a:t>
+            </a:r>
+            <a:r>
+              <a:rPr sz="1000" b="0" i="0">
+                <a:solidFill>
+                  <a:srgbClr val="2B2B2B"/>
+                </a:solidFill>
+                <a:latin typeface="Calibri"/>
+              </a:rPr>
+              <a:t>Формализуемость: цель + переменные + ограничения (gate G2)</a:t>
+            </a:r>
+          </a:p>
+        </p:txBody>
+      </p:sp>
+      <p:sp>
+        <p:nvSpPr>
+          <p:cNvPr id="10" name="Rounded Rectangle 9"/>
+          <p:cNvSpPr/>
+          <p:nvPr/>
+        </p:nvSpPr>
+        <p:spPr>
+          <a:xfrm>
+            <a:off x="548640" y="4270248"/>
+            <a:ext cx="6766560" cy="548640"/>
+          </a:xfrm>
+          <a:prstGeom prst="roundRect">
+            <a:avLst/>
+          </a:prstGeom>
+          <a:solidFill>
+            <a:srgbClr val="ECF1FB"/>
+          </a:solidFill>
+          <a:ln w="12700">
+            <a:solidFill>
+              <a:srgbClr val="D9E1F2"/>
+            </a:solidFill>
+          </a:ln>
+          <a:effectLst/>
+        </p:spPr>
+        <p:style>
+          <a:lnRef idx="1">
+            <a:schemeClr val="accent1"/>
+          </a:lnRef>
+          <a:fillRef idx="3">
+            <a:schemeClr val="accent1"/>
+          </a:fillRef>
+          <a:effectRef idx="2">
+            <a:schemeClr val="accent1"/>
+          </a:effectRef>
+          <a:fontRef idx="minor">
+            <a:schemeClr val="lt1"/>
+          </a:fontRef>
+        </p:style>
+        <p:txBody>
+          <a:bodyPr rtlCol="0" anchor="ctr" wrap="square" lIns="128016" tIns="18288" bIns="18288"/>
+          <a:lstStyle/>
+          <a:p>
+            <a:pPr algn="ctr"/>
+            <a:r>
+              <a:rPr sz="1050" b="1" i="0">
+                <a:solidFill>
+                  <a:srgbClr val="2D6CDF"/>
+                </a:solidFill>
+                <a:latin typeface="Calibri"/>
+              </a:rPr>
+              <a:t>Уровень 4:  </a:t>
+            </a:r>
+            <a:r>
+              <a:rPr sz="1000" b="0" i="0">
+                <a:solidFill>
+                  <a:srgbClr val="2B2B2B"/>
+                </a:solidFill>
+                <a:latin typeface="Calibri"/>
+              </a:rPr>
+              <a:t>Данные и I/O-bottleneck (gate G3)</a:t>
+            </a:r>
+          </a:p>
+        </p:txBody>
+      </p:sp>
+      <p:sp>
+        <p:nvSpPr>
+          <p:cNvPr id="11" name="Rounded Rectangle 10"/>
+          <p:cNvSpPr/>
+          <p:nvPr/>
+        </p:nvSpPr>
+        <p:spPr>
+          <a:xfrm>
+            <a:off x="548640" y="4892040"/>
+            <a:ext cx="6766560" cy="548640"/>
+          </a:xfrm>
+          <a:prstGeom prst="roundRect">
+            <a:avLst/>
+          </a:prstGeom>
+          <a:solidFill>
+            <a:srgbClr val="FFFFFF"/>
+          </a:solidFill>
+          <a:ln w="12700">
+            <a:solidFill>
+              <a:srgbClr val="D9E1F2"/>
+            </a:solidFill>
+          </a:ln>
+          <a:effectLst/>
+        </p:spPr>
+        <p:style>
+          <a:lnRef idx="1">
+            <a:schemeClr val="accent1"/>
+          </a:lnRef>
+          <a:fillRef idx="3">
+            <a:schemeClr val="accent1"/>
+          </a:fillRef>
+          <a:effectRef idx="2">
+            <a:schemeClr val="accent1"/>
+          </a:effectRef>
+          <a:fontRef idx="minor">
+            <a:schemeClr val="lt1"/>
+          </a:fontRef>
+        </p:style>
+        <p:txBody>
+          <a:bodyPr rtlCol="0" anchor="ctr" wrap="square" lIns="128016" tIns="18288" bIns="18288"/>
+          <a:lstStyle/>
+          <a:p>
+            <a:pPr algn="ctr"/>
+            <a:r>
+              <a:rPr sz="1050" b="1" i="0">
+                <a:solidFill>
+                  <a:srgbClr val="2D6CDF"/>
+                </a:solidFill>
+                <a:latin typeface="Calibri"/>
+              </a:rPr>
+              <a:t>Уровень 5:  </a:t>
+            </a:r>
+            <a:r>
+              <a:rPr sz="1000" b="0" i="0">
+                <a:solidFill>
+                  <a:srgbClr val="2B2B2B"/>
+                </a:solidFill>
+                <a:latin typeface="Calibri"/>
+              </a:rPr>
+              <a:t>Масштаб, частота, экономика → бизнес-ценность</a:t>
+            </a:r>
+          </a:p>
+        </p:txBody>
+      </p:sp>
+      <p:sp>
+        <p:nvSpPr>
+          <p:cNvPr id="12" name="Rounded Rectangle 11"/>
+          <p:cNvSpPr/>
+          <p:nvPr/>
+        </p:nvSpPr>
+        <p:spPr>
+          <a:xfrm>
+            <a:off x="548640" y="5513831"/>
+            <a:ext cx="6766560" cy="548640"/>
+          </a:xfrm>
+          <a:prstGeom prst="roundRect">
+            <a:avLst/>
+          </a:prstGeom>
+          <a:solidFill>
+            <a:srgbClr val="ECF1FB"/>
+          </a:solidFill>
+          <a:ln w="12700">
+            <a:solidFill>
+              <a:srgbClr val="D9E1F2"/>
+            </a:solidFill>
+          </a:ln>
+          <a:effectLst/>
+        </p:spPr>
+        <p:style>
+          <a:lnRef idx="1">
+            <a:schemeClr val="accent1"/>
+          </a:lnRef>
+          <a:fillRef idx="3">
+            <a:schemeClr val="accent1"/>
+          </a:fillRef>
+          <a:effectRef idx="2">
+            <a:schemeClr val="accent1"/>
+          </a:effectRef>
+          <a:fontRef idx="minor">
+            <a:schemeClr val="lt1"/>
+          </a:fontRef>
+        </p:style>
+        <p:txBody>
+          <a:bodyPr rtlCol="0" anchor="ctr" wrap="square" lIns="128016" tIns="18288" bIns="18288"/>
+          <a:lstStyle/>
+          <a:p>
+            <a:pPr algn="ctr"/>
+            <a:r>
+              <a:rPr sz="1050" b="1" i="0">
+                <a:solidFill>
+                  <a:srgbClr val="2D6CDF"/>
+                </a:solidFill>
+                <a:latin typeface="Calibri"/>
+              </a:rPr>
+              <a:t>Уровень 6:  </a:t>
+            </a:r>
+            <a:r>
+              <a:rPr sz="1000" b="0" i="0">
+                <a:solidFill>
+                  <a:srgbClr val="2B2B2B"/>
+                </a:solidFill>
+                <a:latin typeface="Calibri"/>
+              </a:rPr>
+              <a:t>Готовность: данные / ИТ / команда / комплаенс</a:t>
+            </a:r>
+          </a:p>
+        </p:txBody>
+      </p:sp>
+      <p:sp>
+        <p:nvSpPr>
+          <p:cNvPr id="13" name="Rounded Rectangle 12"/>
+          <p:cNvSpPr/>
+          <p:nvPr/>
+        </p:nvSpPr>
+        <p:spPr>
+          <a:xfrm>
+            <a:off x="7543800" y="1783080"/>
+            <a:ext cx="4096512" cy="1828800"/>
+          </a:xfrm>
+          <a:prstGeom prst="roundRect">
+            <a:avLst/>
+          </a:prstGeom>
+          <a:solidFill>
+            <a:srgbClr val="FFFFFF"/>
+          </a:solidFill>
+          <a:ln w="12700">
+            <a:solidFill>
+              <a:srgbClr val="D9E1F2"/>
+            </a:solidFill>
+          </a:ln>
+          <a:effectLst/>
+        </p:spPr>
+        <p:style>
+          <a:lnRef idx="1">
+            <a:schemeClr val="accent1"/>
+          </a:lnRef>
+          <a:fillRef idx="3">
+            <a:schemeClr val="accent1"/>
+          </a:fillRef>
+          <a:effectRef idx="2">
+            <a:schemeClr val="accent1"/>
+          </a:effectRef>
+          <a:fontRef idx="minor">
+            <a:schemeClr val="lt1"/>
+          </a:fontRef>
+        </p:style>
+        <p:txBody>
+          <a:bodyPr rtlCol="0" anchor="ctr" wrap="square" lIns="146304" rIns="128016" tIns="109728" bIns="73152"/>
+          <a:lstStyle/>
+          <a:p>
+            <a:pPr algn="ctr"/>
+            <a:r>
+              <a:rPr sz="1200" b="1" i="0">
+                <a:solidFill>
+                  <a:srgbClr val="1A3E8C"/>
+                </a:solidFill>
+                <a:latin typeface="Calibri"/>
+              </a:rPr>
+              <a:t>Принцип (как Акинатор)</a:t>
+            </a:r>
+          </a:p>
+          <a:p>
+            <a:pPr>
+              <a:spcBef>
+                <a:spcPts val="400"/>
+              </a:spcBef>
+            </a:pPr>
+            <a:r>
+              <a:rPr sz="980" b="0" i="0">
+                <a:solidFill>
+                  <a:srgbClr val="2B2B2B"/>
+                </a:solidFill>
+                <a:latin typeface="Calibri"/>
+              </a:rPr>
+              <a:t>От общего к частному, ветвление по ответам</a:t>
+            </a:r>
+          </a:p>
+          <a:p>
+            <a:pPr>
+              <a:spcBef>
+                <a:spcPts val="400"/>
+              </a:spcBef>
+            </a:pPr>
+            <a:r>
+              <a:rPr sz="980" b="0" i="0">
+                <a:solidFill>
+                  <a:srgbClr val="2B2B2B"/>
+                </a:solidFill>
+                <a:latin typeface="Calibri"/>
+              </a:rPr>
+              <a:t>Закрытые ответы → детерминированный скоринг</a:t>
+            </a:r>
+          </a:p>
+          <a:p>
+            <a:pPr>
+              <a:spcBef>
+                <a:spcPts val="400"/>
+              </a:spcBef>
+            </a:pPr>
+            <a:r>
+              <a:rPr sz="980" b="0" i="0">
+                <a:solidFill>
+                  <a:srgbClr val="2B2B2B"/>
+                </a:solidFill>
+                <a:latin typeface="Calibri"/>
+              </a:rPr>
+              <a:t>«Не знаю» не блокирует; живой индикатор «похоже на…»</a:t>
+            </a:r>
+          </a:p>
+          <a:p>
+            <a:pPr>
+              <a:spcBef>
+                <a:spcPts val="400"/>
+              </a:spcBef>
+            </a:pPr>
+            <a:r>
+              <a:rPr sz="980" b="0" i="0">
+                <a:solidFill>
+                  <a:srgbClr val="2B2B2B"/>
+                </a:solidFill>
+                <a:latin typeface="Calibri"/>
+              </a:rPr>
+              <a:t>8–15 вопросов до результата</a:t>
+            </a:r>
+          </a:p>
+        </p:txBody>
+      </p:sp>
+      <p:sp>
+        <p:nvSpPr>
+          <p:cNvPr id="14" name="Rounded Rectangle 13"/>
+          <p:cNvSpPr/>
+          <p:nvPr/>
+        </p:nvSpPr>
+        <p:spPr>
+          <a:xfrm>
+            <a:off x="7543800" y="3749039"/>
+            <a:ext cx="4096512" cy="2468880"/>
+          </a:xfrm>
+          <a:prstGeom prst="roundRect">
+            <a:avLst/>
+          </a:prstGeom>
+          <a:solidFill>
+            <a:srgbClr val="1E8E5A"/>
+          </a:solidFill>
+          <a:ln w="12700">
+            <a:solidFill>
+              <a:srgbClr val="D9E1F2"/>
+            </a:solidFill>
+          </a:ln>
+          <a:effectLst/>
+        </p:spPr>
+        <p:style>
+          <a:lnRef idx="1">
+            <a:schemeClr val="accent1"/>
+          </a:lnRef>
+          <a:fillRef idx="3">
+            <a:schemeClr val="accent1"/>
+          </a:fillRef>
+          <a:effectRef idx="2">
+            <a:schemeClr val="accent1"/>
+          </a:effectRef>
+          <a:fontRef idx="minor">
+            <a:schemeClr val="lt1"/>
+          </a:fontRef>
+        </p:style>
+        <p:txBody>
+          <a:bodyPr rtlCol="0" anchor="ctr" wrap="square" lIns="146304" rIns="128016" tIns="109728" bIns="73152"/>
+          <a:lstStyle/>
+          <a:p>
+            <a:pPr algn="ctr"/>
+            <a:r>
+              <a:rPr sz="1250" b="1" i="0">
+                <a:solidFill>
+                  <a:srgbClr val="FFFFFF"/>
+                </a:solidFill>
+                <a:latin typeface="Calibri"/>
+              </a:rPr>
+              <a:t>Выход: сценарий + эффект</a:t>
+            </a:r>
+          </a:p>
+          <a:p>
+            <a:pPr>
+              <a:spcBef>
+                <a:spcPts val="400"/>
+              </a:spcBef>
+            </a:pPr>
+            <a:r>
+              <a:rPr sz="980" b="0" i="0">
+                <a:solidFill>
+                  <a:srgbClr val="FFFFFF"/>
+                </a:solidFill>
+                <a:latin typeface="Calibri"/>
+              </a:rPr>
+              <a:t>Вердикт: Перспективно → PoC · Watchlist · Классики достаточно</a:t>
+            </a:r>
+          </a:p>
+          <a:p>
+            <a:pPr>
+              <a:spcBef>
+                <a:spcPts val="400"/>
+              </a:spcBef>
+            </a:pPr>
+            <a:r>
+              <a:rPr sz="980" b="0" i="0">
+                <a:solidFill>
+                  <a:srgbClr val="FFFFFF"/>
+                </a:solidFill>
+                <a:latin typeface="Calibri"/>
+              </a:rPr>
+              <a:t>Сценарий: «ваша задача — {подтип}, формализуется как QUBO, подход — гибридный солвер, похоже на {референс-кейс}»</a:t>
+            </a:r>
+          </a:p>
+          <a:p>
+            <a:pPr>
+              <a:spcBef>
+                <a:spcPts val="400"/>
+              </a:spcBef>
+            </a:pPr>
+            <a:r>
+              <a:rPr sz="980" b="0" i="0">
+                <a:solidFill>
+                  <a:srgbClr val="FFFFFF"/>
+                </a:solidFill>
+                <a:latin typeface="Calibri"/>
+              </a:rPr>
+              <a:t>Оценка эффекта (вилка по аналогии) — не гарантия</a:t>
+            </a:r>
+          </a:p>
+          <a:p>
+            <a:pPr>
+              <a:spcBef>
+                <a:spcPts val="400"/>
+              </a:spcBef>
+            </a:pPr>
+            <a:r>
+              <a:rPr sz="980" b="0" i="0">
+                <a:solidFill>
+                  <a:srgbClr val="FFFFFF"/>
+                </a:solidFill>
+                <a:latin typeface="Calibri"/>
+              </a:rPr>
+              <a:t>Кого позвать + кнопка «передать экспертам» → авто-бриф (PDF)</a:t>
+            </a:r>
+          </a:p>
+        </p:txBody>
+      </p:sp>
+    </p:spTree>
+  </p:cSld>
+  <p:clrMapOvr>
+    <a:masterClrMapping/>
+  </p:clrMapOvr>
+</p:sld>
+</file>
+
 <file path=ppt/slides/slide2.xml><?xml version="1.0" encoding="utf-8"?>
 <p:sld xmlns:a="http://schemas.openxmlformats.org/drawingml/2006/main" xmlns:p="http://schemas.openxmlformats.org/presentationml/2006/main" xmlns:r="http://schemas.openxmlformats.org/officeDocument/2006/relationships">
   <p:cSld>
@@ -3650,7 +4540,7 @@
                 </a:solidFill>
                 <a:latin typeface="Calibri"/>
               </a:rPr>
-              <a:t>2 / 5</a:t>
+              <a:t>2 / 10</a:t>
             </a:r>
           </a:p>
         </p:txBody>
@@ -4327,7 +5217,7 @@
                 </a:solidFill>
                 <a:latin typeface="Calibri"/>
               </a:rPr>
-              <a:t>3 / 5</a:t>
+              <a:t>3 / 10</a:t>
             </a:r>
           </a:p>
         </p:txBody>
@@ -5597,7 +6487,7 @@
                 </a:solidFill>
                 <a:latin typeface="Calibri"/>
               </a:rPr>
-              <a:t>4 / 5</a:t>
+              <a:t>4 / 10</a:t>
             </a:r>
           </a:p>
         </p:txBody>
@@ -6451,7 +7341,7 @@
                 </a:solidFill>
                 <a:latin typeface="Calibri"/>
               </a:rPr>
-              <a:t>5 / 5</a:t>
+              <a:t>5 / 10</a:t>
             </a:r>
           </a:p>
         </p:txBody>
@@ -7226,6 +8116,3156 @@
                 <a:latin typeface="Calibri"/>
               </a:rPr>
               <a:t>Принцип MVP: максимально быстрый и честный предварительный сигнал + чистый бриф для экспертов.</a:t>
+            </a:r>
+          </a:p>
+        </p:txBody>
+      </p:sp>
+    </p:spTree>
+  </p:cSld>
+  <p:clrMapOvr>
+    <a:masterClrMapping/>
+  </p:clrMapOvr>
+</p:sld>
+</file>
+
+<file path=ppt/slides/slide6.xml><?xml version="1.0" encoding="utf-8"?>
+<p:sld xmlns:a="http://schemas.openxmlformats.org/drawingml/2006/main" xmlns:p="http://schemas.openxmlformats.org/presentationml/2006/main" xmlns:r="http://schemas.openxmlformats.org/officeDocument/2006/relationships">
+  <p:cSld>
+    <p:bg>
+      <p:bgPr>
+        <a:solidFill>
+          <a:srgbClr val="FFFFFF"/>
+        </a:solidFill>
+        <a:effectLst/>
+      </p:bgPr>
+    </p:bg>
+    <p:spTree>
+      <p:nvGrpSpPr>
+        <p:cNvPr id="1" name=""/>
+        <p:cNvGrpSpPr/>
+        <p:nvPr/>
+      </p:nvGrpSpPr>
+      <p:grpSpPr/>
+      <p:sp>
+        <p:nvSpPr>
+          <p:cNvPr id="2" name="Rectangle 1"/>
+          <p:cNvSpPr/>
+          <p:nvPr/>
+        </p:nvSpPr>
+        <p:spPr>
+          <a:xfrm>
+            <a:off x="548640" y="502920"/>
+            <a:ext cx="109728" cy="868680"/>
+          </a:xfrm>
+          <a:prstGeom prst="rect">
+            <a:avLst/>
+          </a:prstGeom>
+          <a:solidFill>
+            <a:srgbClr val="2D6CDF"/>
+          </a:solidFill>
+          <a:ln>
+            <a:noFill/>
+          </a:ln>
+          <a:effectLst/>
+        </p:spPr>
+        <p:style>
+          <a:lnRef idx="1">
+            <a:schemeClr val="accent1"/>
+          </a:lnRef>
+          <a:fillRef idx="3">
+            <a:schemeClr val="accent1"/>
+          </a:fillRef>
+          <a:effectRef idx="2">
+            <a:schemeClr val="accent1"/>
+          </a:effectRef>
+          <a:fontRef idx="minor">
+            <a:schemeClr val="lt1"/>
+          </a:fontRef>
+        </p:style>
+        <p:txBody>
+          <a:bodyPr rtlCol="0" anchor="ctr"/>
+          <a:lstStyle/>
+          <a:p>
+            <a:pPr algn="ctr"/>
+          </a:p>
+        </p:txBody>
+      </p:sp>
+      <p:sp>
+        <p:nvSpPr>
+          <p:cNvPr id="3" name="TextBox 2"/>
+          <p:cNvSpPr txBox="1"/>
+          <p:nvPr/>
+        </p:nvSpPr>
+        <p:spPr>
+          <a:xfrm>
+            <a:off x="841248" y="457200"/>
+            <a:ext cx="10424160" cy="1005840"/>
+          </a:xfrm>
+          <a:prstGeom prst="rect">
+            <a:avLst/>
+          </a:prstGeom>
+          <a:noFill/>
+        </p:spPr>
+        <p:txBody>
+          <a:bodyPr wrap="square" anchor="t" lIns="0" rIns="0" tIns="0" bIns="0">
+            <a:spAutoFit/>
+          </a:bodyPr>
+          <a:lstStyle/>
+          <a:p>
+            <a:r>
+              <a:rPr sz="1200" b="1" i="0">
+                <a:solidFill>
+                  <a:srgbClr val="2D6CDF"/>
+                </a:solidFill>
+                <a:latin typeface="Calibri"/>
+              </a:rPr>
+              <a:t>ПРИЛОЖЕНИЕ · КЕЙСЫ</a:t>
+            </a:r>
+          </a:p>
+          <a:p>
+            <a:pPr>
+              <a:spcBef>
+                <a:spcPts val="200"/>
+              </a:spcBef>
+            </a:pPr>
+            <a:r>
+              <a:rPr sz="2600" b="1" i="0">
+                <a:solidFill>
+                  <a:srgbClr val="1A3E8C"/>
+                </a:solidFill>
+                <a:latin typeface="Calibri"/>
+              </a:rPr>
+              <a:t>Что конкуренты уже решают на практике</a:t>
+            </a:r>
+          </a:p>
+        </p:txBody>
+      </p:sp>
+      <p:sp>
+        <p:nvSpPr>
+          <p:cNvPr id="4" name="Rectangle 3"/>
+          <p:cNvSpPr/>
+          <p:nvPr/>
+        </p:nvSpPr>
+        <p:spPr>
+          <a:xfrm>
+            <a:off x="548640" y="1481328"/>
+            <a:ext cx="11091672" cy="17780"/>
+          </a:xfrm>
+          <a:prstGeom prst="rect">
+            <a:avLst/>
+          </a:prstGeom>
+          <a:solidFill>
+            <a:srgbClr val="D9E1F2"/>
+          </a:solidFill>
+          <a:ln>
+            <a:noFill/>
+          </a:ln>
+          <a:effectLst/>
+        </p:spPr>
+        <p:style>
+          <a:lnRef idx="1">
+            <a:schemeClr val="accent1"/>
+          </a:lnRef>
+          <a:fillRef idx="3">
+            <a:schemeClr val="accent1"/>
+          </a:fillRef>
+          <a:effectRef idx="2">
+            <a:schemeClr val="accent1"/>
+          </a:effectRef>
+          <a:fontRef idx="minor">
+            <a:schemeClr val="lt1"/>
+          </a:fontRef>
+        </p:style>
+        <p:txBody>
+          <a:bodyPr rtlCol="0" anchor="ctr"/>
+          <a:lstStyle/>
+          <a:p>
+            <a:pPr algn="ctr"/>
+          </a:p>
+        </p:txBody>
+      </p:sp>
+      <p:sp>
+        <p:nvSpPr>
+          <p:cNvPr id="5" name="TextBox 4"/>
+          <p:cNvSpPr txBox="1"/>
+          <p:nvPr/>
+        </p:nvSpPr>
+        <p:spPr>
+          <a:xfrm>
+            <a:off x="11338560" y="6355080"/>
+            <a:ext cx="548640" cy="365760"/>
+          </a:xfrm>
+          <a:prstGeom prst="rect">
+            <a:avLst/>
+          </a:prstGeom>
+          <a:noFill/>
+        </p:spPr>
+        <p:txBody>
+          <a:bodyPr wrap="square" anchor="t" lIns="0" rIns="0" tIns="0" bIns="0">
+            <a:spAutoFit/>
+          </a:bodyPr>
+          <a:lstStyle/>
+          <a:p>
+            <a:pPr algn="r"/>
+            <a:r>
+              <a:rPr sz="1000" b="0" i="0">
+                <a:solidFill>
+                  <a:srgbClr val="666666"/>
+                </a:solidFill>
+                <a:latin typeface="Calibri"/>
+              </a:rPr>
+              <a:t>6 / 10</a:t>
+            </a:r>
+          </a:p>
+        </p:txBody>
+      </p:sp>
+      <p:graphicFrame>
+        <p:nvGraphicFramePr>
+          <p:cNvPr id="6" name="Table 5"/>
+          <p:cNvGraphicFramePr>
+            <a:graphicFrameLocks noGrp="1"/>
+          </p:cNvGraphicFramePr>
+          <p:nvPr/>
+        </p:nvGraphicFramePr>
+        <p:xfrm>
+          <a:off x="548640" y="1737360"/>
+          <a:ext cx="11091672" cy="4206240"/>
+        </p:xfrm>
+        <a:graphic>
+          <a:graphicData uri="http://schemas.openxmlformats.org/drawingml/2006/table">
+            <a:tbl>
+              <a:tblPr firstRow="0" bandRow="0">
+                <a:tableStyleId>{5C22544A-7EE6-4342-B048-85BDC9FD1C3A}</a:tableStyleId>
+              </a:tblPr>
+              <a:tblGrid>
+                <a:gridCol w="2011680"/>
+                <a:gridCol w="2377440"/>
+                <a:gridCol w="5029200"/>
+                <a:gridCol w="1673352"/>
+              </a:tblGrid>
+              <a:tr h="841248">
+                <a:tc>
+                  <a:txBody>
+                    <a:bodyPr/>
+                    <a:lstStyle/>
+                    <a:p>
+                      <a:r>
+                        <a:rPr sz="1100" b="1">
+                          <a:solidFill>
+                            <a:srgbClr val="FFFFFF"/>
+                          </a:solidFill>
+                          <a:latin typeface="Calibri"/>
+                        </a:rPr>
+                        <a:t>Игрок</a:t>
+                      </a:r>
+                    </a:p>
+                  </a:txBody>
+                  <a:tcPr marL="73152" marR="73152" marT="36576" marB="36576" anchor="ctr">
+                    <a:solidFill>
+                      <a:srgbClr val="1A3E8C"/>
+                    </a:solidFill>
+                  </a:tcPr>
+                </a:tc>
+                <a:tc>
+                  <a:txBody>
+                    <a:bodyPr/>
+                    <a:lstStyle/>
+                    <a:p>
+                      <a:r>
+                        <a:rPr sz="1100" b="1">
+                          <a:solidFill>
+                            <a:srgbClr val="FFFFFF"/>
+                          </a:solidFill>
+                          <a:latin typeface="Calibri"/>
+                        </a:rPr>
+                        <a:t>Архетип задач</a:t>
+                      </a:r>
+                    </a:p>
+                  </a:txBody>
+                  <a:tcPr marL="73152" marR="73152" marT="36576" marB="36576" anchor="ctr">
+                    <a:solidFill>
+                      <a:srgbClr val="1A3E8C"/>
+                    </a:solidFill>
+                  </a:tcPr>
+                </a:tc>
+                <a:tc>
+                  <a:txBody>
+                    <a:bodyPr/>
+                    <a:lstStyle/>
+                    <a:p>
+                      <a:r>
+                        <a:rPr sz="1100" b="1">
+                          <a:solidFill>
+                            <a:srgbClr val="FFFFFF"/>
+                          </a:solidFill>
+                          <a:latin typeface="Calibri"/>
+                        </a:rPr>
+                        <a:t>Примеры кейсов (клиент → задача)</a:t>
+                      </a:r>
+                    </a:p>
+                  </a:txBody>
+                  <a:tcPr marL="73152" marR="73152" marT="36576" marB="36576" anchor="ctr">
+                    <a:solidFill>
+                      <a:srgbClr val="1A3E8C"/>
+                    </a:solidFill>
+                  </a:tcPr>
+                </a:tc>
+                <a:tc>
+                  <a:txBody>
+                    <a:bodyPr/>
+                    <a:lstStyle/>
+                    <a:p>
+                      <a:r>
+                        <a:rPr sz="1100" b="1">
+                          <a:solidFill>
+                            <a:srgbClr val="FFFFFF"/>
+                          </a:solidFill>
+                          <a:latin typeface="Calibri"/>
+                        </a:rPr>
+                        <a:t>Зрелость</a:t>
+                      </a:r>
+                    </a:p>
+                  </a:txBody>
+                  <a:tcPr marL="73152" marR="73152" marT="36576" marB="36576" anchor="ctr">
+                    <a:solidFill>
+                      <a:srgbClr val="1A3E8C"/>
+                    </a:solidFill>
+                  </a:tcPr>
+                </a:tc>
+              </a:tr>
+              <a:tr h="841248">
+                <a:tc>
+                  <a:txBody>
+                    <a:bodyPr/>
+                    <a:lstStyle/>
+                    <a:p>
+                      <a:r>
+                        <a:rPr sz="950" b="1">
+                          <a:solidFill>
+                            <a:srgbClr val="1A3E8C"/>
+                          </a:solidFill>
+                          <a:latin typeface="Calibri"/>
+                        </a:rPr>
+                        <a:t>D-Wave</a:t>
+                      </a:r>
+                    </a:p>
+                  </a:txBody>
+                  <a:tcPr marL="73152" marR="73152" marT="36576" marB="36576" anchor="ctr">
+                    <a:solidFill>
+                      <a:srgbClr val="FFFFFF"/>
+                    </a:solidFill>
+                  </a:tcPr>
+                </a:tc>
+                <a:tc>
+                  <a:txBody>
+                    <a:bodyPr/>
+                    <a:lstStyle/>
+                    <a:p>
+                      <a:r>
+                        <a:rPr sz="950">
+                          <a:solidFill>
+                            <a:srgbClr val="2B2B2B"/>
+                          </a:solidFill>
+                          <a:latin typeface="Calibri"/>
+                        </a:rPr>
+                        <a:t>Комбинаторная оптимизация</a:t>
+                      </a:r>
+                    </a:p>
+                  </a:txBody>
+                  <a:tcPr marL="73152" marR="73152" marT="36576" marB="36576" anchor="ctr">
+                    <a:solidFill>
+                      <a:srgbClr val="FFFFFF"/>
+                    </a:solidFill>
+                  </a:tcPr>
+                </a:tc>
+                <a:tc>
+                  <a:txBody>
+                    <a:bodyPr/>
+                    <a:lstStyle/>
+                    <a:p>
+                      <a:r>
+                        <a:rPr sz="950">
+                          <a:solidFill>
+                            <a:srgbClr val="2B2B2B"/>
+                          </a:solidFill>
+                          <a:latin typeface="Calibri"/>
+                        </a:rPr>
+                        <a:t>Save-On-Foods (расписания, −80% времени) · Port of LA · NTT DOCOMO (−15% сигналов) · Ford Otosan · VW (трафик, paint shop) · DENSO</a:t>
+                      </a:r>
+                    </a:p>
+                  </a:txBody>
+                  <a:tcPr marL="73152" marR="73152" marT="36576" marB="36576" anchor="ctr">
+                    <a:solidFill>
+                      <a:srgbClr val="FFFFFF"/>
+                    </a:solidFill>
+                  </a:tcPr>
+                </a:tc>
+                <a:tc>
+                  <a:txBody>
+                    <a:bodyPr/>
+                    <a:lstStyle/>
+                    <a:p>
+                      <a:r>
+                        <a:rPr sz="950">
+                          <a:solidFill>
+                            <a:srgbClr val="2B2B2B"/>
+                          </a:solidFill>
+                          <a:latin typeface="Calibri"/>
+                        </a:rPr>
+                        <a:t>Есть продакшен</a:t>
+                      </a:r>
+                    </a:p>
+                  </a:txBody>
+                  <a:tcPr marL="73152" marR="73152" marT="36576" marB="36576" anchor="ctr">
+                    <a:solidFill>
+                      <a:srgbClr val="FFFFFF"/>
+                    </a:solidFill>
+                  </a:tcPr>
+                </a:tc>
+              </a:tr>
+              <a:tr h="841248">
+                <a:tc>
+                  <a:txBody>
+                    <a:bodyPr/>
+                    <a:lstStyle/>
+                    <a:p>
+                      <a:r>
+                        <a:rPr sz="950" b="1">
+                          <a:solidFill>
+                            <a:srgbClr val="1A3E8C"/>
+                          </a:solidFill>
+                          <a:latin typeface="Calibri"/>
+                        </a:rPr>
+                        <a:t>IBM Quantum</a:t>
+                      </a:r>
+                    </a:p>
+                  </a:txBody>
+                  <a:tcPr marL="73152" marR="73152" marT="36576" marB="36576" anchor="ctr">
+                    <a:solidFill>
+                      <a:srgbClr val="F7F9FD"/>
+                    </a:solidFill>
+                  </a:tcPr>
+                </a:tc>
+                <a:tc>
+                  <a:txBody>
+                    <a:bodyPr/>
+                    <a:lstStyle/>
+                    <a:p>
+                      <a:r>
+                        <a:rPr sz="950">
+                          <a:solidFill>
+                            <a:srgbClr val="2B2B2B"/>
+                          </a:solidFill>
+                          <a:latin typeface="Calibri"/>
+                        </a:rPr>
+                        <a:t>Симуляция + финансы</a:t>
+                      </a:r>
+                    </a:p>
+                  </a:txBody>
+                  <a:tcPr marL="73152" marR="73152" marT="36576" marB="36576" anchor="ctr">
+                    <a:solidFill>
+                      <a:srgbClr val="F7F9FD"/>
+                    </a:solidFill>
+                  </a:tcPr>
+                </a:tc>
+                <a:tc>
+                  <a:txBody>
+                    <a:bodyPr/>
+                    <a:lstStyle/>
+                    <a:p>
+                      <a:r>
+                        <a:rPr sz="950">
+                          <a:solidFill>
+                            <a:srgbClr val="2B2B2B"/>
+                          </a:solidFill>
+                          <a:latin typeface="Calibri"/>
+                        </a:rPr>
+                        <a:t>Boeing (коррозия) · Mercedes (батареи) · Mitsubishi/JSR (OLED) · JPMorgan · HSBC · Cleveland Clinic</a:t>
+                      </a:r>
+                    </a:p>
+                  </a:txBody>
+                  <a:tcPr marL="73152" marR="73152" marT="36576" marB="36576" anchor="ctr">
+                    <a:solidFill>
+                      <a:srgbClr val="F7F9FD"/>
+                    </a:solidFill>
+                  </a:tcPr>
+                </a:tc>
+                <a:tc>
+                  <a:txBody>
+                    <a:bodyPr/>
+                    <a:lstStyle/>
+                    <a:p>
+                      <a:r>
+                        <a:rPr sz="950">
+                          <a:solidFill>
+                            <a:srgbClr val="2B2B2B"/>
+                          </a:solidFill>
+                          <a:latin typeface="Calibri"/>
+                        </a:rPr>
+                        <a:t>В осн. research</a:t>
+                      </a:r>
+                    </a:p>
+                  </a:txBody>
+                  <a:tcPr marL="73152" marR="73152" marT="36576" marB="36576" anchor="ctr">
+                    <a:solidFill>
+                      <a:srgbClr val="F7F9FD"/>
+                    </a:solidFill>
+                  </a:tcPr>
+                </a:tc>
+              </a:tr>
+              <a:tr h="841248">
+                <a:tc>
+                  <a:txBody>
+                    <a:bodyPr/>
+                    <a:lstStyle/>
+                    <a:p>
+                      <a:r>
+                        <a:rPr sz="950" b="1">
+                          <a:solidFill>
+                            <a:srgbClr val="1A3E8C"/>
+                          </a:solidFill>
+                          <a:latin typeface="Calibri"/>
+                        </a:rPr>
+                        <a:t>Multiverse / QC Ware</a:t>
+                      </a:r>
+                    </a:p>
+                  </a:txBody>
+                  <a:tcPr marL="73152" marR="73152" marT="36576" marB="36576" anchor="ctr">
+                    <a:solidFill>
+                      <a:srgbClr val="FFFFFF"/>
+                    </a:solidFill>
+                  </a:tcPr>
+                </a:tc>
+                <a:tc>
+                  <a:txBody>
+                    <a:bodyPr/>
+                    <a:lstStyle/>
+                    <a:p>
+                      <a:r>
+                        <a:rPr sz="950">
+                          <a:solidFill>
+                            <a:srgbClr val="2B2B2B"/>
+                          </a:solidFill>
+                          <a:latin typeface="Calibri"/>
+                        </a:rPr>
+                        <a:t>Финансы, энергетика, химия</a:t>
+                      </a:r>
+                    </a:p>
+                  </a:txBody>
+                  <a:tcPr marL="73152" marR="73152" marT="36576" marB="36576" anchor="ctr">
+                    <a:solidFill>
+                      <a:srgbClr val="FFFFFF"/>
+                    </a:solidFill>
+                  </a:tcPr>
+                </a:tc>
+                <a:tc>
+                  <a:txBody>
+                    <a:bodyPr/>
+                    <a:lstStyle/>
+                    <a:p>
+                      <a:r>
+                        <a:rPr sz="950">
+                          <a:solidFill>
+                            <a:srgbClr val="2B2B2B"/>
+                          </a:solidFill>
+                          <a:latin typeface="Calibri"/>
+                        </a:rPr>
+                        <a:t>BBVA (портфель) · Iberdrola (батареи в сети) · Telefónica (сжатие LLM) · Goldman Sachs · Covestro · Aisin</a:t>
+                      </a:r>
+                    </a:p>
+                  </a:txBody>
+                  <a:tcPr marL="73152" marR="73152" marT="36576" marB="36576" anchor="ctr">
+                    <a:solidFill>
+                      <a:srgbClr val="FFFFFF"/>
+                    </a:solidFill>
+                  </a:tcPr>
+                </a:tc>
+                <a:tc>
+                  <a:txBody>
+                    <a:bodyPr/>
+                    <a:lstStyle/>
+                    <a:p>
+                      <a:r>
+                        <a:rPr sz="950">
+                          <a:solidFill>
+                            <a:srgbClr val="2B2B2B"/>
+                          </a:solidFill>
+                          <a:latin typeface="Calibri"/>
+                        </a:rPr>
+                        <a:t>PoC / пилоты</a:t>
+                      </a:r>
+                    </a:p>
+                  </a:txBody>
+                  <a:tcPr marL="73152" marR="73152" marT="36576" marB="36576" anchor="ctr">
+                    <a:solidFill>
+                      <a:srgbClr val="FFFFFF"/>
+                    </a:solidFill>
+                  </a:tcPr>
+                </a:tc>
+              </a:tr>
+              <a:tr h="841248">
+                <a:tc>
+                  <a:txBody>
+                    <a:bodyPr/>
+                    <a:lstStyle/>
+                    <a:p>
+                      <a:r>
+                        <a:rPr sz="950" b="1">
+                          <a:solidFill>
+                            <a:srgbClr val="1A3E8C"/>
+                          </a:solidFill>
+                          <a:latin typeface="Calibri"/>
+                        </a:rPr>
+                        <a:t>MS AI Readiness / AWS WA</a:t>
+                      </a:r>
+                    </a:p>
+                  </a:txBody>
+                  <a:tcPr marL="73152" marR="73152" marT="36576" marB="36576" anchor="ctr">
+                    <a:solidFill>
+                      <a:srgbClr val="F7F9FD"/>
+                    </a:solidFill>
+                  </a:tcPr>
+                </a:tc>
+                <a:tc>
+                  <a:txBody>
+                    <a:bodyPr/>
+                    <a:lstStyle/>
+                    <a:p>
+                      <a:r>
+                        <a:rPr sz="950">
+                          <a:solidFill>
+                            <a:srgbClr val="2B2B2B"/>
+                          </a:solidFill>
+                          <a:latin typeface="Calibri"/>
+                        </a:rPr>
+                        <a:t>Не квантовые — self-service ассессмент</a:t>
+                      </a:r>
+                    </a:p>
+                  </a:txBody>
+                  <a:tcPr marL="73152" marR="73152" marT="36576" marB="36576" anchor="ctr">
+                    <a:solidFill>
+                      <a:srgbClr val="F7F9FD"/>
+                    </a:solidFill>
+                  </a:tcPr>
+                </a:tc>
+                <a:tc>
+                  <a:txBody>
+                    <a:bodyPr/>
+                    <a:lstStyle/>
+                    <a:p>
+                      <a:r>
+                        <a:rPr sz="950">
+                          <a:solidFill>
+                            <a:srgbClr val="2B2B2B"/>
+                          </a:solidFill>
+                          <a:latin typeface="Calibri"/>
+                        </a:rPr>
+                        <a:t>Не отраслевые кейсы, а эталон формата: анкета по pillars → скоринг → приоритизированный отчёт</a:t>
+                      </a:r>
+                    </a:p>
+                  </a:txBody>
+                  <a:tcPr marL="73152" marR="73152" marT="36576" marB="36576" anchor="ctr">
+                    <a:solidFill>
+                      <a:srgbClr val="F7F9FD"/>
+                    </a:solidFill>
+                  </a:tcPr>
+                </a:tc>
+                <a:tc>
+                  <a:txBody>
+                    <a:bodyPr/>
+                    <a:lstStyle/>
+                    <a:p>
+                      <a:r>
+                        <a:rPr sz="950">
+                          <a:solidFill>
+                            <a:srgbClr val="2B2B2B"/>
+                          </a:solidFill>
+                          <a:latin typeface="Calibri"/>
+                        </a:rPr>
+                        <a:t>Массовый продукт</a:t>
+                      </a:r>
+                    </a:p>
+                  </a:txBody>
+                  <a:tcPr marL="73152" marR="73152" marT="36576" marB="36576" anchor="ctr">
+                    <a:solidFill>
+                      <a:srgbClr val="F7F9FD"/>
+                    </a:solidFill>
+                  </a:tcPr>
+                </a:tc>
+              </a:tr>
+            </a:tbl>
+          </a:graphicData>
+        </a:graphic>
+      </p:graphicFrame>
+      <p:sp>
+        <p:nvSpPr>
+          <p:cNvPr id="7" name="TextBox 6"/>
+          <p:cNvSpPr txBox="1"/>
+          <p:nvPr/>
+        </p:nvSpPr>
+        <p:spPr>
+          <a:xfrm>
+            <a:off x="548640" y="6126480"/>
+            <a:ext cx="10789920" cy="457200"/>
+          </a:xfrm>
+          <a:prstGeom prst="rect">
+            <a:avLst/>
+          </a:prstGeom>
+          <a:noFill/>
+        </p:spPr>
+        <p:txBody>
+          <a:bodyPr wrap="square" anchor="t" lIns="0" rIns="0" tIns="0" bIns="0">
+            <a:spAutoFit/>
+          </a:bodyPr>
+          <a:lstStyle/>
+          <a:p>
+            <a:r>
+              <a:rPr sz="950" b="0" i="1">
+                <a:solidFill>
+                  <a:srgbClr val="666666"/>
+                </a:solidFill>
+                <a:latin typeface="Calibri"/>
+              </a:rPr>
+              <a:t>Цифры — заявления вендоров/партнёров (PoC/research-стадия), не аудированный production-ROI. Реально «в проде» — преимущественно оптимизация (D-Wave).</a:t>
+            </a:r>
+          </a:p>
+        </p:txBody>
+      </p:sp>
+    </p:spTree>
+  </p:cSld>
+  <p:clrMapOvr>
+    <a:masterClrMapping/>
+  </p:clrMapOvr>
+</p:sld>
+</file>
+
+<file path=ppt/slides/slide7.xml><?xml version="1.0" encoding="utf-8"?>
+<p:sld xmlns:a="http://schemas.openxmlformats.org/drawingml/2006/main" xmlns:p="http://schemas.openxmlformats.org/presentationml/2006/main" xmlns:r="http://schemas.openxmlformats.org/officeDocument/2006/relationships">
+  <p:cSld>
+    <p:bg>
+      <p:bgPr>
+        <a:solidFill>
+          <a:srgbClr val="FFFFFF"/>
+        </a:solidFill>
+        <a:effectLst/>
+      </p:bgPr>
+    </p:bg>
+    <p:spTree>
+      <p:nvGrpSpPr>
+        <p:cNvPr id="1" name=""/>
+        <p:cNvGrpSpPr/>
+        <p:nvPr/>
+      </p:nvGrpSpPr>
+      <p:grpSpPr/>
+      <p:sp>
+        <p:nvSpPr>
+          <p:cNvPr id="2" name="Rectangle 1"/>
+          <p:cNvSpPr/>
+          <p:nvPr/>
+        </p:nvSpPr>
+        <p:spPr>
+          <a:xfrm>
+            <a:off x="548640" y="502920"/>
+            <a:ext cx="109728" cy="868680"/>
+          </a:xfrm>
+          <a:prstGeom prst="rect">
+            <a:avLst/>
+          </a:prstGeom>
+          <a:solidFill>
+            <a:srgbClr val="2D6CDF"/>
+          </a:solidFill>
+          <a:ln>
+            <a:noFill/>
+          </a:ln>
+          <a:effectLst/>
+        </p:spPr>
+        <p:style>
+          <a:lnRef idx="1">
+            <a:schemeClr val="accent1"/>
+          </a:lnRef>
+          <a:fillRef idx="3">
+            <a:schemeClr val="accent1"/>
+          </a:fillRef>
+          <a:effectRef idx="2">
+            <a:schemeClr val="accent1"/>
+          </a:effectRef>
+          <a:fontRef idx="minor">
+            <a:schemeClr val="lt1"/>
+          </a:fontRef>
+        </p:style>
+        <p:txBody>
+          <a:bodyPr rtlCol="0" anchor="ctr"/>
+          <a:lstStyle/>
+          <a:p>
+            <a:pPr algn="ctr"/>
+          </a:p>
+        </p:txBody>
+      </p:sp>
+      <p:sp>
+        <p:nvSpPr>
+          <p:cNvPr id="3" name="TextBox 2"/>
+          <p:cNvSpPr txBox="1"/>
+          <p:nvPr/>
+        </p:nvSpPr>
+        <p:spPr>
+          <a:xfrm>
+            <a:off x="841248" y="457200"/>
+            <a:ext cx="10424160" cy="1005840"/>
+          </a:xfrm>
+          <a:prstGeom prst="rect">
+            <a:avLst/>
+          </a:prstGeom>
+          <a:noFill/>
+        </p:spPr>
+        <p:txBody>
+          <a:bodyPr wrap="square" anchor="t" lIns="0" rIns="0" tIns="0" bIns="0">
+            <a:spAutoFit/>
+          </a:bodyPr>
+          <a:lstStyle/>
+          <a:p>
+            <a:r>
+              <a:rPr sz="1200" b="1" i="0">
+                <a:solidFill>
+                  <a:srgbClr val="2D6CDF"/>
+                </a:solidFill>
+                <a:latin typeface="Calibri"/>
+              </a:rPr>
+              <a:t>ПРИЛОЖЕНИЕ · ПРОЦЕСС</a:t>
+            </a:r>
+          </a:p>
+          <a:p>
+            <a:pPr>
+              <a:spcBef>
+                <a:spcPts val="200"/>
+              </a:spcBef>
+            </a:pPr>
+            <a:r>
+              <a:rPr sz="2600" b="1" i="0">
+                <a:solidFill>
+                  <a:srgbClr val="1A3E8C"/>
+                </a:solidFill>
+                <a:latin typeface="Calibri"/>
+              </a:rPr>
+              <a:t>Как конкуренты выстраивают процесс с клиентом</a:t>
+            </a:r>
+          </a:p>
+        </p:txBody>
+      </p:sp>
+      <p:sp>
+        <p:nvSpPr>
+          <p:cNvPr id="4" name="Rectangle 3"/>
+          <p:cNvSpPr/>
+          <p:nvPr/>
+        </p:nvSpPr>
+        <p:spPr>
+          <a:xfrm>
+            <a:off x="548640" y="1481328"/>
+            <a:ext cx="11091672" cy="17780"/>
+          </a:xfrm>
+          <a:prstGeom prst="rect">
+            <a:avLst/>
+          </a:prstGeom>
+          <a:solidFill>
+            <a:srgbClr val="D9E1F2"/>
+          </a:solidFill>
+          <a:ln>
+            <a:noFill/>
+          </a:ln>
+          <a:effectLst/>
+        </p:spPr>
+        <p:style>
+          <a:lnRef idx="1">
+            <a:schemeClr val="accent1"/>
+          </a:lnRef>
+          <a:fillRef idx="3">
+            <a:schemeClr val="accent1"/>
+          </a:fillRef>
+          <a:effectRef idx="2">
+            <a:schemeClr val="accent1"/>
+          </a:effectRef>
+          <a:fontRef idx="minor">
+            <a:schemeClr val="lt1"/>
+          </a:fontRef>
+        </p:style>
+        <p:txBody>
+          <a:bodyPr rtlCol="0" anchor="ctr"/>
+          <a:lstStyle/>
+          <a:p>
+            <a:pPr algn="ctr"/>
+          </a:p>
+        </p:txBody>
+      </p:sp>
+      <p:sp>
+        <p:nvSpPr>
+          <p:cNvPr id="5" name="TextBox 4"/>
+          <p:cNvSpPr txBox="1"/>
+          <p:nvPr/>
+        </p:nvSpPr>
+        <p:spPr>
+          <a:xfrm>
+            <a:off x="11338560" y="6355080"/>
+            <a:ext cx="548640" cy="365760"/>
+          </a:xfrm>
+          <a:prstGeom prst="rect">
+            <a:avLst/>
+          </a:prstGeom>
+          <a:noFill/>
+        </p:spPr>
+        <p:txBody>
+          <a:bodyPr wrap="square" anchor="t" lIns="0" rIns="0" tIns="0" bIns="0">
+            <a:spAutoFit/>
+          </a:bodyPr>
+          <a:lstStyle/>
+          <a:p>
+            <a:pPr algn="r"/>
+            <a:r>
+              <a:rPr sz="1000" b="0" i="0">
+                <a:solidFill>
+                  <a:srgbClr val="666666"/>
+                </a:solidFill>
+                <a:latin typeface="Calibri"/>
+              </a:rPr>
+              <a:t>7 / 10</a:t>
+            </a:r>
+          </a:p>
+        </p:txBody>
+      </p:sp>
+      <p:sp>
+        <p:nvSpPr>
+          <p:cNvPr id="6" name="Rounded Rectangle 5"/>
+          <p:cNvSpPr/>
+          <p:nvPr/>
+        </p:nvSpPr>
+        <p:spPr>
+          <a:xfrm>
+            <a:off x="548640" y="1783080"/>
+            <a:ext cx="2542032" cy="868680"/>
+          </a:xfrm>
+          <a:prstGeom prst="roundRect">
+            <a:avLst/>
+          </a:prstGeom>
+          <a:solidFill>
+            <a:srgbClr val="1A3E8C"/>
+          </a:solidFill>
+          <a:ln>
+            <a:noFill/>
+          </a:ln>
+          <a:effectLst/>
+        </p:spPr>
+        <p:style>
+          <a:lnRef idx="1">
+            <a:schemeClr val="accent1"/>
+          </a:lnRef>
+          <a:fillRef idx="3">
+            <a:schemeClr val="accent1"/>
+          </a:fillRef>
+          <a:effectRef idx="2">
+            <a:schemeClr val="accent1"/>
+          </a:effectRef>
+          <a:fontRef idx="minor">
+            <a:schemeClr val="lt1"/>
+          </a:fontRef>
+        </p:style>
+        <p:txBody>
+          <a:bodyPr rtlCol="0" anchor="ctr" wrap="square"/>
+          <a:lstStyle/>
+          <a:p>
+            <a:pPr algn="ctr"/>
+            <a:r>
+              <a:rPr sz="1200" b="1" i="0">
+                <a:solidFill>
+                  <a:srgbClr val="FFFFFF"/>
+                </a:solidFill>
+                <a:latin typeface="Calibri"/>
+              </a:rPr>
+              <a:t>1. Discovery</a:t>
+            </a:r>
+          </a:p>
+          <a:p>
+            <a:pPr algn="ctr"/>
+            <a:r>
+              <a:rPr sz="950" b="0" i="0">
+                <a:solidFill>
+                  <a:srgbClr val="FFFFFF"/>
+                </a:solidFill>
+                <a:latin typeface="Calibri"/>
+              </a:rPr>
+              <a:t>(поиск задачи)</a:t>
+            </a:r>
+          </a:p>
+        </p:txBody>
+      </p:sp>
+      <p:sp>
+        <p:nvSpPr>
+          <p:cNvPr id="7" name="Chevron 6"/>
+          <p:cNvSpPr/>
+          <p:nvPr/>
+        </p:nvSpPr>
+        <p:spPr>
+          <a:xfrm>
+            <a:off x="3108960" y="1993392"/>
+            <a:ext cx="256032" cy="457200"/>
+          </a:xfrm>
+          <a:prstGeom prst="chevron">
+            <a:avLst/>
+          </a:prstGeom>
+          <a:solidFill>
+            <a:srgbClr val="2D6CDF"/>
+          </a:solidFill>
+          <a:ln>
+            <a:noFill/>
+          </a:ln>
+          <a:effectLst/>
+        </p:spPr>
+        <p:style>
+          <a:lnRef idx="1">
+            <a:schemeClr val="accent1"/>
+          </a:lnRef>
+          <a:fillRef idx="3">
+            <a:schemeClr val="accent1"/>
+          </a:fillRef>
+          <a:effectRef idx="2">
+            <a:schemeClr val="accent1"/>
+          </a:effectRef>
+          <a:fontRef idx="minor">
+            <a:schemeClr val="lt1"/>
+          </a:fontRef>
+        </p:style>
+        <p:txBody>
+          <a:bodyPr rtlCol="0" anchor="ctr"/>
+          <a:lstStyle/>
+          <a:p>
+            <a:pPr algn="ctr"/>
+          </a:p>
+        </p:txBody>
+      </p:sp>
+      <p:sp>
+        <p:nvSpPr>
+          <p:cNvPr id="8" name="Rounded Rectangle 7"/>
+          <p:cNvSpPr/>
+          <p:nvPr/>
+        </p:nvSpPr>
+        <p:spPr>
+          <a:xfrm>
+            <a:off x="3392424" y="1783080"/>
+            <a:ext cx="2542032" cy="868680"/>
+          </a:xfrm>
+          <a:prstGeom prst="roundRect">
+            <a:avLst/>
+          </a:prstGeom>
+          <a:solidFill>
+            <a:srgbClr val="1A3E8C"/>
+          </a:solidFill>
+          <a:ln>
+            <a:noFill/>
+          </a:ln>
+          <a:effectLst/>
+        </p:spPr>
+        <p:style>
+          <a:lnRef idx="1">
+            <a:schemeClr val="accent1"/>
+          </a:lnRef>
+          <a:fillRef idx="3">
+            <a:schemeClr val="accent1"/>
+          </a:fillRef>
+          <a:effectRef idx="2">
+            <a:schemeClr val="accent1"/>
+          </a:effectRef>
+          <a:fontRef idx="minor">
+            <a:schemeClr val="lt1"/>
+          </a:fontRef>
+        </p:style>
+        <p:txBody>
+          <a:bodyPr rtlCol="0" anchor="ctr" wrap="square"/>
+          <a:lstStyle/>
+          <a:p>
+            <a:pPr algn="ctr"/>
+            <a:r>
+              <a:rPr sz="1200" b="1" i="0">
+                <a:solidFill>
+                  <a:srgbClr val="FFFFFF"/>
+                </a:solidFill>
+                <a:latin typeface="Calibri"/>
+              </a:rPr>
+              <a:t>2. Assessment</a:t>
+            </a:r>
+          </a:p>
+          <a:p>
+            <a:pPr algn="ctr"/>
+            <a:r>
+              <a:rPr sz="950" b="0" i="0">
+                <a:solidFill>
+                  <a:srgbClr val="FFFFFF"/>
+                </a:solidFill>
+                <a:latin typeface="Calibri"/>
+              </a:rPr>
+              <a:t>(оценка применимости)</a:t>
+            </a:r>
+          </a:p>
+        </p:txBody>
+      </p:sp>
+      <p:sp>
+        <p:nvSpPr>
+          <p:cNvPr id="9" name="Chevron 8"/>
+          <p:cNvSpPr/>
+          <p:nvPr/>
+        </p:nvSpPr>
+        <p:spPr>
+          <a:xfrm>
+            <a:off x="5952744" y="1993392"/>
+            <a:ext cx="256032" cy="457200"/>
+          </a:xfrm>
+          <a:prstGeom prst="chevron">
+            <a:avLst/>
+          </a:prstGeom>
+          <a:solidFill>
+            <a:srgbClr val="2D6CDF"/>
+          </a:solidFill>
+          <a:ln>
+            <a:noFill/>
+          </a:ln>
+          <a:effectLst/>
+        </p:spPr>
+        <p:style>
+          <a:lnRef idx="1">
+            <a:schemeClr val="accent1"/>
+          </a:lnRef>
+          <a:fillRef idx="3">
+            <a:schemeClr val="accent1"/>
+          </a:fillRef>
+          <a:effectRef idx="2">
+            <a:schemeClr val="accent1"/>
+          </a:effectRef>
+          <a:fontRef idx="minor">
+            <a:schemeClr val="lt1"/>
+          </a:fontRef>
+        </p:style>
+        <p:txBody>
+          <a:bodyPr rtlCol="0" anchor="ctr"/>
+          <a:lstStyle/>
+          <a:p>
+            <a:pPr algn="ctr"/>
+          </a:p>
+        </p:txBody>
+      </p:sp>
+      <p:sp>
+        <p:nvSpPr>
+          <p:cNvPr id="10" name="Rounded Rectangle 9"/>
+          <p:cNvSpPr/>
+          <p:nvPr/>
+        </p:nvSpPr>
+        <p:spPr>
+          <a:xfrm>
+            <a:off x="6236207" y="1783080"/>
+            <a:ext cx="2542032" cy="868680"/>
+          </a:xfrm>
+          <a:prstGeom prst="roundRect">
+            <a:avLst/>
+          </a:prstGeom>
+          <a:solidFill>
+            <a:srgbClr val="1A3E8C"/>
+          </a:solidFill>
+          <a:ln>
+            <a:noFill/>
+          </a:ln>
+          <a:effectLst/>
+        </p:spPr>
+        <p:style>
+          <a:lnRef idx="1">
+            <a:schemeClr val="accent1"/>
+          </a:lnRef>
+          <a:fillRef idx="3">
+            <a:schemeClr val="accent1"/>
+          </a:fillRef>
+          <a:effectRef idx="2">
+            <a:schemeClr val="accent1"/>
+          </a:effectRef>
+          <a:fontRef idx="minor">
+            <a:schemeClr val="lt1"/>
+          </a:fontRef>
+        </p:style>
+        <p:txBody>
+          <a:bodyPr rtlCol="0" anchor="ctr" wrap="square"/>
+          <a:lstStyle/>
+          <a:p>
+            <a:pPr algn="ctr"/>
+            <a:r>
+              <a:rPr sz="1200" b="1" i="0">
+                <a:solidFill>
+                  <a:srgbClr val="FFFFFF"/>
+                </a:solidFill>
+                <a:latin typeface="Calibri"/>
+              </a:rPr>
+              <a:t>3. PoC / Pilot</a:t>
+            </a:r>
+          </a:p>
+          <a:p>
+            <a:pPr algn="ctr"/>
+            <a:r>
+              <a:rPr sz="950" b="0" i="0">
+                <a:solidFill>
+                  <a:srgbClr val="FFFFFF"/>
+                </a:solidFill>
+                <a:latin typeface="Calibri"/>
+              </a:rPr>
+              <a:t>(прототип на данных)</a:t>
+            </a:r>
+          </a:p>
+        </p:txBody>
+      </p:sp>
+      <p:sp>
+        <p:nvSpPr>
+          <p:cNvPr id="11" name="Chevron 10"/>
+          <p:cNvSpPr/>
+          <p:nvPr/>
+        </p:nvSpPr>
+        <p:spPr>
+          <a:xfrm>
+            <a:off x="8796528" y="1993392"/>
+            <a:ext cx="256032" cy="457200"/>
+          </a:xfrm>
+          <a:prstGeom prst="chevron">
+            <a:avLst/>
+          </a:prstGeom>
+          <a:solidFill>
+            <a:srgbClr val="2D6CDF"/>
+          </a:solidFill>
+          <a:ln>
+            <a:noFill/>
+          </a:ln>
+          <a:effectLst/>
+        </p:spPr>
+        <p:style>
+          <a:lnRef idx="1">
+            <a:schemeClr val="accent1"/>
+          </a:lnRef>
+          <a:fillRef idx="3">
+            <a:schemeClr val="accent1"/>
+          </a:fillRef>
+          <a:effectRef idx="2">
+            <a:schemeClr val="accent1"/>
+          </a:effectRef>
+          <a:fontRef idx="minor">
+            <a:schemeClr val="lt1"/>
+          </a:fontRef>
+        </p:style>
+        <p:txBody>
+          <a:bodyPr rtlCol="0" anchor="ctr"/>
+          <a:lstStyle/>
+          <a:p>
+            <a:pPr algn="ctr"/>
+          </a:p>
+        </p:txBody>
+      </p:sp>
+      <p:sp>
+        <p:nvSpPr>
+          <p:cNvPr id="12" name="Rounded Rectangle 11"/>
+          <p:cNvSpPr/>
+          <p:nvPr/>
+        </p:nvSpPr>
+        <p:spPr>
+          <a:xfrm>
+            <a:off x="9079992" y="1783080"/>
+            <a:ext cx="2542032" cy="868680"/>
+          </a:xfrm>
+          <a:prstGeom prst="roundRect">
+            <a:avLst/>
+          </a:prstGeom>
+          <a:solidFill>
+            <a:srgbClr val="1A3E8C"/>
+          </a:solidFill>
+          <a:ln>
+            <a:noFill/>
+          </a:ln>
+          <a:effectLst/>
+        </p:spPr>
+        <p:style>
+          <a:lnRef idx="1">
+            <a:schemeClr val="accent1"/>
+          </a:lnRef>
+          <a:fillRef idx="3">
+            <a:schemeClr val="accent1"/>
+          </a:fillRef>
+          <a:effectRef idx="2">
+            <a:schemeClr val="accent1"/>
+          </a:effectRef>
+          <a:fontRef idx="minor">
+            <a:schemeClr val="lt1"/>
+          </a:fontRef>
+        </p:style>
+        <p:txBody>
+          <a:bodyPr rtlCol="0" anchor="ctr" wrap="square"/>
+          <a:lstStyle/>
+          <a:p>
+            <a:pPr algn="ctr"/>
+            <a:r>
+              <a:rPr sz="1200" b="1" i="0">
+                <a:solidFill>
+                  <a:srgbClr val="FFFFFF"/>
+                </a:solidFill>
+                <a:latin typeface="Calibri"/>
+              </a:rPr>
+              <a:t>4. Production</a:t>
+            </a:r>
+          </a:p>
+          <a:p>
+            <a:pPr algn="ctr"/>
+            <a:r>
+              <a:rPr sz="950" b="0" i="0">
+                <a:solidFill>
+                  <a:srgbClr val="FFFFFF"/>
+                </a:solidFill>
+                <a:latin typeface="Calibri"/>
+              </a:rPr>
+              <a:t>(внедрение, сопровождение)</a:t>
+            </a:r>
+          </a:p>
+        </p:txBody>
+      </p:sp>
+      <p:sp>
+        <p:nvSpPr>
+          <p:cNvPr id="13" name="TextBox 12"/>
+          <p:cNvSpPr txBox="1"/>
+          <p:nvPr/>
+        </p:nvSpPr>
+        <p:spPr>
+          <a:xfrm>
+            <a:off x="548640" y="2743200"/>
+            <a:ext cx="11064240" cy="365760"/>
+          </a:xfrm>
+          <a:prstGeom prst="rect">
+            <a:avLst/>
+          </a:prstGeom>
+          <a:noFill/>
+        </p:spPr>
+        <p:txBody>
+          <a:bodyPr wrap="square" anchor="t" lIns="0" rIns="0" tIns="0" bIns="0">
+            <a:spAutoFit/>
+          </a:bodyPr>
+          <a:lstStyle/>
+          <a:p>
+            <a:r>
+              <a:rPr sz="1000" b="0" i="1">
+                <a:solidFill>
+                  <a:srgbClr val="666666"/>
+                </a:solidFill>
+                <a:latin typeface="Calibri"/>
+              </a:rPr>
+              <a:t>Общая схема у всех квантовых игроков — консалтинго-ведомая, sales-gated, требует тех-грамотности клиента.</a:t>
+            </a:r>
+          </a:p>
+        </p:txBody>
+      </p:sp>
+      <p:sp>
+        <p:nvSpPr>
+          <p:cNvPr id="14" name="Rounded Rectangle 13"/>
+          <p:cNvSpPr/>
+          <p:nvPr/>
+        </p:nvSpPr>
+        <p:spPr>
+          <a:xfrm>
+            <a:off x="548640" y="3246120"/>
+            <a:ext cx="5349240" cy="868680"/>
+          </a:xfrm>
+          <a:prstGeom prst="roundRect">
+            <a:avLst/>
+          </a:prstGeom>
+          <a:solidFill>
+            <a:srgbClr val="FFFFFF"/>
+          </a:solidFill>
+          <a:ln w="12700">
+            <a:solidFill>
+              <a:srgbClr val="D9E1F2"/>
+            </a:solidFill>
+          </a:ln>
+          <a:effectLst/>
+        </p:spPr>
+        <p:style>
+          <a:lnRef idx="1">
+            <a:schemeClr val="accent1"/>
+          </a:lnRef>
+          <a:fillRef idx="3">
+            <a:schemeClr val="accent1"/>
+          </a:fillRef>
+          <a:effectRef idx="2">
+            <a:schemeClr val="accent1"/>
+          </a:effectRef>
+          <a:fontRef idx="minor">
+            <a:schemeClr val="lt1"/>
+          </a:fontRef>
+        </p:style>
+        <p:txBody>
+          <a:bodyPr rtlCol="0" anchor="ctr" wrap="square" lIns="146304" rIns="128016" tIns="109728" bIns="73152"/>
+          <a:lstStyle/>
+          <a:p>
+            <a:pPr algn="ctr"/>
+            <a:r>
+              <a:rPr sz="1200" b="1" i="0">
+                <a:solidFill>
+                  <a:srgbClr val="1A3E8C"/>
+                </a:solidFill>
+                <a:latin typeface="Calibri"/>
+              </a:rPr>
+              <a:t>D-Wave Launch</a:t>
+            </a:r>
+          </a:p>
+          <a:p>
+            <a:pPr>
+              <a:spcBef>
+                <a:spcPts val="400"/>
+              </a:spcBef>
+            </a:pPr>
+            <a:r>
+              <a:rPr sz="1000" b="0" i="0">
+                <a:solidFill>
+                  <a:srgbClr val="2B2B2B"/>
+                </a:solidFill>
+                <a:latin typeface="Calibri"/>
+              </a:rPr>
+              <a:t>Проф. услуги: эксперты «переводят» задачу в QUBO; доставка через облако Leap.</a:t>
+            </a:r>
+          </a:p>
+        </p:txBody>
+      </p:sp>
+      <p:sp>
+        <p:nvSpPr>
+          <p:cNvPr id="15" name="Rounded Rectangle 14"/>
+          <p:cNvSpPr/>
+          <p:nvPr/>
+        </p:nvSpPr>
+        <p:spPr>
+          <a:xfrm>
+            <a:off x="6126479" y="3246120"/>
+            <a:ext cx="5349240" cy="868680"/>
+          </a:xfrm>
+          <a:prstGeom prst="roundRect">
+            <a:avLst/>
+          </a:prstGeom>
+          <a:solidFill>
+            <a:srgbClr val="FFFFFF"/>
+          </a:solidFill>
+          <a:ln w="12700">
+            <a:solidFill>
+              <a:srgbClr val="D9E1F2"/>
+            </a:solidFill>
+          </a:ln>
+          <a:effectLst/>
+        </p:spPr>
+        <p:style>
+          <a:lnRef idx="1">
+            <a:schemeClr val="accent1"/>
+          </a:lnRef>
+          <a:fillRef idx="3">
+            <a:schemeClr val="accent1"/>
+          </a:fillRef>
+          <a:effectRef idx="2">
+            <a:schemeClr val="accent1"/>
+          </a:effectRef>
+          <a:fontRef idx="minor">
+            <a:schemeClr val="lt1"/>
+          </a:fontRef>
+        </p:style>
+        <p:txBody>
+          <a:bodyPr rtlCol="0" anchor="ctr" wrap="square" lIns="146304" rIns="128016" tIns="109728" bIns="73152"/>
+          <a:lstStyle/>
+          <a:p>
+            <a:pPr algn="ctr"/>
+            <a:r>
+              <a:rPr sz="1200" b="1" i="0">
+                <a:solidFill>
+                  <a:srgbClr val="1A3E8C"/>
+                </a:solidFill>
+                <a:latin typeface="Calibri"/>
+              </a:rPr>
+              <a:t>IBM Quantum</a:t>
+            </a:r>
+          </a:p>
+          <a:p>
+            <a:pPr>
+              <a:spcBef>
+                <a:spcPts val="400"/>
+              </a:spcBef>
+            </a:pPr>
+            <a:r>
+              <a:rPr sz="1000" b="0" i="0">
+                <a:solidFill>
+                  <a:srgbClr val="2B2B2B"/>
+                </a:solidFill>
+                <a:latin typeface="Calibri"/>
+              </a:rPr>
+              <a:t>Членство (Network) + доменные working groups + обучение Quantum Business Foundations.</a:t>
+            </a:r>
+          </a:p>
+        </p:txBody>
+      </p:sp>
+      <p:sp>
+        <p:nvSpPr>
+          <p:cNvPr id="16" name="Rounded Rectangle 15"/>
+          <p:cNvSpPr/>
+          <p:nvPr/>
+        </p:nvSpPr>
+        <p:spPr>
+          <a:xfrm>
+            <a:off x="548640" y="4206240"/>
+            <a:ext cx="5349240" cy="868680"/>
+          </a:xfrm>
+          <a:prstGeom prst="roundRect">
+            <a:avLst/>
+          </a:prstGeom>
+          <a:solidFill>
+            <a:srgbClr val="FFFFFF"/>
+          </a:solidFill>
+          <a:ln w="12700">
+            <a:solidFill>
+              <a:srgbClr val="D9E1F2"/>
+            </a:solidFill>
+          </a:ln>
+          <a:effectLst/>
+        </p:spPr>
+        <p:style>
+          <a:lnRef idx="1">
+            <a:schemeClr val="accent1"/>
+          </a:lnRef>
+          <a:fillRef idx="3">
+            <a:schemeClr val="accent1"/>
+          </a:fillRef>
+          <a:effectRef idx="2">
+            <a:schemeClr val="accent1"/>
+          </a:effectRef>
+          <a:fontRef idx="minor">
+            <a:schemeClr val="lt1"/>
+          </a:fontRef>
+        </p:style>
+        <p:txBody>
+          <a:bodyPr rtlCol="0" anchor="ctr" wrap="square" lIns="146304" rIns="128016" tIns="109728" bIns="73152"/>
+          <a:lstStyle/>
+          <a:p>
+            <a:pPr algn="ctr"/>
+            <a:r>
+              <a:rPr sz="1200" b="1" i="0">
+                <a:solidFill>
+                  <a:srgbClr val="1A3E8C"/>
+                </a:solidFill>
+                <a:latin typeface="Calibri"/>
+              </a:rPr>
+              <a:t>Multiverse / QC Ware</a:t>
+            </a:r>
+          </a:p>
+          <a:p>
+            <a:pPr>
+              <a:spcBef>
+                <a:spcPts val="400"/>
+              </a:spcBef>
+            </a:pPr>
+            <a:r>
+              <a:rPr sz="1000" b="0" i="0">
+                <a:solidFill>
+                  <a:srgbClr val="2B2B2B"/>
+                </a:solidFill>
+                <a:latin typeface="Calibri"/>
+              </a:rPr>
+              <a:t>Продукт (Singularity / Forge) + консалтинг; discovery → PoC → deployment.</a:t>
+            </a:r>
+          </a:p>
+        </p:txBody>
+      </p:sp>
+      <p:sp>
+        <p:nvSpPr>
+          <p:cNvPr id="17" name="Rounded Rectangle 16"/>
+          <p:cNvSpPr/>
+          <p:nvPr/>
+        </p:nvSpPr>
+        <p:spPr>
+          <a:xfrm>
+            <a:off x="6126479" y="4206240"/>
+            <a:ext cx="5349240" cy="868680"/>
+          </a:xfrm>
+          <a:prstGeom prst="roundRect">
+            <a:avLst/>
+          </a:prstGeom>
+          <a:solidFill>
+            <a:srgbClr val="FFFFFF"/>
+          </a:solidFill>
+          <a:ln w="12700">
+            <a:solidFill>
+              <a:srgbClr val="D9E1F2"/>
+            </a:solidFill>
+          </a:ln>
+          <a:effectLst/>
+        </p:spPr>
+        <p:style>
+          <a:lnRef idx="1">
+            <a:schemeClr val="accent1"/>
+          </a:lnRef>
+          <a:fillRef idx="3">
+            <a:schemeClr val="accent1"/>
+          </a:fillRef>
+          <a:effectRef idx="2">
+            <a:schemeClr val="accent1"/>
+          </a:effectRef>
+          <a:fontRef idx="minor">
+            <a:schemeClr val="lt1"/>
+          </a:fontRef>
+        </p:style>
+        <p:txBody>
+          <a:bodyPr rtlCol="0" anchor="ctr" wrap="square" lIns="146304" rIns="128016" tIns="109728" bIns="73152"/>
+          <a:lstStyle/>
+          <a:p>
+            <a:pPr algn="ctr"/>
+            <a:r>
+              <a:rPr sz="1200" b="1" i="0">
+                <a:solidFill>
+                  <a:srgbClr val="1A3E8C"/>
+                </a:solidFill>
+                <a:latin typeface="Calibri"/>
+              </a:rPr>
+              <a:t>MS / AWS (эталон)</a:t>
+            </a:r>
+          </a:p>
+          <a:p>
+            <a:pPr>
+              <a:spcBef>
+                <a:spcPts val="400"/>
+              </a:spcBef>
+            </a:pPr>
+            <a:r>
+              <a:rPr sz="1000" b="0" i="0">
+                <a:solidFill>
+                  <a:srgbClr val="2B2B2B"/>
+                </a:solidFill>
+                <a:latin typeface="Calibri"/>
+              </a:rPr>
+              <a:t>Self-service анкета по pillars, без консультанта; хэндофф к партнёрам.</a:t>
+            </a:r>
+          </a:p>
+        </p:txBody>
+      </p:sp>
+      <p:sp>
+        <p:nvSpPr>
+          <p:cNvPr id="18" name="Rounded Rectangle 17"/>
+          <p:cNvSpPr/>
+          <p:nvPr/>
+        </p:nvSpPr>
+        <p:spPr>
+          <a:xfrm>
+            <a:off x="548640" y="5303520"/>
+            <a:ext cx="11091672" cy="914400"/>
+          </a:xfrm>
+          <a:prstGeom prst="roundRect">
+            <a:avLst/>
+          </a:prstGeom>
+          <a:solidFill>
+            <a:srgbClr val="ECF1FB"/>
+          </a:solidFill>
+          <a:ln w="12700">
+            <a:solidFill>
+              <a:srgbClr val="D9E1F2"/>
+            </a:solidFill>
+          </a:ln>
+          <a:effectLst/>
+        </p:spPr>
+        <p:style>
+          <a:lnRef idx="1">
+            <a:schemeClr val="accent1"/>
+          </a:lnRef>
+          <a:fillRef idx="3">
+            <a:schemeClr val="accent1"/>
+          </a:fillRef>
+          <a:effectRef idx="2">
+            <a:schemeClr val="accent1"/>
+          </a:effectRef>
+          <a:fontRef idx="minor">
+            <a:schemeClr val="lt1"/>
+          </a:fontRef>
+        </p:style>
+        <p:txBody>
+          <a:bodyPr rtlCol="0" anchor="ctr" wrap="square" lIns="146304" rIns="128016" tIns="109728" bIns="73152"/>
+          <a:lstStyle/>
+          <a:p>
+            <a:pPr algn="ctr"/>
+            <a:r>
+              <a:rPr sz="1300" b="1" i="0">
+                <a:solidFill>
+                  <a:srgbClr val="2D6CDF"/>
+                </a:solidFill>
+                <a:latin typeface="Calibri"/>
+              </a:rPr>
+              <a:t>Наш сдвиг (Q-Scope):</a:t>
+            </a:r>
+          </a:p>
+          <a:p>
+            <a:pPr>
+              <a:spcBef>
+                <a:spcPts val="400"/>
+              </a:spcBef>
+            </a:pPr>
+            <a:r>
+              <a:rPr sz="1100" b="0" i="0">
+                <a:solidFill>
+                  <a:srgbClr val="2B2B2B"/>
+                </a:solidFill>
+                <a:latin typeface="Calibri"/>
+              </a:rPr>
+              <a:t>Self-service анкета на входе вместо sales-gated discovery → быстро и дёшево квалифицируем задачу, дальше — структурированный бриф к экспертам. Vendor-нейтрально.</a:t>
+            </a:r>
+          </a:p>
+        </p:txBody>
+      </p:sp>
+    </p:spTree>
+  </p:cSld>
+  <p:clrMapOvr>
+    <a:masterClrMapping/>
+  </p:clrMapOvr>
+</p:sld>
+</file>
+
+<file path=ppt/slides/slide8.xml><?xml version="1.0" encoding="utf-8"?>
+<p:sld xmlns:a="http://schemas.openxmlformats.org/drawingml/2006/main" xmlns:p="http://schemas.openxmlformats.org/presentationml/2006/main" xmlns:r="http://schemas.openxmlformats.org/officeDocument/2006/relationships">
+  <p:cSld>
+    <p:bg>
+      <p:bgPr>
+        <a:solidFill>
+          <a:srgbClr val="FFFFFF"/>
+        </a:solidFill>
+        <a:effectLst/>
+      </p:bgPr>
+    </p:bg>
+    <p:spTree>
+      <p:nvGrpSpPr>
+        <p:cNvPr id="1" name=""/>
+        <p:cNvGrpSpPr/>
+        <p:nvPr/>
+      </p:nvGrpSpPr>
+      <p:grpSpPr/>
+      <p:sp>
+        <p:nvSpPr>
+          <p:cNvPr id="2" name="Rectangle 1"/>
+          <p:cNvSpPr/>
+          <p:nvPr/>
+        </p:nvSpPr>
+        <p:spPr>
+          <a:xfrm>
+            <a:off x="548640" y="502920"/>
+            <a:ext cx="109728" cy="868680"/>
+          </a:xfrm>
+          <a:prstGeom prst="rect">
+            <a:avLst/>
+          </a:prstGeom>
+          <a:solidFill>
+            <a:srgbClr val="2D6CDF"/>
+          </a:solidFill>
+          <a:ln>
+            <a:noFill/>
+          </a:ln>
+          <a:effectLst/>
+        </p:spPr>
+        <p:style>
+          <a:lnRef idx="1">
+            <a:schemeClr val="accent1"/>
+          </a:lnRef>
+          <a:fillRef idx="3">
+            <a:schemeClr val="accent1"/>
+          </a:fillRef>
+          <a:effectRef idx="2">
+            <a:schemeClr val="accent1"/>
+          </a:effectRef>
+          <a:fontRef idx="minor">
+            <a:schemeClr val="lt1"/>
+          </a:fontRef>
+        </p:style>
+        <p:txBody>
+          <a:bodyPr rtlCol="0" anchor="ctr"/>
+          <a:lstStyle/>
+          <a:p>
+            <a:pPr algn="ctr"/>
+          </a:p>
+        </p:txBody>
+      </p:sp>
+      <p:sp>
+        <p:nvSpPr>
+          <p:cNvPr id="3" name="TextBox 2"/>
+          <p:cNvSpPr txBox="1"/>
+          <p:nvPr/>
+        </p:nvSpPr>
+        <p:spPr>
+          <a:xfrm>
+            <a:off x="841248" y="457200"/>
+            <a:ext cx="10424160" cy="1005840"/>
+          </a:xfrm>
+          <a:prstGeom prst="rect">
+            <a:avLst/>
+          </a:prstGeom>
+          <a:noFill/>
+        </p:spPr>
+        <p:txBody>
+          <a:bodyPr wrap="square" anchor="t" lIns="0" rIns="0" tIns="0" bIns="0">
+            <a:spAutoFit/>
+          </a:bodyPr>
+          <a:lstStyle/>
+          <a:p>
+            <a:r>
+              <a:rPr sz="1200" b="1" i="0">
+                <a:solidFill>
+                  <a:srgbClr val="2D6CDF"/>
+                </a:solidFill>
+                <a:latin typeface="Calibri"/>
+              </a:rPr>
+              <a:t>ПРИЛОЖЕНИЕ · ДВИЖОК</a:t>
+            </a:r>
+          </a:p>
+          <a:p>
+            <a:pPr>
+              <a:spcBef>
+                <a:spcPts val="200"/>
+              </a:spcBef>
+            </a:pPr>
+            <a:r>
+              <a:rPr sz="2600" b="1" i="0">
+                <a:solidFill>
+                  <a:srgbClr val="1A3E8C"/>
+                </a:solidFill>
+                <a:latin typeface="Calibri"/>
+              </a:rPr>
+              <a:t>Движок приоритизации инициатив</a:t>
+            </a:r>
+          </a:p>
+        </p:txBody>
+      </p:sp>
+      <p:sp>
+        <p:nvSpPr>
+          <p:cNvPr id="4" name="Rectangle 3"/>
+          <p:cNvSpPr/>
+          <p:nvPr/>
+        </p:nvSpPr>
+        <p:spPr>
+          <a:xfrm>
+            <a:off x="548640" y="1481328"/>
+            <a:ext cx="11091672" cy="17780"/>
+          </a:xfrm>
+          <a:prstGeom prst="rect">
+            <a:avLst/>
+          </a:prstGeom>
+          <a:solidFill>
+            <a:srgbClr val="D9E1F2"/>
+          </a:solidFill>
+          <a:ln>
+            <a:noFill/>
+          </a:ln>
+          <a:effectLst/>
+        </p:spPr>
+        <p:style>
+          <a:lnRef idx="1">
+            <a:schemeClr val="accent1"/>
+          </a:lnRef>
+          <a:fillRef idx="3">
+            <a:schemeClr val="accent1"/>
+          </a:fillRef>
+          <a:effectRef idx="2">
+            <a:schemeClr val="accent1"/>
+          </a:effectRef>
+          <a:fontRef idx="minor">
+            <a:schemeClr val="lt1"/>
+          </a:fontRef>
+        </p:style>
+        <p:txBody>
+          <a:bodyPr rtlCol="0" anchor="ctr"/>
+          <a:lstStyle/>
+          <a:p>
+            <a:pPr algn="ctr"/>
+          </a:p>
+        </p:txBody>
+      </p:sp>
+      <p:sp>
+        <p:nvSpPr>
+          <p:cNvPr id="5" name="TextBox 4"/>
+          <p:cNvSpPr txBox="1"/>
+          <p:nvPr/>
+        </p:nvSpPr>
+        <p:spPr>
+          <a:xfrm>
+            <a:off x="11338560" y="6355080"/>
+            <a:ext cx="548640" cy="365760"/>
+          </a:xfrm>
+          <a:prstGeom prst="rect">
+            <a:avLst/>
+          </a:prstGeom>
+          <a:noFill/>
+        </p:spPr>
+        <p:txBody>
+          <a:bodyPr wrap="square" anchor="t" lIns="0" rIns="0" tIns="0" bIns="0">
+            <a:spAutoFit/>
+          </a:bodyPr>
+          <a:lstStyle/>
+          <a:p>
+            <a:pPr algn="r"/>
+            <a:r>
+              <a:rPr sz="1000" b="0" i="0">
+                <a:solidFill>
+                  <a:srgbClr val="666666"/>
+                </a:solidFill>
+                <a:latin typeface="Calibri"/>
+              </a:rPr>
+              <a:t>8 / 10</a:t>
+            </a:r>
+          </a:p>
+        </p:txBody>
+      </p:sp>
+      <p:sp>
+        <p:nvSpPr>
+          <p:cNvPr id="6" name="Rounded Rectangle 5"/>
+          <p:cNvSpPr/>
+          <p:nvPr/>
+        </p:nvSpPr>
+        <p:spPr>
+          <a:xfrm>
+            <a:off x="548640" y="1783080"/>
+            <a:ext cx="5577840" cy="1691640"/>
+          </a:xfrm>
+          <a:prstGeom prst="roundRect">
+            <a:avLst/>
+          </a:prstGeom>
+          <a:solidFill>
+            <a:srgbClr val="FFFFFF"/>
+          </a:solidFill>
+          <a:ln w="12700">
+            <a:solidFill>
+              <a:srgbClr val="D9E1F2"/>
+            </a:solidFill>
+          </a:ln>
+          <a:effectLst/>
+        </p:spPr>
+        <p:style>
+          <a:lnRef idx="1">
+            <a:schemeClr val="accent1"/>
+          </a:lnRef>
+          <a:fillRef idx="3">
+            <a:schemeClr val="accent1"/>
+          </a:fillRef>
+          <a:effectRef idx="2">
+            <a:schemeClr val="accent1"/>
+          </a:effectRef>
+          <a:fontRef idx="minor">
+            <a:schemeClr val="lt1"/>
+          </a:fontRef>
+        </p:style>
+        <p:txBody>
+          <a:bodyPr rtlCol="0" anchor="ctr" wrap="square" lIns="146304" rIns="128016" tIns="109728" bIns="73152"/>
+          <a:lstStyle/>
+          <a:p>
+            <a:pPr algn="ctr"/>
+            <a:r>
+              <a:rPr sz="1250" b="1" i="0">
+                <a:solidFill>
+                  <a:srgbClr val="1A3E8C"/>
+                </a:solidFill>
+                <a:latin typeface="Calibri"/>
+              </a:rPr>
+              <a:t>Шаг 1. Gate-фильтры (любое «нет» → не для кванта)</a:t>
+            </a:r>
+          </a:p>
+          <a:p>
+            <a:pPr>
+              <a:spcBef>
+                <a:spcPts val="400"/>
+              </a:spcBef>
+            </a:pPr>
+            <a:r>
+              <a:rPr sz="1050" b="0" i="0">
+                <a:solidFill>
+                  <a:srgbClr val="2B2B2B"/>
+                </a:solidFill>
+                <a:latin typeface="Calibri"/>
+              </a:rPr>
+              <a:t>1. Классика провисает (экспоненциально / NP-трудно)</a:t>
+            </a:r>
+          </a:p>
+          <a:p>
+            <a:pPr>
+              <a:spcBef>
+                <a:spcPts val="400"/>
+              </a:spcBef>
+            </a:pPr>
+            <a:r>
+              <a:rPr sz="1050" b="0" i="0">
+                <a:solidFill>
+                  <a:srgbClr val="2B2B2B"/>
+                </a:solidFill>
+                <a:latin typeface="Calibri"/>
+              </a:rPr>
+              <a:t>2. Формализуемо как QUBO / Hamiltonian (цель + ограничения)</a:t>
+            </a:r>
+          </a:p>
+          <a:p>
+            <a:pPr>
+              <a:spcBef>
+                <a:spcPts val="400"/>
+              </a:spcBef>
+            </a:pPr>
+            <a:r>
+              <a:rPr sz="1050" b="0" i="0">
+                <a:solidFill>
+                  <a:srgbClr val="2B2B2B"/>
+                </a:solidFill>
+                <a:latin typeface="Calibri"/>
+              </a:rPr>
+              <a:t>3. Нет I/O-bottleneck (вход мал относительно пространства решений)</a:t>
+            </a:r>
+          </a:p>
+        </p:txBody>
+      </p:sp>
+      <p:sp>
+        <p:nvSpPr>
+          <p:cNvPr id="7" name="Rounded Rectangle 6"/>
+          <p:cNvSpPr/>
+          <p:nvPr/>
+        </p:nvSpPr>
+        <p:spPr>
+          <a:xfrm>
+            <a:off x="548640" y="3611880"/>
+            <a:ext cx="5577840" cy="2606040"/>
+          </a:xfrm>
+          <a:prstGeom prst="roundRect">
+            <a:avLst/>
+          </a:prstGeom>
+          <a:solidFill>
+            <a:srgbClr val="FFFFFF"/>
+          </a:solidFill>
+          <a:ln w="12700">
+            <a:solidFill>
+              <a:srgbClr val="D9E1F2"/>
+            </a:solidFill>
+          </a:ln>
+          <a:effectLst/>
+        </p:spPr>
+        <p:style>
+          <a:lnRef idx="1">
+            <a:schemeClr val="accent1"/>
+          </a:lnRef>
+          <a:fillRef idx="3">
+            <a:schemeClr val="accent1"/>
+          </a:fillRef>
+          <a:effectRef idx="2">
+            <a:schemeClr val="accent1"/>
+          </a:effectRef>
+          <a:fontRef idx="minor">
+            <a:schemeClr val="lt1"/>
+          </a:fontRef>
+        </p:style>
+        <p:txBody>
+          <a:bodyPr rtlCol="0" anchor="ctr" wrap="square" lIns="146304" tIns="109728"/>
+          <a:lstStyle/>
+          <a:p>
+            <a:pPr algn="ctr"/>
+            <a:r>
+              <a:rPr sz="1250" b="1" i="0">
+                <a:solidFill>
+                  <a:srgbClr val="1A3E8C"/>
+                </a:solidFill>
+                <a:latin typeface="Calibri"/>
+              </a:rPr>
+              <a:t>Шаг 2. Взвешенный скоринг (0–5)</a:t>
+            </a:r>
+          </a:p>
+          <a:p>
+            <a:pPr>
+              <a:spcBef>
+                <a:spcPts val="500"/>
+              </a:spcBef>
+            </a:pPr>
+            <a:r>
+              <a:rPr sz="1050" b="1" i="0">
+                <a:solidFill>
+                  <a:srgbClr val="2D6CDF"/>
+                </a:solidFill>
+                <a:latin typeface="Calibri"/>
+              </a:rPr>
+              <a:t>25%  </a:t>
+            </a:r>
+            <a:r>
+              <a:rPr sz="1050" b="0" i="0">
+                <a:solidFill>
+                  <a:srgbClr val="2B2B2B"/>
+                </a:solidFill>
+                <a:latin typeface="Calibri"/>
+              </a:rPr>
+              <a:t>Бизнес-ценность / ROI</a:t>
+            </a:r>
+          </a:p>
+          <a:p>
+            <a:pPr>
+              <a:spcBef>
+                <a:spcPts val="500"/>
+              </a:spcBef>
+            </a:pPr>
+            <a:r>
+              <a:rPr sz="1050" b="1" i="0">
+                <a:solidFill>
+                  <a:srgbClr val="2D6CDF"/>
+                </a:solidFill>
+                <a:latin typeface="Calibri"/>
+              </a:rPr>
+              <a:t>25%  </a:t>
+            </a:r>
+            <a:r>
+              <a:rPr sz="1050" b="0" i="0">
+                <a:solidFill>
+                  <a:srgbClr val="2B2B2B"/>
+                </a:solidFill>
+                <a:latin typeface="Calibri"/>
+              </a:rPr>
+              <a:t>Классическая твёрдость + speedup</a:t>
+            </a:r>
+          </a:p>
+          <a:p>
+            <a:pPr>
+              <a:spcBef>
+                <a:spcPts val="500"/>
+              </a:spcBef>
+            </a:pPr>
+            <a:r>
+              <a:rPr sz="1050" b="1" i="0">
+                <a:solidFill>
+                  <a:srgbClr val="2D6CDF"/>
+                </a:solidFill>
+                <a:latin typeface="Calibri"/>
+              </a:rPr>
+              <a:t>15%  </a:t>
+            </a:r>
+            <a:r>
+              <a:rPr sz="1050" b="0" i="0">
+                <a:solidFill>
+                  <a:srgbClr val="2B2B2B"/>
+                </a:solidFill>
+                <a:latin typeface="Calibri"/>
+              </a:rPr>
+              <a:t>Архетип-fit (симуляция/оптимизация ≫ QML)</a:t>
+            </a:r>
+          </a:p>
+          <a:p>
+            <a:pPr>
+              <a:spcBef>
+                <a:spcPts val="500"/>
+              </a:spcBef>
+            </a:pPr>
+            <a:r>
+              <a:rPr sz="1050" b="1" i="0">
+                <a:solidFill>
+                  <a:srgbClr val="2D6CDF"/>
+                </a:solidFill>
+                <a:latin typeface="Calibri"/>
+              </a:rPr>
+              <a:t>15%  </a:t>
+            </a:r>
+            <a:r>
+              <a:rPr sz="1050" b="0" i="0">
+                <a:solidFill>
+                  <a:srgbClr val="2B2B2B"/>
+                </a:solidFill>
+                <a:latin typeface="Calibri"/>
+              </a:rPr>
+              <a:t>Реализуемость (NISQ сейчас vs FT)</a:t>
+            </a:r>
+          </a:p>
+          <a:p>
+            <a:pPr>
+              <a:spcBef>
+                <a:spcPts val="500"/>
+              </a:spcBef>
+            </a:pPr>
+            <a:r>
+              <a:rPr sz="1050" b="1" i="0">
+                <a:solidFill>
+                  <a:srgbClr val="2D6CDF"/>
+                </a:solidFill>
+                <a:latin typeface="Calibri"/>
+              </a:rPr>
+              <a:t>10%  </a:t>
+            </a:r>
+            <a:r>
+              <a:rPr sz="1050" b="0" i="0">
+                <a:solidFill>
+                  <a:srgbClr val="2B2B2B"/>
+                </a:solidFill>
+                <a:latin typeface="Calibri"/>
+              </a:rPr>
+              <a:t>Готовность данных/инфры/команды</a:t>
+            </a:r>
+          </a:p>
+          <a:p>
+            <a:pPr>
+              <a:spcBef>
+                <a:spcPts val="500"/>
+              </a:spcBef>
+            </a:pPr>
+            <a:r>
+              <a:rPr sz="1050" b="1" i="0">
+                <a:solidFill>
+                  <a:srgbClr val="2D6CDF"/>
+                </a:solidFill>
+                <a:latin typeface="Calibri"/>
+              </a:rPr>
+              <a:t>10%  </a:t>
+            </a:r>
+            <a:r>
+              <a:rPr sz="1050" b="0" i="0">
+                <a:solidFill>
+                  <a:srgbClr val="2B2B2B"/>
+                </a:solidFill>
+                <a:latin typeface="Calibri"/>
+              </a:rPr>
+              <a:t>Допустимость приближённого решения</a:t>
+            </a:r>
+          </a:p>
+        </p:txBody>
+      </p:sp>
+      <p:sp>
+        <p:nvSpPr>
+          <p:cNvPr id="8" name="TextBox 7"/>
+          <p:cNvSpPr txBox="1"/>
+          <p:nvPr/>
+        </p:nvSpPr>
+        <p:spPr>
+          <a:xfrm>
+            <a:off x="6812280" y="1810512"/>
+            <a:ext cx="4297680" cy="320040"/>
+          </a:xfrm>
+          <a:prstGeom prst="rect">
+            <a:avLst/>
+          </a:prstGeom>
+          <a:noFill/>
+        </p:spPr>
+        <p:txBody>
+          <a:bodyPr wrap="square" anchor="t" lIns="0" rIns="0" tIns="0" bIns="0">
+            <a:spAutoFit/>
+          </a:bodyPr>
+          <a:lstStyle/>
+          <a:p>
+            <a:r>
+              <a:rPr sz="1250" b="1" i="0">
+                <a:solidFill>
+                  <a:srgbClr val="1A3E8C"/>
+                </a:solidFill>
+                <a:latin typeface="Calibri"/>
+              </a:rPr>
+              <a:t>Шаг 3. Матрица 2×2 → приоритет</a:t>
+            </a:r>
+          </a:p>
+        </p:txBody>
+      </p:sp>
+      <p:sp>
+        <p:nvSpPr>
+          <p:cNvPr id="9" name="Rounded Rectangle 8"/>
+          <p:cNvSpPr/>
+          <p:nvPr/>
+        </p:nvSpPr>
+        <p:spPr>
+          <a:xfrm>
+            <a:off x="6812280" y="2240280"/>
+            <a:ext cx="2148840" cy="2148840"/>
+          </a:xfrm>
+          <a:prstGeom prst="roundRect">
+            <a:avLst/>
+          </a:prstGeom>
+          <a:solidFill>
+            <a:srgbClr val="ECF1FB"/>
+          </a:solidFill>
+          <a:ln w="25400">
+            <a:solidFill>
+              <a:srgbClr val="FFFFFF"/>
+            </a:solidFill>
+          </a:ln>
+          <a:effectLst/>
+        </p:spPr>
+        <p:style>
+          <a:lnRef idx="1">
+            <a:schemeClr val="accent1"/>
+          </a:lnRef>
+          <a:fillRef idx="3">
+            <a:schemeClr val="accent1"/>
+          </a:fillRef>
+          <a:effectRef idx="2">
+            <a:schemeClr val="accent1"/>
+          </a:effectRef>
+          <a:fontRef idx="minor">
+            <a:schemeClr val="lt1"/>
+          </a:fontRef>
+        </p:style>
+        <p:txBody>
+          <a:bodyPr rtlCol="0" anchor="ctr" wrap="square"/>
+          <a:lstStyle/>
+          <a:p>
+            <a:pPr algn="ctr"/>
+            <a:r>
+              <a:rPr sz="1100" b="1" i="0">
+                <a:solidFill>
+                  <a:srgbClr val="1A3E8C"/>
+                </a:solidFill>
+                <a:latin typeface="Calibri"/>
+              </a:rPr>
+              <a:t>Watchlist / glide path</a:t>
+            </a:r>
+          </a:p>
+        </p:txBody>
+      </p:sp>
+      <p:sp>
+        <p:nvSpPr>
+          <p:cNvPr id="10" name="Rounded Rectangle 9"/>
+          <p:cNvSpPr/>
+          <p:nvPr/>
+        </p:nvSpPr>
+        <p:spPr>
+          <a:xfrm>
+            <a:off x="9015984" y="2240280"/>
+            <a:ext cx="2148840" cy="2148840"/>
+          </a:xfrm>
+          <a:prstGeom prst="roundRect">
+            <a:avLst/>
+          </a:prstGeom>
+          <a:solidFill>
+            <a:srgbClr val="2D6CDF"/>
+          </a:solidFill>
+          <a:ln w="25400">
+            <a:solidFill>
+              <a:srgbClr val="FFFFFF"/>
+            </a:solidFill>
+          </a:ln>
+          <a:effectLst/>
+        </p:spPr>
+        <p:style>
+          <a:lnRef idx="1">
+            <a:schemeClr val="accent1"/>
+          </a:lnRef>
+          <a:fillRef idx="3">
+            <a:schemeClr val="accent1"/>
+          </a:fillRef>
+          <a:effectRef idx="2">
+            <a:schemeClr val="accent1"/>
+          </a:effectRef>
+          <a:fontRef idx="minor">
+            <a:schemeClr val="lt1"/>
+          </a:fontRef>
+        </p:style>
+        <p:txBody>
+          <a:bodyPr rtlCol="0" anchor="ctr" wrap="square"/>
+          <a:lstStyle/>
+          <a:p>
+            <a:pPr algn="ctr"/>
+            <a:r>
+              <a:rPr sz="1100" b="1" i="0">
+                <a:solidFill>
+                  <a:srgbClr val="FFFFFF"/>
+                </a:solidFill>
+                <a:latin typeface="Calibri"/>
+              </a:rPr>
+              <a:t>PoC сейчас</a:t>
+            </a:r>
+          </a:p>
+        </p:txBody>
+      </p:sp>
+      <p:sp>
+        <p:nvSpPr>
+          <p:cNvPr id="11" name="Rounded Rectangle 10"/>
+          <p:cNvSpPr/>
+          <p:nvPr/>
+        </p:nvSpPr>
+        <p:spPr>
+          <a:xfrm>
+            <a:off x="6812280" y="4443984"/>
+            <a:ext cx="2148840" cy="2148840"/>
+          </a:xfrm>
+          <a:prstGeom prst="roundRect">
+            <a:avLst/>
+          </a:prstGeom>
+          <a:solidFill>
+            <a:srgbClr val="EEEFF2"/>
+          </a:solidFill>
+          <a:ln w="25400">
+            <a:solidFill>
+              <a:srgbClr val="FFFFFF"/>
+            </a:solidFill>
+          </a:ln>
+          <a:effectLst/>
+        </p:spPr>
+        <p:style>
+          <a:lnRef idx="1">
+            <a:schemeClr val="accent1"/>
+          </a:lnRef>
+          <a:fillRef idx="3">
+            <a:schemeClr val="accent1"/>
+          </a:fillRef>
+          <a:effectRef idx="2">
+            <a:schemeClr val="accent1"/>
+          </a:effectRef>
+          <a:fontRef idx="minor">
+            <a:schemeClr val="lt1"/>
+          </a:fontRef>
+        </p:style>
+        <p:txBody>
+          <a:bodyPr rtlCol="0" anchor="ctr" wrap="square"/>
+          <a:lstStyle/>
+          <a:p>
+            <a:pPr algn="ctr"/>
+            <a:r>
+              <a:rPr sz="1100" b="1" i="0">
+                <a:solidFill>
+                  <a:srgbClr val="666666"/>
+                </a:solidFill>
+                <a:latin typeface="Calibri"/>
+              </a:rPr>
+              <a:t>Отбросить</a:t>
+            </a:r>
+          </a:p>
+        </p:txBody>
+      </p:sp>
+      <p:sp>
+        <p:nvSpPr>
+          <p:cNvPr id="12" name="Rounded Rectangle 11"/>
+          <p:cNvSpPr/>
+          <p:nvPr/>
+        </p:nvSpPr>
+        <p:spPr>
+          <a:xfrm>
+            <a:off x="9015984" y="4443984"/>
+            <a:ext cx="2148840" cy="2148840"/>
+          </a:xfrm>
+          <a:prstGeom prst="roundRect">
+            <a:avLst/>
+          </a:prstGeom>
+          <a:solidFill>
+            <a:srgbClr val="ECF1FB"/>
+          </a:solidFill>
+          <a:ln w="25400">
+            <a:solidFill>
+              <a:srgbClr val="FFFFFF"/>
+            </a:solidFill>
+          </a:ln>
+          <a:effectLst/>
+        </p:spPr>
+        <p:style>
+          <a:lnRef idx="1">
+            <a:schemeClr val="accent1"/>
+          </a:lnRef>
+          <a:fillRef idx="3">
+            <a:schemeClr val="accent1"/>
+          </a:fillRef>
+          <a:effectRef idx="2">
+            <a:schemeClr val="accent1"/>
+          </a:effectRef>
+          <a:fontRef idx="minor">
+            <a:schemeClr val="lt1"/>
+          </a:fontRef>
+        </p:style>
+        <p:txBody>
+          <a:bodyPr rtlCol="0" anchor="ctr" wrap="square"/>
+          <a:lstStyle/>
+          <a:p>
+            <a:pPr algn="ctr"/>
+            <a:r>
+              <a:rPr sz="1100" b="1" i="0">
+                <a:solidFill>
+                  <a:srgbClr val="1A3E8C"/>
+                </a:solidFill>
+                <a:latin typeface="Calibri"/>
+              </a:rPr>
+              <a:t>Классический / гибридный солвер</a:t>
+            </a:r>
+          </a:p>
+        </p:txBody>
+      </p:sp>
+      <p:sp>
+        <p:nvSpPr>
+          <p:cNvPr id="13" name="TextBox 12"/>
+          <p:cNvSpPr txBox="1"/>
+          <p:nvPr/>
+        </p:nvSpPr>
+        <p:spPr>
+          <a:xfrm>
+            <a:off x="6766560" y="1947672"/>
+            <a:ext cx="4297680" cy="274320"/>
+          </a:xfrm>
+          <a:prstGeom prst="rect">
+            <a:avLst/>
+          </a:prstGeom>
+          <a:noFill/>
+        </p:spPr>
+        <p:txBody>
+          <a:bodyPr wrap="square" anchor="t" lIns="0" rIns="0" tIns="0" bIns="0">
+            <a:spAutoFit/>
+          </a:bodyPr>
+          <a:lstStyle/>
+          <a:p>
+            <a:r>
+              <a:rPr sz="950" b="1" i="0">
+                <a:solidFill>
+                  <a:srgbClr val="666666"/>
+                </a:solidFill>
+                <a:latin typeface="Calibri"/>
+              </a:rPr>
+              <a:t>↑ Квантовый потенциал</a:t>
+            </a:r>
+          </a:p>
+        </p:txBody>
+      </p:sp>
+      <p:sp>
+        <p:nvSpPr>
+          <p:cNvPr id="14" name="TextBox 13"/>
+          <p:cNvSpPr txBox="1"/>
+          <p:nvPr/>
+        </p:nvSpPr>
+        <p:spPr>
+          <a:xfrm>
+            <a:off x="6812280" y="6702552"/>
+            <a:ext cx="4352544" cy="274320"/>
+          </a:xfrm>
+          <a:prstGeom prst="rect">
+            <a:avLst/>
+          </a:prstGeom>
+          <a:noFill/>
+        </p:spPr>
+        <p:txBody>
+          <a:bodyPr wrap="square" anchor="t" lIns="0" rIns="0" tIns="0" bIns="0">
+            <a:spAutoFit/>
+          </a:bodyPr>
+          <a:lstStyle/>
+          <a:p>
+            <a:pPr algn="ctr"/>
+            <a:r>
+              <a:rPr sz="950" b="1" i="0">
+                <a:solidFill>
+                  <a:srgbClr val="666666"/>
+                </a:solidFill>
+                <a:latin typeface="Calibri"/>
+              </a:rPr>
+              <a:t>Бизнес-ценность / реализуемость →</a:t>
+            </a:r>
+          </a:p>
+        </p:txBody>
+      </p:sp>
+    </p:spTree>
+  </p:cSld>
+  <p:clrMapOvr>
+    <a:masterClrMapping/>
+  </p:clrMapOvr>
+</p:sld>
+</file>
+
+<file path=ppt/slides/slide9.xml><?xml version="1.0" encoding="utf-8"?>
+<p:sld xmlns:a="http://schemas.openxmlformats.org/drawingml/2006/main" xmlns:p="http://schemas.openxmlformats.org/presentationml/2006/main" xmlns:r="http://schemas.openxmlformats.org/officeDocument/2006/relationships">
+  <p:cSld>
+    <p:bg>
+      <p:bgPr>
+        <a:solidFill>
+          <a:srgbClr val="FFFFFF"/>
+        </a:solidFill>
+        <a:effectLst/>
+      </p:bgPr>
+    </p:bg>
+    <p:spTree>
+      <p:nvGrpSpPr>
+        <p:cNvPr id="1" name=""/>
+        <p:cNvGrpSpPr/>
+        <p:nvPr/>
+      </p:nvGrpSpPr>
+      <p:grpSpPr/>
+      <p:sp>
+        <p:nvSpPr>
+          <p:cNvPr id="2" name="Rectangle 1"/>
+          <p:cNvSpPr/>
+          <p:nvPr/>
+        </p:nvSpPr>
+        <p:spPr>
+          <a:xfrm>
+            <a:off x="548640" y="502920"/>
+            <a:ext cx="109728" cy="868680"/>
+          </a:xfrm>
+          <a:prstGeom prst="rect">
+            <a:avLst/>
+          </a:prstGeom>
+          <a:solidFill>
+            <a:srgbClr val="2D6CDF"/>
+          </a:solidFill>
+          <a:ln>
+            <a:noFill/>
+          </a:ln>
+          <a:effectLst/>
+        </p:spPr>
+        <p:style>
+          <a:lnRef idx="1">
+            <a:schemeClr val="accent1"/>
+          </a:lnRef>
+          <a:fillRef idx="3">
+            <a:schemeClr val="accent1"/>
+          </a:fillRef>
+          <a:effectRef idx="2">
+            <a:schemeClr val="accent1"/>
+          </a:effectRef>
+          <a:fontRef idx="minor">
+            <a:schemeClr val="lt1"/>
+          </a:fontRef>
+        </p:style>
+        <p:txBody>
+          <a:bodyPr rtlCol="0" anchor="ctr"/>
+          <a:lstStyle/>
+          <a:p>
+            <a:pPr algn="ctr"/>
+          </a:p>
+        </p:txBody>
+      </p:sp>
+      <p:sp>
+        <p:nvSpPr>
+          <p:cNvPr id="3" name="TextBox 2"/>
+          <p:cNvSpPr txBox="1"/>
+          <p:nvPr/>
+        </p:nvSpPr>
+        <p:spPr>
+          <a:xfrm>
+            <a:off x="841248" y="457200"/>
+            <a:ext cx="10424160" cy="1005840"/>
+          </a:xfrm>
+          <a:prstGeom prst="rect">
+            <a:avLst/>
+          </a:prstGeom>
+          <a:noFill/>
+        </p:spPr>
+        <p:txBody>
+          <a:bodyPr wrap="square" anchor="t" lIns="0" rIns="0" tIns="0" bIns="0">
+            <a:spAutoFit/>
+          </a:bodyPr>
+          <a:lstStyle/>
+          <a:p>
+            <a:r>
+              <a:rPr sz="1200" b="1" i="0">
+                <a:solidFill>
+                  <a:srgbClr val="2D6CDF"/>
+                </a:solidFill>
+                <a:latin typeface="Calibri"/>
+              </a:rPr>
+              <a:t>ПРИЛОЖЕНИЕ · MVP</a:t>
+            </a:r>
+          </a:p>
+          <a:p>
+            <a:pPr>
+              <a:spcBef>
+                <a:spcPts val="200"/>
+              </a:spcBef>
+            </a:pPr>
+            <a:r>
+              <a:rPr sz="2600" b="1" i="0">
+                <a:solidFill>
+                  <a:srgbClr val="1A3E8C"/>
+                </a:solidFill>
+                <a:latin typeface="Calibri"/>
+              </a:rPr>
+              <a:t>Бриф задачи и подготовка клиента</a:t>
+            </a:r>
+          </a:p>
+        </p:txBody>
+      </p:sp>
+      <p:sp>
+        <p:nvSpPr>
+          <p:cNvPr id="4" name="Rectangle 3"/>
+          <p:cNvSpPr/>
+          <p:nvPr/>
+        </p:nvSpPr>
+        <p:spPr>
+          <a:xfrm>
+            <a:off x="548640" y="1481328"/>
+            <a:ext cx="11091672" cy="17780"/>
+          </a:xfrm>
+          <a:prstGeom prst="rect">
+            <a:avLst/>
+          </a:prstGeom>
+          <a:solidFill>
+            <a:srgbClr val="D9E1F2"/>
+          </a:solidFill>
+          <a:ln>
+            <a:noFill/>
+          </a:ln>
+          <a:effectLst/>
+        </p:spPr>
+        <p:style>
+          <a:lnRef idx="1">
+            <a:schemeClr val="accent1"/>
+          </a:lnRef>
+          <a:fillRef idx="3">
+            <a:schemeClr val="accent1"/>
+          </a:fillRef>
+          <a:effectRef idx="2">
+            <a:schemeClr val="accent1"/>
+          </a:effectRef>
+          <a:fontRef idx="minor">
+            <a:schemeClr val="lt1"/>
+          </a:fontRef>
+        </p:style>
+        <p:txBody>
+          <a:bodyPr rtlCol="0" anchor="ctr"/>
+          <a:lstStyle/>
+          <a:p>
+            <a:pPr algn="ctr"/>
+          </a:p>
+        </p:txBody>
+      </p:sp>
+      <p:sp>
+        <p:nvSpPr>
+          <p:cNvPr id="5" name="TextBox 4"/>
+          <p:cNvSpPr txBox="1"/>
+          <p:nvPr/>
+        </p:nvSpPr>
+        <p:spPr>
+          <a:xfrm>
+            <a:off x="11338560" y="6355080"/>
+            <a:ext cx="548640" cy="365760"/>
+          </a:xfrm>
+          <a:prstGeom prst="rect">
+            <a:avLst/>
+          </a:prstGeom>
+          <a:noFill/>
+        </p:spPr>
+        <p:txBody>
+          <a:bodyPr wrap="square" anchor="t" lIns="0" rIns="0" tIns="0" bIns="0">
+            <a:spAutoFit/>
+          </a:bodyPr>
+          <a:lstStyle/>
+          <a:p>
+            <a:pPr algn="r"/>
+            <a:r>
+              <a:rPr sz="1000" b="0" i="0">
+                <a:solidFill>
+                  <a:srgbClr val="666666"/>
+                </a:solidFill>
+                <a:latin typeface="Calibri"/>
+              </a:rPr>
+              <a:t>9 / 10</a:t>
+            </a:r>
+          </a:p>
+        </p:txBody>
+      </p:sp>
+      <p:sp>
+        <p:nvSpPr>
+          <p:cNvPr id="6" name="Rounded Rectangle 5"/>
+          <p:cNvSpPr/>
+          <p:nvPr/>
+        </p:nvSpPr>
+        <p:spPr>
+          <a:xfrm>
+            <a:off x="548640" y="1783080"/>
+            <a:ext cx="5760720" cy="4434840"/>
+          </a:xfrm>
+          <a:prstGeom prst="roundRect">
+            <a:avLst/>
+          </a:prstGeom>
+          <a:solidFill>
+            <a:srgbClr val="FFFFFF"/>
+          </a:solidFill>
+          <a:ln w="12700">
+            <a:solidFill>
+              <a:srgbClr val="D9E1F2"/>
+            </a:solidFill>
+          </a:ln>
+          <a:effectLst/>
+        </p:spPr>
+        <p:style>
+          <a:lnRef idx="1">
+            <a:schemeClr val="accent1"/>
+          </a:lnRef>
+          <a:fillRef idx="3">
+            <a:schemeClr val="accent1"/>
+          </a:fillRef>
+          <a:effectRef idx="2">
+            <a:schemeClr val="accent1"/>
+          </a:effectRef>
+          <a:fontRef idx="minor">
+            <a:schemeClr val="lt1"/>
+          </a:fontRef>
+        </p:style>
+        <p:txBody>
+          <a:bodyPr rtlCol="0" anchor="ctr" wrap="square" lIns="164592" tIns="128016"/>
+          <a:lstStyle/>
+          <a:p>
+            <a:pPr algn="ctr"/>
+            <a:r>
+              <a:rPr sz="1300" b="1" i="0">
+                <a:solidFill>
+                  <a:srgbClr val="1A3E8C"/>
+                </a:solidFill>
+                <a:latin typeface="Calibri"/>
+              </a:rPr>
+              <a:t>Структура брифа (12 секций)</a:t>
+            </a:r>
+          </a:p>
+          <a:p>
+            <a:pPr>
+              <a:spcBef>
+                <a:spcPts val="300"/>
+              </a:spcBef>
+            </a:pPr>
+            <a:r>
+              <a:rPr sz="1000" b="0" i="0">
+                <a:solidFill>
+                  <a:srgbClr val="2B2B2B"/>
+                </a:solidFill>
+                <a:latin typeface="Calibri"/>
+              </a:rPr>
+              <a:t>•  Владелец задачи и роли (кто решает, кто платит)</a:t>
+            </a:r>
+          </a:p>
+          <a:p>
+            <a:pPr>
+              <a:spcBef>
+                <a:spcPts val="300"/>
+              </a:spcBef>
+            </a:pPr>
+            <a:r>
+              <a:rPr sz="1000" b="0" i="0">
+                <a:solidFill>
+                  <a:srgbClr val="2B2B2B"/>
+                </a:solidFill>
+                <a:latin typeface="Calibri"/>
+              </a:rPr>
+              <a:t>•  Бизнес-задача в одном предложении: «как есть» → «как надо»</a:t>
+            </a:r>
+          </a:p>
+          <a:p>
+            <a:pPr>
+              <a:spcBef>
+                <a:spcPts val="300"/>
+              </a:spcBef>
+            </a:pPr>
+            <a:r>
+              <a:rPr sz="1000" b="0" i="0">
+                <a:solidFill>
+                  <a:srgbClr val="2B2B2B"/>
+                </a:solidFill>
+                <a:latin typeface="Calibri"/>
+              </a:rPr>
+              <a:t>•  Текущее решение и боль (время / стоимость / качество)</a:t>
+            </a:r>
+          </a:p>
+          <a:p>
+            <a:pPr>
+              <a:spcBef>
+                <a:spcPts val="300"/>
+              </a:spcBef>
+            </a:pPr>
+            <a:r>
+              <a:rPr sz="1000" b="0" i="0">
+                <a:solidFill>
+                  <a:srgbClr val="2B2B2B"/>
+                </a:solidFill>
+                <a:latin typeface="Calibri"/>
+              </a:rPr>
+              <a:t>•  Тип задачи и цель (что значит «лучше»)</a:t>
+            </a:r>
+          </a:p>
+          <a:p>
+            <a:pPr>
+              <a:spcBef>
+                <a:spcPts val="300"/>
+              </a:spcBef>
+            </a:pPr>
+            <a:r>
+              <a:rPr sz="1000" b="0" i="0">
+                <a:solidFill>
+                  <a:srgbClr val="2B2B2B"/>
+                </a:solidFill>
+                <a:latin typeface="Calibri"/>
+              </a:rPr>
+              <a:t>•  Переменные решения (что можно менять)</a:t>
+            </a:r>
+          </a:p>
+          <a:p>
+            <a:pPr>
+              <a:spcBef>
+                <a:spcPts val="300"/>
+              </a:spcBef>
+            </a:pPr>
+            <a:r>
+              <a:rPr sz="1000" b="0" i="0">
+                <a:solidFill>
+                  <a:srgbClr val="2B2B2B"/>
+                </a:solidFill>
+                <a:latin typeface="Calibri"/>
+              </a:rPr>
+              <a:t>•  Ограничения (жёсткие / мягкие)</a:t>
+            </a:r>
+          </a:p>
+          <a:p>
+            <a:pPr>
+              <a:spcBef>
+                <a:spcPts val="300"/>
+              </a:spcBef>
+            </a:pPr>
+            <a:r>
+              <a:rPr sz="1000" b="0" i="0">
+                <a:solidFill>
+                  <a:srgbClr val="2B2B2B"/>
+                </a:solidFill>
+                <a:latin typeface="Calibri"/>
+              </a:rPr>
+              <a:t>•  Масштаб (сколько объектов; рост со временем)</a:t>
+            </a:r>
+          </a:p>
+          <a:p>
+            <a:pPr>
+              <a:spcBef>
+                <a:spcPts val="300"/>
+              </a:spcBef>
+            </a:pPr>
+            <a:r>
+              <a:rPr sz="1000" b="0" i="0">
+                <a:solidFill>
+                  <a:srgbClr val="2B2B2B"/>
+                </a:solidFill>
+                <a:latin typeface="Calibri"/>
+              </a:rPr>
+              <a:t>•  Данные (объём, формат, доступность, чувствительность)</a:t>
+            </a:r>
+          </a:p>
+          <a:p>
+            <a:pPr>
+              <a:spcBef>
+                <a:spcPts val="300"/>
+              </a:spcBef>
+            </a:pPr>
+            <a:r>
+              <a:rPr sz="1000" b="0" i="0">
+                <a:solidFill>
+                  <a:srgbClr val="2B2B2B"/>
+                </a:solidFill>
+                <a:latin typeface="Calibri"/>
+              </a:rPr>
+              <a:t>•  Метрика успеха и базовая линия</a:t>
+            </a:r>
+          </a:p>
+          <a:p>
+            <a:pPr>
+              <a:spcBef>
+                <a:spcPts val="300"/>
+              </a:spcBef>
+            </a:pPr>
+            <a:r>
+              <a:rPr sz="1000" b="0" i="0">
+                <a:solidFill>
+                  <a:srgbClr val="2B2B2B"/>
+                </a:solidFill>
+                <a:latin typeface="Calibri"/>
+              </a:rPr>
+              <a:t>•  Частота и режим (разово / real-time)</a:t>
+            </a:r>
+          </a:p>
+          <a:p>
+            <a:pPr>
+              <a:spcBef>
+                <a:spcPts val="300"/>
+              </a:spcBef>
+            </a:pPr>
+            <a:r>
+              <a:rPr sz="1000" b="0" i="0">
+                <a:solidFill>
+                  <a:srgbClr val="2B2B2B"/>
+                </a:solidFill>
+                <a:latin typeface="Calibri"/>
+              </a:rPr>
+              <a:t>•  Экономика (стоимость, цена ошибки, эффект)</a:t>
+            </a:r>
+          </a:p>
+          <a:p>
+            <a:pPr>
+              <a:spcBef>
+                <a:spcPts val="300"/>
+              </a:spcBef>
+            </a:pPr>
+            <a:r>
+              <a:rPr sz="1000" b="0" i="0">
+                <a:solidFill>
+                  <a:srgbClr val="2B2B2B"/>
+                </a:solidFill>
+                <a:latin typeface="Calibri"/>
+              </a:rPr>
+              <a:t>•  Готовность и ограничения (ИТ, бюджет, комплаенс)</a:t>
+            </a:r>
+          </a:p>
+        </p:txBody>
+      </p:sp>
+      <p:sp>
+        <p:nvSpPr>
+          <p:cNvPr id="7" name="Rounded Rectangle 6"/>
+          <p:cNvSpPr/>
+          <p:nvPr/>
+        </p:nvSpPr>
+        <p:spPr>
+          <a:xfrm>
+            <a:off x="6492240" y="1783080"/>
+            <a:ext cx="5148072" cy="4434840"/>
+          </a:xfrm>
+          <a:prstGeom prst="roundRect">
+            <a:avLst/>
+          </a:prstGeom>
+          <a:solidFill>
+            <a:srgbClr val="ECF1FB"/>
+          </a:solidFill>
+          <a:ln w="12700">
+            <a:solidFill>
+              <a:srgbClr val="D9E1F2"/>
+            </a:solidFill>
+          </a:ln>
+          <a:effectLst/>
+        </p:spPr>
+        <p:style>
+          <a:lnRef idx="1">
+            <a:schemeClr val="accent1"/>
+          </a:lnRef>
+          <a:fillRef idx="3">
+            <a:schemeClr val="accent1"/>
+          </a:fillRef>
+          <a:effectRef idx="2">
+            <a:schemeClr val="accent1"/>
+          </a:effectRef>
+          <a:fontRef idx="minor">
+            <a:schemeClr val="lt1"/>
+          </a:fontRef>
+        </p:style>
+        <p:txBody>
+          <a:bodyPr rtlCol="0" anchor="ctr" wrap="square" lIns="146304" rIns="128016" tIns="109728" bIns="73152"/>
+          <a:lstStyle/>
+          <a:p>
+            <a:pPr algn="ctr"/>
+            <a:r>
+              <a:rPr sz="1300" b="1" i="0">
+                <a:solidFill>
+                  <a:srgbClr val="2D6CDF"/>
+                </a:solidFill>
+                <a:latin typeface="Calibri"/>
+              </a:rPr>
+              <a:t>Кого пригласить и что подготовить</a:t>
+            </a:r>
+          </a:p>
+          <a:p>
+            <a:pPr>
+              <a:spcBef>
+                <a:spcPts val="400"/>
+              </a:spcBef>
+            </a:pPr>
+            <a:r>
+              <a:rPr sz="1030" b="0" i="0">
+                <a:solidFill>
+                  <a:srgbClr val="2B2B2B"/>
+                </a:solidFill>
+                <a:latin typeface="Calibri"/>
+              </a:rPr>
+              <a:t>Бизнес-заказчик — боль, метрика, эффект</a:t>
+            </a:r>
+          </a:p>
+          <a:p>
+            <a:pPr>
+              <a:spcBef>
+                <a:spcPts val="400"/>
+              </a:spcBef>
+            </a:pPr>
+            <a:r>
+              <a:rPr sz="1030" b="0" i="0">
+                <a:solidFill>
+                  <a:srgbClr val="2B2B2B"/>
+                </a:solidFill>
+                <a:latin typeface="Calibri"/>
+              </a:rPr>
+              <a:t>Профильные операции — как устроен процесс, ограничения, объёмы</a:t>
+            </a:r>
+          </a:p>
+          <a:p>
+            <a:pPr>
+              <a:spcBef>
+                <a:spcPts val="400"/>
+              </a:spcBef>
+            </a:pPr>
+            <a:r>
+              <a:rPr sz="1030" b="0" i="0">
+                <a:solidFill>
+                  <a:srgbClr val="2B2B2B"/>
+                </a:solidFill>
+                <a:latin typeface="Calibri"/>
+              </a:rPr>
+              <a:t>Владелец данных — какие данные, объём, качество, доступ</a:t>
+            </a:r>
+          </a:p>
+          <a:p>
+            <a:pPr>
+              <a:spcBef>
+                <a:spcPts val="400"/>
+              </a:spcBef>
+            </a:pPr>
+            <a:r>
+              <a:rPr sz="1030" b="0" i="0">
+                <a:solidFill>
+                  <a:srgbClr val="2B2B2B"/>
+                </a:solidFill>
+                <a:latin typeface="Calibri"/>
+              </a:rPr>
+              <a:t>ИТ / инфраструктура — где данные, интеграции, безопасность</a:t>
+            </a:r>
+          </a:p>
+          <a:p>
+            <a:pPr>
+              <a:spcBef>
+                <a:spcPts val="400"/>
+              </a:spcBef>
+            </a:pPr>
+            <a:r>
+              <a:rPr sz="1030" b="0" i="0">
+                <a:solidFill>
+                  <a:srgbClr val="2B2B2B"/>
+                </a:solidFill>
+                <a:latin typeface="Calibri"/>
+              </a:rPr>
+              <a:t>Финансы — стоимость текущего решения, цена ошибки, ROI</a:t>
+            </a:r>
+          </a:p>
+          <a:p>
+            <a:pPr>
+              <a:spcBef>
+                <a:spcPts val="400"/>
+              </a:spcBef>
+            </a:pPr>
+            <a:r>
+              <a:rPr sz="1030" b="0" i="0">
+                <a:solidFill>
+                  <a:srgbClr val="2B2B2B"/>
+                </a:solidFill>
+                <a:latin typeface="Calibri"/>
+              </a:rPr>
+              <a:t>Комплаенс (опц.) — ограничения на данные</a:t>
+            </a:r>
+          </a:p>
+          <a:p>
+            <a:pPr>
+              <a:spcBef>
+                <a:spcPts val="400"/>
+              </a:spcBef>
+            </a:pPr>
+            <a:r>
+              <a:rPr sz="1030" b="0" i="0">
+                <a:solidFill>
+                  <a:srgbClr val="2B2B2B"/>
+                </a:solidFill>
+                <a:latin typeface="Calibri"/>
+              </a:rPr>
+              <a:t/>
+            </a:r>
+          </a:p>
+          <a:p>
+            <a:pPr>
+              <a:spcBef>
+                <a:spcPts val="400"/>
+              </a:spcBef>
+            </a:pPr>
+            <a:r>
+              <a:rPr sz="1030" b="0" i="0">
+                <a:solidFill>
+                  <a:srgbClr val="2B2B2B"/>
+                </a:solidFill>
+                <a:latin typeface="Calibri"/>
+              </a:rPr>
+              <a:t>Сервис выдаёт этот чек-лист, чтобы клиент пришёл подготовленным и собрал нужные службы.</a:t>
             </a:r>
           </a:p>
         </p:txBody>

</xml_diff>

<commit_message>
Add appendix slide 11: 2x2 scatter matrix of 16 simulated cases
</commit_message>
<xml_diff>
--- a/quantum-service-competitor-analysis/Анализ-конкурентов-Q-Scope.pptx
+++ b/quantum-service-competitor-analysis/Анализ-конкурентов-Q-Scope.pptx
@@ -15,6 +15,7 @@
     <p:sldId id="263" r:id="rId14"/>
     <p:sldId id="264" r:id="rId15"/>
     <p:sldId id="265" r:id="rId16"/>
+    <p:sldId id="266" r:id="rId17"/>
   </p:sldIdLst>
   <p:sldSz cx="12191695" cy="6858000" type="screen4x3"/>
   <p:notesSz cx="6858000" cy="9144000"/>
@@ -3655,7 +3656,7 @@
                 </a:solidFill>
                 <a:latin typeface="Calibri"/>
               </a:rPr>
-              <a:t>10 / 10</a:t>
+              <a:t>10 / 11</a:t>
             </a:r>
           </a:p>
         </p:txBody>
@@ -4342,6 +4343,1839 @@
                 <a:latin typeface="Calibri"/>
               </a:rPr>
               <a:t>Кого позвать + кнопка «передать экспертам» → авто-бриф (PDF)</a:t>
+            </a:r>
+          </a:p>
+        </p:txBody>
+      </p:sp>
+    </p:spTree>
+  </p:cSld>
+  <p:clrMapOvr>
+    <a:masterClrMapping/>
+  </p:clrMapOvr>
+</p:sld>
+</file>
+
+<file path=ppt/slides/slide11.xml><?xml version="1.0" encoding="utf-8"?>
+<p:sld xmlns:a="http://schemas.openxmlformats.org/drawingml/2006/main" xmlns:p="http://schemas.openxmlformats.org/presentationml/2006/main" xmlns:r="http://schemas.openxmlformats.org/officeDocument/2006/relationships">
+  <p:cSld>
+    <p:bg>
+      <p:bgPr>
+        <a:solidFill>
+          <a:srgbClr val="FFFFFF"/>
+        </a:solidFill>
+        <a:effectLst/>
+      </p:bgPr>
+    </p:bg>
+    <p:spTree>
+      <p:nvGrpSpPr>
+        <p:cNvPr id="1" name=""/>
+        <p:cNvGrpSpPr/>
+        <p:nvPr/>
+      </p:nvGrpSpPr>
+      <p:grpSpPr/>
+      <p:sp>
+        <p:nvSpPr>
+          <p:cNvPr id="2" name="Rectangle 1"/>
+          <p:cNvSpPr/>
+          <p:nvPr/>
+        </p:nvSpPr>
+        <p:spPr>
+          <a:xfrm>
+            <a:off x="548640" y="502920"/>
+            <a:ext cx="109728" cy="868680"/>
+          </a:xfrm>
+          <a:prstGeom prst="rect">
+            <a:avLst/>
+          </a:prstGeom>
+          <a:solidFill>
+            <a:srgbClr val="2D6CDF"/>
+          </a:solidFill>
+          <a:ln>
+            <a:noFill/>
+          </a:ln>
+          <a:effectLst/>
+        </p:spPr>
+        <p:style>
+          <a:lnRef idx="1">
+            <a:schemeClr val="accent1"/>
+          </a:lnRef>
+          <a:fillRef idx="3">
+            <a:schemeClr val="accent1"/>
+          </a:fillRef>
+          <a:effectRef idx="2">
+            <a:schemeClr val="accent1"/>
+          </a:effectRef>
+          <a:fontRef idx="minor">
+            <a:schemeClr val="lt1"/>
+          </a:fontRef>
+        </p:style>
+        <p:txBody>
+          <a:bodyPr rtlCol="0" anchor="ctr"/>
+          <a:lstStyle/>
+          <a:p>
+            <a:pPr algn="ctr"/>
+          </a:p>
+        </p:txBody>
+      </p:sp>
+      <p:sp>
+        <p:nvSpPr>
+          <p:cNvPr id="3" name="TextBox 2"/>
+          <p:cNvSpPr txBox="1"/>
+          <p:nvPr/>
+        </p:nvSpPr>
+        <p:spPr>
+          <a:xfrm>
+            <a:off x="841248" y="457200"/>
+            <a:ext cx="10424160" cy="1005840"/>
+          </a:xfrm>
+          <a:prstGeom prst="rect">
+            <a:avLst/>
+          </a:prstGeom>
+          <a:noFill/>
+        </p:spPr>
+        <p:txBody>
+          <a:bodyPr wrap="square" anchor="t" lIns="0" rIns="0" tIns="0" bIns="0">
+            <a:spAutoFit/>
+          </a:bodyPr>
+          <a:lstStyle/>
+          <a:p>
+            <a:r>
+              <a:rPr sz="1200" b="1" i="0">
+                <a:solidFill>
+                  <a:srgbClr val="2D6CDF"/>
+                </a:solidFill>
+                <a:latin typeface="Calibri"/>
+              </a:rPr>
+              <a:t>ПРИЛОЖЕНИЕ · МАТРИЦА</a:t>
+            </a:r>
+          </a:p>
+          <a:p>
+            <a:pPr>
+              <a:spcBef>
+                <a:spcPts val="200"/>
+              </a:spcBef>
+            </a:pPr>
+            <a:r>
+              <a:rPr sz="2600" b="1" i="0">
+                <a:solidFill>
+                  <a:srgbClr val="1A3E8C"/>
+                </a:solidFill>
+                <a:latin typeface="Calibri"/>
+              </a:rPr>
+              <a:t>Карта 16 кейсов: квантовый потенциал × бизнес-ценность</a:t>
+            </a:r>
+          </a:p>
+        </p:txBody>
+      </p:sp>
+      <p:sp>
+        <p:nvSpPr>
+          <p:cNvPr id="4" name="Rectangle 3"/>
+          <p:cNvSpPr/>
+          <p:nvPr/>
+        </p:nvSpPr>
+        <p:spPr>
+          <a:xfrm>
+            <a:off x="548640" y="1481328"/>
+            <a:ext cx="11091672" cy="17780"/>
+          </a:xfrm>
+          <a:prstGeom prst="rect">
+            <a:avLst/>
+          </a:prstGeom>
+          <a:solidFill>
+            <a:srgbClr val="D9E1F2"/>
+          </a:solidFill>
+          <a:ln>
+            <a:noFill/>
+          </a:ln>
+          <a:effectLst/>
+        </p:spPr>
+        <p:style>
+          <a:lnRef idx="1">
+            <a:schemeClr val="accent1"/>
+          </a:lnRef>
+          <a:fillRef idx="3">
+            <a:schemeClr val="accent1"/>
+          </a:fillRef>
+          <a:effectRef idx="2">
+            <a:schemeClr val="accent1"/>
+          </a:effectRef>
+          <a:fontRef idx="minor">
+            <a:schemeClr val="lt1"/>
+          </a:fontRef>
+        </p:style>
+        <p:txBody>
+          <a:bodyPr rtlCol="0" anchor="ctr"/>
+          <a:lstStyle/>
+          <a:p>
+            <a:pPr algn="ctr"/>
+          </a:p>
+        </p:txBody>
+      </p:sp>
+      <p:sp>
+        <p:nvSpPr>
+          <p:cNvPr id="5" name="TextBox 4"/>
+          <p:cNvSpPr txBox="1"/>
+          <p:nvPr/>
+        </p:nvSpPr>
+        <p:spPr>
+          <a:xfrm>
+            <a:off x="11338560" y="6355080"/>
+            <a:ext cx="548640" cy="365760"/>
+          </a:xfrm>
+          <a:prstGeom prst="rect">
+            <a:avLst/>
+          </a:prstGeom>
+          <a:noFill/>
+        </p:spPr>
+        <p:txBody>
+          <a:bodyPr wrap="square" anchor="t" lIns="0" rIns="0" tIns="0" bIns="0">
+            <a:spAutoFit/>
+          </a:bodyPr>
+          <a:lstStyle/>
+          <a:p>
+            <a:pPr algn="r"/>
+            <a:r>
+              <a:rPr sz="1000" b="0" i="0">
+                <a:solidFill>
+                  <a:srgbClr val="666666"/>
+                </a:solidFill>
+                <a:latin typeface="Calibri"/>
+              </a:rPr>
+              <a:t>11 / 11</a:t>
+            </a:r>
+          </a:p>
+        </p:txBody>
+      </p:sp>
+      <p:sp>
+        <p:nvSpPr>
+          <p:cNvPr id="6" name="Rounded Rectangle 5"/>
+          <p:cNvSpPr/>
+          <p:nvPr/>
+        </p:nvSpPr>
+        <p:spPr>
+          <a:xfrm>
+            <a:off x="1280160" y="1828800"/>
+            <a:ext cx="3657600" cy="2057400"/>
+          </a:xfrm>
+          <a:prstGeom prst="roundRect">
+            <a:avLst/>
+          </a:prstGeom>
+          <a:solidFill>
+            <a:srgbClr val="ECF1FB"/>
+          </a:solidFill>
+          <a:ln w="19050">
+            <a:solidFill>
+              <a:srgbClr val="FFFFFF"/>
+            </a:solidFill>
+          </a:ln>
+          <a:effectLst/>
+        </p:spPr>
+        <p:style>
+          <a:lnRef idx="1">
+            <a:schemeClr val="accent1"/>
+          </a:lnRef>
+          <a:fillRef idx="3">
+            <a:schemeClr val="accent1"/>
+          </a:fillRef>
+          <a:effectRef idx="2">
+            <a:schemeClr val="accent1"/>
+          </a:effectRef>
+          <a:fontRef idx="minor">
+            <a:schemeClr val="lt1"/>
+          </a:fontRef>
+        </p:style>
+        <p:txBody>
+          <a:bodyPr rtlCol="0" anchor="t" wrap="square" tIns="54864"/>
+          <a:lstStyle/>
+          <a:p>
+            <a:pPr algn="l"/>
+            <a:r>
+              <a:rPr sz="1200" b="1" i="0">
+                <a:solidFill>
+                  <a:srgbClr val="6E8AC0"/>
+                </a:solidFill>
+                <a:latin typeface="Calibri"/>
+              </a:rPr>
+              <a:t>Watchlist</a:t>
+            </a:r>
+          </a:p>
+        </p:txBody>
+      </p:sp>
+      <p:sp>
+        <p:nvSpPr>
+          <p:cNvPr id="7" name="Rounded Rectangle 6"/>
+          <p:cNvSpPr/>
+          <p:nvPr/>
+        </p:nvSpPr>
+        <p:spPr>
+          <a:xfrm>
+            <a:off x="4937760" y="1828800"/>
+            <a:ext cx="3657600" cy="2057400"/>
+          </a:xfrm>
+          <a:prstGeom prst="roundRect">
+            <a:avLst/>
+          </a:prstGeom>
+          <a:solidFill>
+            <a:srgbClr val="E3F3EA"/>
+          </a:solidFill>
+          <a:ln w="19050">
+            <a:solidFill>
+              <a:srgbClr val="FFFFFF"/>
+            </a:solidFill>
+          </a:ln>
+          <a:effectLst/>
+        </p:spPr>
+        <p:style>
+          <a:lnRef idx="1">
+            <a:schemeClr val="accent1"/>
+          </a:lnRef>
+          <a:fillRef idx="3">
+            <a:schemeClr val="accent1"/>
+          </a:fillRef>
+          <a:effectRef idx="2">
+            <a:schemeClr val="accent1"/>
+          </a:effectRef>
+          <a:fontRef idx="minor">
+            <a:schemeClr val="lt1"/>
+          </a:fontRef>
+        </p:style>
+        <p:txBody>
+          <a:bodyPr rtlCol="0" anchor="t" wrap="square" tIns="54864"/>
+          <a:lstStyle/>
+          <a:p>
+            <a:pPr algn="r"/>
+            <a:r>
+              <a:rPr sz="1200" b="1" i="0">
+                <a:solidFill>
+                  <a:srgbClr val="4F9E73"/>
+                </a:solidFill>
+                <a:latin typeface="Calibri"/>
+              </a:rPr>
+              <a:t>PoC сейчас</a:t>
+            </a:r>
+          </a:p>
+        </p:txBody>
+      </p:sp>
+      <p:sp>
+        <p:nvSpPr>
+          <p:cNvPr id="8" name="Rounded Rectangle 7"/>
+          <p:cNvSpPr/>
+          <p:nvPr/>
+        </p:nvSpPr>
+        <p:spPr>
+          <a:xfrm>
+            <a:off x="1280160" y="3886200"/>
+            <a:ext cx="3657600" cy="2057400"/>
+          </a:xfrm>
+          <a:prstGeom prst="roundRect">
+            <a:avLst/>
+          </a:prstGeom>
+          <a:solidFill>
+            <a:srgbClr val="EEEFF2"/>
+          </a:solidFill>
+          <a:ln w="19050">
+            <a:solidFill>
+              <a:srgbClr val="FFFFFF"/>
+            </a:solidFill>
+          </a:ln>
+          <a:effectLst/>
+        </p:spPr>
+        <p:style>
+          <a:lnRef idx="1">
+            <a:schemeClr val="accent1"/>
+          </a:lnRef>
+          <a:fillRef idx="3">
+            <a:schemeClr val="accent1"/>
+          </a:fillRef>
+          <a:effectRef idx="2">
+            <a:schemeClr val="accent1"/>
+          </a:effectRef>
+          <a:fontRef idx="minor">
+            <a:schemeClr val="lt1"/>
+          </a:fontRef>
+        </p:style>
+        <p:txBody>
+          <a:bodyPr rtlCol="0" anchor="t" wrap="square" tIns="54864"/>
+          <a:lstStyle/>
+          <a:p>
+            <a:pPr algn="l"/>
+            <a:r>
+              <a:rPr sz="1200" b="1" i="0">
+                <a:solidFill>
+                  <a:srgbClr val="A0A6B0"/>
+                </a:solidFill>
+                <a:latin typeface="Calibri"/>
+              </a:rPr>
+              <a:t>Отбросить</a:t>
+            </a:r>
+          </a:p>
+        </p:txBody>
+      </p:sp>
+      <p:sp>
+        <p:nvSpPr>
+          <p:cNvPr id="9" name="Rounded Rectangle 8"/>
+          <p:cNvSpPr/>
+          <p:nvPr/>
+        </p:nvSpPr>
+        <p:spPr>
+          <a:xfrm>
+            <a:off x="4937760" y="3886200"/>
+            <a:ext cx="3657600" cy="2057400"/>
+          </a:xfrm>
+          <a:prstGeom prst="roundRect">
+            <a:avLst/>
+          </a:prstGeom>
+          <a:solidFill>
+            <a:srgbClr val="F3F7FC"/>
+          </a:solidFill>
+          <a:ln w="19050">
+            <a:solidFill>
+              <a:srgbClr val="FFFFFF"/>
+            </a:solidFill>
+          </a:ln>
+          <a:effectLst/>
+        </p:spPr>
+        <p:style>
+          <a:lnRef idx="1">
+            <a:schemeClr val="accent1"/>
+          </a:lnRef>
+          <a:fillRef idx="3">
+            <a:schemeClr val="accent1"/>
+          </a:fillRef>
+          <a:effectRef idx="2">
+            <a:schemeClr val="accent1"/>
+          </a:effectRef>
+          <a:fontRef idx="minor">
+            <a:schemeClr val="lt1"/>
+          </a:fontRef>
+        </p:style>
+        <p:txBody>
+          <a:bodyPr rtlCol="0" anchor="t" wrap="square" tIns="54864"/>
+          <a:lstStyle/>
+          <a:p>
+            <a:pPr algn="r"/>
+            <a:r>
+              <a:rPr sz="1200" b="1" i="0">
+                <a:solidFill>
+                  <a:srgbClr val="7E90AE"/>
+                </a:solidFill>
+                <a:latin typeface="Calibri"/>
+              </a:rPr>
+              <a:t>Классический солвер</a:t>
+            </a:r>
+          </a:p>
+        </p:txBody>
+      </p:sp>
+      <p:sp>
+        <p:nvSpPr>
+          <p:cNvPr id="10" name="Oval 9"/>
+          <p:cNvSpPr/>
+          <p:nvPr/>
+        </p:nvSpPr>
+        <p:spPr>
+          <a:xfrm>
+            <a:off x="7891271" y="1956815"/>
+            <a:ext cx="292608" cy="292608"/>
+          </a:xfrm>
+          <a:prstGeom prst="ellipse">
+            <a:avLst/>
+          </a:prstGeom>
+          <a:solidFill>
+            <a:srgbClr val="2D6CDF"/>
+          </a:solidFill>
+          <a:ln w="15240">
+            <a:solidFill>
+              <a:srgbClr val="FFFFFF"/>
+            </a:solidFill>
+          </a:ln>
+          <a:effectLst/>
+        </p:spPr>
+        <p:style>
+          <a:lnRef idx="1">
+            <a:schemeClr val="accent1"/>
+          </a:lnRef>
+          <a:fillRef idx="3">
+            <a:schemeClr val="accent1"/>
+          </a:fillRef>
+          <a:effectRef idx="2">
+            <a:schemeClr val="accent1"/>
+          </a:effectRef>
+          <a:fontRef idx="minor">
+            <a:schemeClr val="lt1"/>
+          </a:fontRef>
+        </p:style>
+        <p:txBody>
+          <a:bodyPr rtlCol="0" anchor="ctr" wrap="none" lIns="0" rIns="0" tIns="0" bIns="0"/>
+          <a:lstStyle/>
+          <a:p>
+            <a:pPr algn="ctr"/>
+            <a:r>
+              <a:rPr sz="750" b="1" i="0">
+                <a:solidFill>
+                  <a:srgbClr val="FFFFFF"/>
+                </a:solidFill>
+                <a:latin typeface="Calibri"/>
+              </a:rPr>
+              <a:t>L1</a:t>
+            </a:r>
+          </a:p>
+        </p:txBody>
+      </p:sp>
+      <p:sp>
+        <p:nvSpPr>
+          <p:cNvPr id="11" name="Oval 10"/>
+          <p:cNvSpPr/>
+          <p:nvPr/>
+        </p:nvSpPr>
+        <p:spPr>
+          <a:xfrm>
+            <a:off x="8275320" y="1956815"/>
+            <a:ext cx="292608" cy="292608"/>
+          </a:xfrm>
+          <a:prstGeom prst="ellipse">
+            <a:avLst/>
+          </a:prstGeom>
+          <a:solidFill>
+            <a:srgbClr val="1E8E5A"/>
+          </a:solidFill>
+          <a:ln w="15240">
+            <a:solidFill>
+              <a:srgbClr val="FFFFFF"/>
+            </a:solidFill>
+          </a:ln>
+          <a:effectLst/>
+        </p:spPr>
+        <p:style>
+          <a:lnRef idx="1">
+            <a:schemeClr val="accent1"/>
+          </a:lnRef>
+          <a:fillRef idx="3">
+            <a:schemeClr val="accent1"/>
+          </a:fillRef>
+          <a:effectRef idx="2">
+            <a:schemeClr val="accent1"/>
+          </a:effectRef>
+          <a:fontRef idx="minor">
+            <a:schemeClr val="lt1"/>
+          </a:fontRef>
+        </p:style>
+        <p:txBody>
+          <a:bodyPr rtlCol="0" anchor="ctr" wrap="none" lIns="0" rIns="0" tIns="0" bIns="0"/>
+          <a:lstStyle/>
+          <a:p>
+            <a:pPr algn="ctr"/>
+            <a:r>
+              <a:rPr sz="750" b="1" i="0">
+                <a:solidFill>
+                  <a:srgbClr val="FFFFFF"/>
+                </a:solidFill>
+                <a:latin typeface="Calibri"/>
+              </a:rPr>
+              <a:t>P1</a:t>
+            </a:r>
+          </a:p>
+        </p:txBody>
+      </p:sp>
+      <p:sp>
+        <p:nvSpPr>
+          <p:cNvPr id="12" name="Oval 11"/>
+          <p:cNvSpPr/>
+          <p:nvPr/>
+        </p:nvSpPr>
+        <p:spPr>
+          <a:xfrm>
+            <a:off x="3931920" y="2551175"/>
+            <a:ext cx="292608" cy="292608"/>
+          </a:xfrm>
+          <a:prstGeom prst="ellipse">
+            <a:avLst/>
+          </a:prstGeom>
+          <a:solidFill>
+            <a:srgbClr val="2D6CDF"/>
+          </a:solidFill>
+          <a:ln w="15240">
+            <a:solidFill>
+              <a:srgbClr val="FFFFFF"/>
+            </a:solidFill>
+          </a:ln>
+          <a:effectLst/>
+        </p:spPr>
+        <p:style>
+          <a:lnRef idx="1">
+            <a:schemeClr val="accent1"/>
+          </a:lnRef>
+          <a:fillRef idx="3">
+            <a:schemeClr val="accent1"/>
+          </a:fillRef>
+          <a:effectRef idx="2">
+            <a:schemeClr val="accent1"/>
+          </a:effectRef>
+          <a:fontRef idx="minor">
+            <a:schemeClr val="lt1"/>
+          </a:fontRef>
+        </p:style>
+        <p:txBody>
+          <a:bodyPr rtlCol="0" anchor="ctr" wrap="none" lIns="0" rIns="0" tIns="0" bIns="0"/>
+          <a:lstStyle/>
+          <a:p>
+            <a:pPr algn="ctr"/>
+            <a:r>
+              <a:rPr sz="750" b="1" i="0">
+                <a:solidFill>
+                  <a:srgbClr val="FFFFFF"/>
+                </a:solidFill>
+                <a:latin typeface="Calibri"/>
+              </a:rPr>
+              <a:t>L2</a:t>
+            </a:r>
+          </a:p>
+        </p:txBody>
+      </p:sp>
+      <p:sp>
+        <p:nvSpPr>
+          <p:cNvPr id="13" name="Oval 12"/>
+          <p:cNvSpPr/>
+          <p:nvPr/>
+        </p:nvSpPr>
+        <p:spPr>
+          <a:xfrm>
+            <a:off x="4334255" y="2551175"/>
+            <a:ext cx="292608" cy="292608"/>
+          </a:xfrm>
+          <a:prstGeom prst="ellipse">
+            <a:avLst/>
+          </a:prstGeom>
+          <a:solidFill>
+            <a:srgbClr val="1E8E5A"/>
+          </a:solidFill>
+          <a:ln w="15240">
+            <a:solidFill>
+              <a:srgbClr val="FFFFFF"/>
+            </a:solidFill>
+          </a:ln>
+          <a:effectLst/>
+        </p:spPr>
+        <p:style>
+          <a:lnRef idx="1">
+            <a:schemeClr val="accent1"/>
+          </a:lnRef>
+          <a:fillRef idx="3">
+            <a:schemeClr val="accent1"/>
+          </a:fillRef>
+          <a:effectRef idx="2">
+            <a:schemeClr val="accent1"/>
+          </a:effectRef>
+          <a:fontRef idx="minor">
+            <a:schemeClr val="lt1"/>
+          </a:fontRef>
+        </p:style>
+        <p:txBody>
+          <a:bodyPr rtlCol="0" anchor="ctr" wrap="none" lIns="0" rIns="0" tIns="0" bIns="0"/>
+          <a:lstStyle/>
+          <a:p>
+            <a:pPr algn="ctr"/>
+            <a:r>
+              <a:rPr sz="750" b="1" i="0">
+                <a:solidFill>
+                  <a:srgbClr val="FFFFFF"/>
+                </a:solidFill>
+                <a:latin typeface="Calibri"/>
+              </a:rPr>
+              <a:t>P2</a:t>
+            </a:r>
+          </a:p>
+        </p:txBody>
+      </p:sp>
+      <p:sp>
+        <p:nvSpPr>
+          <p:cNvPr id="14" name="Oval 13"/>
+          <p:cNvSpPr/>
+          <p:nvPr/>
+        </p:nvSpPr>
+        <p:spPr>
+          <a:xfrm>
+            <a:off x="4133087" y="2871215"/>
+            <a:ext cx="292608" cy="292608"/>
+          </a:xfrm>
+          <a:prstGeom prst="ellipse">
+            <a:avLst/>
+          </a:prstGeom>
+          <a:solidFill>
+            <a:srgbClr val="E08A1E"/>
+          </a:solidFill>
+          <a:ln w="15240">
+            <a:solidFill>
+              <a:srgbClr val="FFFFFF"/>
+            </a:solidFill>
+          </a:ln>
+          <a:effectLst/>
+        </p:spPr>
+        <p:style>
+          <a:lnRef idx="1">
+            <a:schemeClr val="accent1"/>
+          </a:lnRef>
+          <a:fillRef idx="3">
+            <a:schemeClr val="accent1"/>
+          </a:fillRef>
+          <a:effectRef idx="2">
+            <a:schemeClr val="accent1"/>
+          </a:effectRef>
+          <a:fontRef idx="minor">
+            <a:schemeClr val="lt1"/>
+          </a:fontRef>
+        </p:style>
+        <p:txBody>
+          <a:bodyPr rtlCol="0" anchor="ctr" wrap="none" lIns="0" rIns="0" tIns="0" bIns="0"/>
+          <a:lstStyle/>
+          <a:p>
+            <a:pPr algn="ctr"/>
+            <a:r>
+              <a:rPr sz="750" b="1" i="0">
+                <a:solidFill>
+                  <a:srgbClr val="FFFFFF"/>
+                </a:solidFill>
+                <a:latin typeface="Calibri"/>
+              </a:rPr>
+              <a:t>F2</a:t>
+            </a:r>
+          </a:p>
+        </p:txBody>
+      </p:sp>
+      <p:sp>
+        <p:nvSpPr>
+          <p:cNvPr id="15" name="Oval 14"/>
+          <p:cNvSpPr/>
+          <p:nvPr/>
+        </p:nvSpPr>
+        <p:spPr>
+          <a:xfrm>
+            <a:off x="6574536" y="4617719"/>
+            <a:ext cx="292608" cy="292608"/>
+          </a:xfrm>
+          <a:prstGeom prst="ellipse">
+            <a:avLst/>
+          </a:prstGeom>
+          <a:solidFill>
+            <a:srgbClr val="2D6CDF"/>
+          </a:solidFill>
+          <a:ln w="15240">
+            <a:solidFill>
+              <a:srgbClr val="FFFFFF"/>
+            </a:solidFill>
+          </a:ln>
+          <a:effectLst/>
+        </p:spPr>
+        <p:style>
+          <a:lnRef idx="1">
+            <a:schemeClr val="accent1"/>
+          </a:lnRef>
+          <a:fillRef idx="3">
+            <a:schemeClr val="accent1"/>
+          </a:fillRef>
+          <a:effectRef idx="2">
+            <a:schemeClr val="accent1"/>
+          </a:effectRef>
+          <a:fontRef idx="minor">
+            <a:schemeClr val="lt1"/>
+          </a:fontRef>
+        </p:style>
+        <p:txBody>
+          <a:bodyPr rtlCol="0" anchor="ctr" wrap="none" lIns="0" rIns="0" tIns="0" bIns="0"/>
+          <a:lstStyle/>
+          <a:p>
+            <a:pPr algn="ctr"/>
+            <a:r>
+              <a:rPr sz="750" b="1" i="0">
+                <a:solidFill>
+                  <a:srgbClr val="FFFFFF"/>
+                </a:solidFill>
+                <a:latin typeface="Calibri"/>
+              </a:rPr>
+              <a:t>L3</a:t>
+            </a:r>
+          </a:p>
+        </p:txBody>
+      </p:sp>
+      <p:sp>
+        <p:nvSpPr>
+          <p:cNvPr id="16" name="Oval 15"/>
+          <p:cNvSpPr/>
+          <p:nvPr/>
+        </p:nvSpPr>
+        <p:spPr>
+          <a:xfrm>
+            <a:off x="6958584" y="4617719"/>
+            <a:ext cx="292608" cy="292608"/>
+          </a:xfrm>
+          <a:prstGeom prst="ellipse">
+            <a:avLst/>
+          </a:prstGeom>
+          <a:solidFill>
+            <a:srgbClr val="1E8E5A"/>
+          </a:solidFill>
+          <a:ln w="15240">
+            <a:solidFill>
+              <a:srgbClr val="FFFFFF"/>
+            </a:solidFill>
+          </a:ln>
+          <a:effectLst/>
+        </p:spPr>
+        <p:style>
+          <a:lnRef idx="1">
+            <a:schemeClr val="accent1"/>
+          </a:lnRef>
+          <a:fillRef idx="3">
+            <a:schemeClr val="accent1"/>
+          </a:fillRef>
+          <a:effectRef idx="2">
+            <a:schemeClr val="accent1"/>
+          </a:effectRef>
+          <a:fontRef idx="minor">
+            <a:schemeClr val="lt1"/>
+          </a:fontRef>
+        </p:style>
+        <p:txBody>
+          <a:bodyPr rtlCol="0" anchor="ctr" wrap="none" lIns="0" rIns="0" tIns="0" bIns="0"/>
+          <a:lstStyle/>
+          <a:p>
+            <a:pPr algn="ctr"/>
+            <a:r>
+              <a:rPr sz="750" b="1" i="0">
+                <a:solidFill>
+                  <a:srgbClr val="FFFFFF"/>
+                </a:solidFill>
+                <a:latin typeface="Calibri"/>
+              </a:rPr>
+              <a:t>P3</a:t>
+            </a:r>
+          </a:p>
+        </p:txBody>
+      </p:sp>
+      <p:sp>
+        <p:nvSpPr>
+          <p:cNvPr id="17" name="Oval 16"/>
+          <p:cNvSpPr/>
+          <p:nvPr/>
+        </p:nvSpPr>
+        <p:spPr>
+          <a:xfrm>
+            <a:off x="6574536" y="5001767"/>
+            <a:ext cx="292608" cy="292608"/>
+          </a:xfrm>
+          <a:prstGeom prst="ellipse">
+            <a:avLst/>
+          </a:prstGeom>
+          <a:solidFill>
+            <a:srgbClr val="7A4FC0"/>
+          </a:solidFill>
+          <a:ln w="15240">
+            <a:solidFill>
+              <a:srgbClr val="FFFFFF"/>
+            </a:solidFill>
+          </a:ln>
+          <a:effectLst/>
+        </p:spPr>
+        <p:style>
+          <a:lnRef idx="1">
+            <a:schemeClr val="accent1"/>
+          </a:lnRef>
+          <a:fillRef idx="3">
+            <a:schemeClr val="accent1"/>
+          </a:fillRef>
+          <a:effectRef idx="2">
+            <a:schemeClr val="accent1"/>
+          </a:effectRef>
+          <a:fontRef idx="minor">
+            <a:schemeClr val="lt1"/>
+          </a:fontRef>
+        </p:style>
+        <p:txBody>
+          <a:bodyPr rtlCol="0" anchor="ctr" wrap="none" lIns="0" rIns="0" tIns="0" bIns="0"/>
+          <a:lstStyle/>
+          <a:p>
+            <a:pPr algn="ctr"/>
+            <a:r>
+              <a:rPr sz="750" b="1" i="0">
+                <a:solidFill>
+                  <a:srgbClr val="FFFFFF"/>
+                </a:solidFill>
+                <a:latin typeface="Calibri"/>
+              </a:rPr>
+              <a:t>C3</a:t>
+            </a:r>
+          </a:p>
+        </p:txBody>
+      </p:sp>
+      <p:sp>
+        <p:nvSpPr>
+          <p:cNvPr id="18" name="Oval 17"/>
+          <p:cNvSpPr/>
+          <p:nvPr/>
+        </p:nvSpPr>
+        <p:spPr>
+          <a:xfrm>
+            <a:off x="6958584" y="5001767"/>
+            <a:ext cx="292608" cy="292608"/>
+          </a:xfrm>
+          <a:prstGeom prst="ellipse">
+            <a:avLst/>
+          </a:prstGeom>
+          <a:solidFill>
+            <a:srgbClr val="E08A1E"/>
+          </a:solidFill>
+          <a:ln w="15240">
+            <a:solidFill>
+              <a:srgbClr val="FFFFFF"/>
+            </a:solidFill>
+          </a:ln>
+          <a:effectLst/>
+        </p:spPr>
+        <p:style>
+          <a:lnRef idx="1">
+            <a:schemeClr val="accent1"/>
+          </a:lnRef>
+          <a:fillRef idx="3">
+            <a:schemeClr val="accent1"/>
+          </a:fillRef>
+          <a:effectRef idx="2">
+            <a:schemeClr val="accent1"/>
+          </a:effectRef>
+          <a:fontRef idx="minor">
+            <a:schemeClr val="lt1"/>
+          </a:fontRef>
+        </p:style>
+        <p:txBody>
+          <a:bodyPr rtlCol="0" anchor="ctr" wrap="none" lIns="0" rIns="0" tIns="0" bIns="0"/>
+          <a:lstStyle/>
+          <a:p>
+            <a:pPr algn="ctr"/>
+            <a:r>
+              <a:rPr sz="750" b="1" i="0">
+                <a:solidFill>
+                  <a:srgbClr val="FFFFFF"/>
+                </a:solidFill>
+                <a:latin typeface="Calibri"/>
+              </a:rPr>
+              <a:t>F3</a:t>
+            </a:r>
+          </a:p>
+        </p:txBody>
+      </p:sp>
+      <p:sp>
+        <p:nvSpPr>
+          <p:cNvPr id="19" name="Oval 18"/>
+          <p:cNvSpPr/>
+          <p:nvPr/>
+        </p:nvSpPr>
+        <p:spPr>
+          <a:xfrm>
+            <a:off x="2624328" y="4617719"/>
+            <a:ext cx="292608" cy="292608"/>
+          </a:xfrm>
+          <a:prstGeom prst="ellipse">
+            <a:avLst/>
+          </a:prstGeom>
+          <a:solidFill>
+            <a:srgbClr val="2D6CDF"/>
+          </a:solidFill>
+          <a:ln w="15240">
+            <a:solidFill>
+              <a:srgbClr val="FFFFFF"/>
+            </a:solidFill>
+          </a:ln>
+          <a:effectLst/>
+        </p:spPr>
+        <p:style>
+          <a:lnRef idx="1">
+            <a:schemeClr val="accent1"/>
+          </a:lnRef>
+          <a:fillRef idx="3">
+            <a:schemeClr val="accent1"/>
+          </a:fillRef>
+          <a:effectRef idx="2">
+            <a:schemeClr val="accent1"/>
+          </a:effectRef>
+          <a:fontRef idx="minor">
+            <a:schemeClr val="lt1"/>
+          </a:fontRef>
+        </p:style>
+        <p:txBody>
+          <a:bodyPr rtlCol="0" anchor="ctr" wrap="none" lIns="0" rIns="0" tIns="0" bIns="0"/>
+          <a:lstStyle/>
+          <a:p>
+            <a:pPr algn="ctr"/>
+            <a:r>
+              <a:rPr sz="750" b="1" i="0">
+                <a:solidFill>
+                  <a:srgbClr val="FFFFFF"/>
+                </a:solidFill>
+                <a:latin typeface="Calibri"/>
+              </a:rPr>
+              <a:t>L4</a:t>
+            </a:r>
+          </a:p>
+        </p:txBody>
+      </p:sp>
+      <p:sp>
+        <p:nvSpPr>
+          <p:cNvPr id="20" name="Oval 19"/>
+          <p:cNvSpPr/>
+          <p:nvPr/>
+        </p:nvSpPr>
+        <p:spPr>
+          <a:xfrm>
+            <a:off x="3008376" y="4617719"/>
+            <a:ext cx="292608" cy="292608"/>
+          </a:xfrm>
+          <a:prstGeom prst="ellipse">
+            <a:avLst/>
+          </a:prstGeom>
+          <a:solidFill>
+            <a:srgbClr val="1E8E5A"/>
+          </a:solidFill>
+          <a:ln w="15240">
+            <a:solidFill>
+              <a:srgbClr val="FFFFFF"/>
+            </a:solidFill>
+          </a:ln>
+          <a:effectLst/>
+        </p:spPr>
+        <p:style>
+          <a:lnRef idx="1">
+            <a:schemeClr val="accent1"/>
+          </a:lnRef>
+          <a:fillRef idx="3">
+            <a:schemeClr val="accent1"/>
+          </a:fillRef>
+          <a:effectRef idx="2">
+            <a:schemeClr val="accent1"/>
+          </a:effectRef>
+          <a:fontRef idx="minor">
+            <a:schemeClr val="lt1"/>
+          </a:fontRef>
+        </p:style>
+        <p:txBody>
+          <a:bodyPr rtlCol="0" anchor="ctr" wrap="none" lIns="0" rIns="0" tIns="0" bIns="0"/>
+          <a:lstStyle/>
+          <a:p>
+            <a:pPr algn="ctr"/>
+            <a:r>
+              <a:rPr sz="750" b="1" i="0">
+                <a:solidFill>
+                  <a:srgbClr val="FFFFFF"/>
+                </a:solidFill>
+                <a:latin typeface="Calibri"/>
+              </a:rPr>
+              <a:t>P4</a:t>
+            </a:r>
+          </a:p>
+        </p:txBody>
+      </p:sp>
+      <p:sp>
+        <p:nvSpPr>
+          <p:cNvPr id="21" name="Oval 20"/>
+          <p:cNvSpPr/>
+          <p:nvPr/>
+        </p:nvSpPr>
+        <p:spPr>
+          <a:xfrm>
+            <a:off x="2624328" y="5001767"/>
+            <a:ext cx="292608" cy="292608"/>
+          </a:xfrm>
+          <a:prstGeom prst="ellipse">
+            <a:avLst/>
+          </a:prstGeom>
+          <a:solidFill>
+            <a:srgbClr val="7A4FC0"/>
+          </a:solidFill>
+          <a:ln w="15240">
+            <a:solidFill>
+              <a:srgbClr val="FFFFFF"/>
+            </a:solidFill>
+          </a:ln>
+          <a:effectLst/>
+        </p:spPr>
+        <p:style>
+          <a:lnRef idx="1">
+            <a:schemeClr val="accent1"/>
+          </a:lnRef>
+          <a:fillRef idx="3">
+            <a:schemeClr val="accent1"/>
+          </a:fillRef>
+          <a:effectRef idx="2">
+            <a:schemeClr val="accent1"/>
+          </a:effectRef>
+          <a:fontRef idx="minor">
+            <a:schemeClr val="lt1"/>
+          </a:fontRef>
+        </p:style>
+        <p:txBody>
+          <a:bodyPr rtlCol="0" anchor="ctr" wrap="none" lIns="0" rIns="0" tIns="0" bIns="0"/>
+          <a:lstStyle/>
+          <a:p>
+            <a:pPr algn="ctr"/>
+            <a:r>
+              <a:rPr sz="750" b="1" i="0">
+                <a:solidFill>
+                  <a:srgbClr val="FFFFFF"/>
+                </a:solidFill>
+                <a:latin typeface="Calibri"/>
+              </a:rPr>
+              <a:t>C4</a:t>
+            </a:r>
+          </a:p>
+        </p:txBody>
+      </p:sp>
+      <p:sp>
+        <p:nvSpPr>
+          <p:cNvPr id="22" name="Oval 21"/>
+          <p:cNvSpPr/>
+          <p:nvPr/>
+        </p:nvSpPr>
+        <p:spPr>
+          <a:xfrm>
+            <a:off x="3008376" y="5001767"/>
+            <a:ext cx="292608" cy="292608"/>
+          </a:xfrm>
+          <a:prstGeom prst="ellipse">
+            <a:avLst/>
+          </a:prstGeom>
+          <a:solidFill>
+            <a:srgbClr val="E08A1E"/>
+          </a:solidFill>
+          <a:ln w="15240">
+            <a:solidFill>
+              <a:srgbClr val="FFFFFF"/>
+            </a:solidFill>
+          </a:ln>
+          <a:effectLst/>
+        </p:spPr>
+        <p:style>
+          <a:lnRef idx="1">
+            <a:schemeClr val="accent1"/>
+          </a:lnRef>
+          <a:fillRef idx="3">
+            <a:schemeClr val="accent1"/>
+          </a:fillRef>
+          <a:effectRef idx="2">
+            <a:schemeClr val="accent1"/>
+          </a:effectRef>
+          <a:fontRef idx="minor">
+            <a:schemeClr val="lt1"/>
+          </a:fontRef>
+        </p:style>
+        <p:txBody>
+          <a:bodyPr rtlCol="0" anchor="ctr" wrap="none" lIns="0" rIns="0" tIns="0" bIns="0"/>
+          <a:lstStyle/>
+          <a:p>
+            <a:pPr algn="ctr"/>
+            <a:r>
+              <a:rPr sz="750" b="1" i="0">
+                <a:solidFill>
+                  <a:srgbClr val="FFFFFF"/>
+                </a:solidFill>
+                <a:latin typeface="Calibri"/>
+              </a:rPr>
+              <a:t>F4</a:t>
+            </a:r>
+          </a:p>
+        </p:txBody>
+      </p:sp>
+      <p:sp>
+        <p:nvSpPr>
+          <p:cNvPr id="23" name="Oval 22"/>
+          <p:cNvSpPr/>
+          <p:nvPr/>
+        </p:nvSpPr>
+        <p:spPr>
+          <a:xfrm>
+            <a:off x="6766560" y="1956815"/>
+            <a:ext cx="292608" cy="292608"/>
+          </a:xfrm>
+          <a:prstGeom prst="ellipse">
+            <a:avLst/>
+          </a:prstGeom>
+          <a:solidFill>
+            <a:srgbClr val="7A4FC0"/>
+          </a:solidFill>
+          <a:ln w="15240">
+            <a:solidFill>
+              <a:srgbClr val="FFFFFF"/>
+            </a:solidFill>
+          </a:ln>
+          <a:effectLst/>
+        </p:spPr>
+        <p:style>
+          <a:lnRef idx="1">
+            <a:schemeClr val="accent1"/>
+          </a:lnRef>
+          <a:fillRef idx="3">
+            <a:schemeClr val="accent1"/>
+          </a:fillRef>
+          <a:effectRef idx="2">
+            <a:schemeClr val="accent1"/>
+          </a:effectRef>
+          <a:fontRef idx="minor">
+            <a:schemeClr val="lt1"/>
+          </a:fontRef>
+        </p:style>
+        <p:txBody>
+          <a:bodyPr rtlCol="0" anchor="ctr" wrap="none" lIns="0" rIns="0" tIns="0" bIns="0"/>
+          <a:lstStyle/>
+          <a:p>
+            <a:pPr algn="ctr"/>
+            <a:r>
+              <a:rPr sz="750" b="1" i="0">
+                <a:solidFill>
+                  <a:srgbClr val="FFFFFF"/>
+                </a:solidFill>
+                <a:latin typeface="Calibri"/>
+              </a:rPr>
+              <a:t>C1</a:t>
+            </a:r>
+          </a:p>
+        </p:txBody>
+      </p:sp>
+      <p:sp>
+        <p:nvSpPr>
+          <p:cNvPr id="24" name="Oval 23"/>
+          <p:cNvSpPr/>
+          <p:nvPr/>
+        </p:nvSpPr>
+        <p:spPr>
+          <a:xfrm>
+            <a:off x="4133087" y="1956815"/>
+            <a:ext cx="292608" cy="292608"/>
+          </a:xfrm>
+          <a:prstGeom prst="ellipse">
+            <a:avLst/>
+          </a:prstGeom>
+          <a:solidFill>
+            <a:srgbClr val="7A4FC0"/>
+          </a:solidFill>
+          <a:ln w="15240">
+            <a:solidFill>
+              <a:srgbClr val="FFFFFF"/>
+            </a:solidFill>
+          </a:ln>
+          <a:effectLst/>
+        </p:spPr>
+        <p:style>
+          <a:lnRef idx="1">
+            <a:schemeClr val="accent1"/>
+          </a:lnRef>
+          <a:fillRef idx="3">
+            <a:schemeClr val="accent1"/>
+          </a:fillRef>
+          <a:effectRef idx="2">
+            <a:schemeClr val="accent1"/>
+          </a:effectRef>
+          <a:fontRef idx="minor">
+            <a:schemeClr val="lt1"/>
+          </a:fontRef>
+        </p:style>
+        <p:txBody>
+          <a:bodyPr rtlCol="0" anchor="ctr" wrap="none" lIns="0" rIns="0" tIns="0" bIns="0"/>
+          <a:lstStyle/>
+          <a:p>
+            <a:pPr algn="ctr"/>
+            <a:r>
+              <a:rPr sz="750" b="1" i="0">
+                <a:solidFill>
+                  <a:srgbClr val="FFFFFF"/>
+                </a:solidFill>
+                <a:latin typeface="Calibri"/>
+              </a:rPr>
+              <a:t>C2</a:t>
+            </a:r>
+          </a:p>
+        </p:txBody>
+      </p:sp>
+      <p:sp>
+        <p:nvSpPr>
+          <p:cNvPr id="25" name="Oval 24"/>
+          <p:cNvSpPr/>
+          <p:nvPr/>
+        </p:nvSpPr>
+        <p:spPr>
+          <a:xfrm>
+            <a:off x="8083296" y="2670047"/>
+            <a:ext cx="292608" cy="292608"/>
+          </a:xfrm>
+          <a:prstGeom prst="ellipse">
+            <a:avLst/>
+          </a:prstGeom>
+          <a:solidFill>
+            <a:srgbClr val="E08A1E"/>
+          </a:solidFill>
+          <a:ln w="15240">
+            <a:solidFill>
+              <a:srgbClr val="FFFFFF"/>
+            </a:solidFill>
+          </a:ln>
+          <a:effectLst/>
+        </p:spPr>
+        <p:style>
+          <a:lnRef idx="1">
+            <a:schemeClr val="accent1"/>
+          </a:lnRef>
+          <a:fillRef idx="3">
+            <a:schemeClr val="accent1"/>
+          </a:fillRef>
+          <a:effectRef idx="2">
+            <a:schemeClr val="accent1"/>
+          </a:effectRef>
+          <a:fontRef idx="minor">
+            <a:schemeClr val="lt1"/>
+          </a:fontRef>
+        </p:style>
+        <p:txBody>
+          <a:bodyPr rtlCol="0" anchor="ctr" wrap="none" lIns="0" rIns="0" tIns="0" bIns="0"/>
+          <a:lstStyle/>
+          <a:p>
+            <a:pPr algn="ctr"/>
+            <a:r>
+              <a:rPr sz="750" b="1" i="0">
+                <a:solidFill>
+                  <a:srgbClr val="FFFFFF"/>
+                </a:solidFill>
+                <a:latin typeface="Calibri"/>
+              </a:rPr>
+              <a:t>F1</a:t>
+            </a:r>
+          </a:p>
+        </p:txBody>
+      </p:sp>
+      <p:sp>
+        <p:nvSpPr>
+          <p:cNvPr id="26" name="TextBox 25"/>
+          <p:cNvSpPr txBox="1"/>
+          <p:nvPr/>
+        </p:nvSpPr>
+        <p:spPr>
+          <a:xfrm>
+            <a:off x="1234439" y="1536192"/>
+            <a:ext cx="3657600" cy="274320"/>
+          </a:xfrm>
+          <a:prstGeom prst="rect">
+            <a:avLst/>
+          </a:prstGeom>
+          <a:noFill/>
+        </p:spPr>
+        <p:txBody>
+          <a:bodyPr wrap="square" anchor="t" lIns="0" rIns="0" tIns="0" bIns="0">
+            <a:spAutoFit/>
+          </a:bodyPr>
+          <a:lstStyle/>
+          <a:p>
+            <a:r>
+              <a:rPr sz="1000" b="1" i="0">
+                <a:solidFill>
+                  <a:srgbClr val="666666"/>
+                </a:solidFill>
+                <a:latin typeface="Calibri"/>
+              </a:rPr>
+              <a:t>↑ Квантовый потенциал</a:t>
+            </a:r>
+          </a:p>
+        </p:txBody>
+      </p:sp>
+      <p:sp>
+        <p:nvSpPr>
+          <p:cNvPr id="27" name="TextBox 26"/>
+          <p:cNvSpPr txBox="1"/>
+          <p:nvPr/>
+        </p:nvSpPr>
+        <p:spPr>
+          <a:xfrm>
+            <a:off x="1280160" y="6016752"/>
+            <a:ext cx="7315200" cy="274320"/>
+          </a:xfrm>
+          <a:prstGeom prst="rect">
+            <a:avLst/>
+          </a:prstGeom>
+          <a:noFill/>
+        </p:spPr>
+        <p:txBody>
+          <a:bodyPr wrap="square" anchor="t" lIns="0" rIns="0" tIns="0" bIns="0">
+            <a:spAutoFit/>
+          </a:bodyPr>
+          <a:lstStyle/>
+          <a:p>
+            <a:pPr algn="ctr"/>
+            <a:r>
+              <a:rPr sz="1000" b="1" i="0">
+                <a:solidFill>
+                  <a:srgbClr val="666666"/>
+                </a:solidFill>
+                <a:latin typeface="Calibri"/>
+              </a:rPr>
+              <a:t>Бизнес-ценность / реализуемость →</a:t>
+            </a:r>
+          </a:p>
+        </p:txBody>
+      </p:sp>
+      <p:sp>
+        <p:nvSpPr>
+          <p:cNvPr id="28" name="TextBox 27"/>
+          <p:cNvSpPr txBox="1"/>
+          <p:nvPr/>
+        </p:nvSpPr>
+        <p:spPr>
+          <a:xfrm>
+            <a:off x="8915400" y="1828800"/>
+            <a:ext cx="2697480" cy="320040"/>
+          </a:xfrm>
+          <a:prstGeom prst="rect">
+            <a:avLst/>
+          </a:prstGeom>
+          <a:noFill/>
+        </p:spPr>
+        <p:txBody>
+          <a:bodyPr wrap="square" anchor="t" lIns="0" rIns="0" tIns="0" bIns="0">
+            <a:spAutoFit/>
+          </a:bodyPr>
+          <a:lstStyle/>
+          <a:p>
+            <a:r>
+              <a:rPr sz="1250" b="1" i="0">
+                <a:solidFill>
+                  <a:srgbClr val="1A3E8C"/>
+                </a:solidFill>
+                <a:latin typeface="Calibri"/>
+              </a:rPr>
+              <a:t>Направления</a:t>
+            </a:r>
+          </a:p>
+        </p:txBody>
+      </p:sp>
+      <p:sp>
+        <p:nvSpPr>
+          <p:cNvPr id="29" name="Oval 28"/>
+          <p:cNvSpPr/>
+          <p:nvPr/>
+        </p:nvSpPr>
+        <p:spPr>
+          <a:xfrm>
+            <a:off x="8915400" y="2286000"/>
+            <a:ext cx="201168" cy="201168"/>
+          </a:xfrm>
+          <a:prstGeom prst="ellipse">
+            <a:avLst/>
+          </a:prstGeom>
+          <a:solidFill>
+            <a:srgbClr val="2D6CDF"/>
+          </a:solidFill>
+          <a:ln>
+            <a:noFill/>
+          </a:ln>
+          <a:effectLst/>
+        </p:spPr>
+        <p:style>
+          <a:lnRef idx="1">
+            <a:schemeClr val="accent1"/>
+          </a:lnRef>
+          <a:fillRef idx="3">
+            <a:schemeClr val="accent1"/>
+          </a:fillRef>
+          <a:effectRef idx="2">
+            <a:schemeClr val="accent1"/>
+          </a:effectRef>
+          <a:fontRef idx="minor">
+            <a:schemeClr val="lt1"/>
+          </a:fontRef>
+        </p:style>
+        <p:txBody>
+          <a:bodyPr rtlCol="0" anchor="ctr"/>
+          <a:lstStyle/>
+          <a:p>
+            <a:pPr algn="ctr"/>
+          </a:p>
+        </p:txBody>
+      </p:sp>
+      <p:sp>
+        <p:nvSpPr>
+          <p:cNvPr id="30" name="TextBox 29"/>
+          <p:cNvSpPr txBox="1"/>
+          <p:nvPr/>
+        </p:nvSpPr>
+        <p:spPr>
+          <a:xfrm>
+            <a:off x="9208008" y="2267712"/>
+            <a:ext cx="2377440" cy="274320"/>
+          </a:xfrm>
+          <a:prstGeom prst="rect">
+            <a:avLst/>
+          </a:prstGeom>
+          <a:noFill/>
+        </p:spPr>
+        <p:txBody>
+          <a:bodyPr wrap="square" anchor="t" lIns="0" rIns="0" tIns="0" bIns="0">
+            <a:spAutoFit/>
+          </a:bodyPr>
+          <a:lstStyle/>
+          <a:p>
+            <a:r>
+              <a:rPr sz="1100" b="0" i="0">
+                <a:solidFill>
+                  <a:srgbClr val="2B2B2B"/>
+                </a:solidFill>
+                <a:latin typeface="Calibri"/>
+              </a:rPr>
+              <a:t>Логистика</a:t>
+            </a:r>
+          </a:p>
+        </p:txBody>
+      </p:sp>
+      <p:sp>
+        <p:nvSpPr>
+          <p:cNvPr id="31" name="Oval 30"/>
+          <p:cNvSpPr/>
+          <p:nvPr/>
+        </p:nvSpPr>
+        <p:spPr>
+          <a:xfrm>
+            <a:off x="8915400" y="2670048"/>
+            <a:ext cx="201168" cy="201168"/>
+          </a:xfrm>
+          <a:prstGeom prst="ellipse">
+            <a:avLst/>
+          </a:prstGeom>
+          <a:solidFill>
+            <a:srgbClr val="1E8E5A"/>
+          </a:solidFill>
+          <a:ln>
+            <a:noFill/>
+          </a:ln>
+          <a:effectLst/>
+        </p:spPr>
+        <p:style>
+          <a:lnRef idx="1">
+            <a:schemeClr val="accent1"/>
+          </a:lnRef>
+          <a:fillRef idx="3">
+            <a:schemeClr val="accent1"/>
+          </a:fillRef>
+          <a:effectRef idx="2">
+            <a:schemeClr val="accent1"/>
+          </a:effectRef>
+          <a:fontRef idx="minor">
+            <a:schemeClr val="lt1"/>
+          </a:fontRef>
+        </p:style>
+        <p:txBody>
+          <a:bodyPr rtlCol="0" anchor="ctr"/>
+          <a:lstStyle/>
+          <a:p>
+            <a:pPr algn="ctr"/>
+          </a:p>
+        </p:txBody>
+      </p:sp>
+      <p:sp>
+        <p:nvSpPr>
+          <p:cNvPr id="32" name="TextBox 31"/>
+          <p:cNvSpPr txBox="1"/>
+          <p:nvPr/>
+        </p:nvSpPr>
+        <p:spPr>
+          <a:xfrm>
+            <a:off x="9208008" y="2651760"/>
+            <a:ext cx="2377440" cy="274320"/>
+          </a:xfrm>
+          <a:prstGeom prst="rect">
+            <a:avLst/>
+          </a:prstGeom>
+          <a:noFill/>
+        </p:spPr>
+        <p:txBody>
+          <a:bodyPr wrap="square" anchor="t" lIns="0" rIns="0" tIns="0" bIns="0">
+            <a:spAutoFit/>
+          </a:bodyPr>
+          <a:lstStyle/>
+          <a:p>
+            <a:r>
+              <a:rPr sz="1100" b="0" i="0">
+                <a:solidFill>
+                  <a:srgbClr val="2B2B2B"/>
+                </a:solidFill>
+                <a:latin typeface="Calibri"/>
+              </a:rPr>
+              <a:t>Производство</a:t>
+            </a:r>
+          </a:p>
+        </p:txBody>
+      </p:sp>
+      <p:sp>
+        <p:nvSpPr>
+          <p:cNvPr id="33" name="Oval 32"/>
+          <p:cNvSpPr/>
+          <p:nvPr/>
+        </p:nvSpPr>
+        <p:spPr>
+          <a:xfrm>
+            <a:off x="8915400" y="3054096"/>
+            <a:ext cx="201168" cy="201168"/>
+          </a:xfrm>
+          <a:prstGeom prst="ellipse">
+            <a:avLst/>
+          </a:prstGeom>
+          <a:solidFill>
+            <a:srgbClr val="7A4FC0"/>
+          </a:solidFill>
+          <a:ln>
+            <a:noFill/>
+          </a:ln>
+          <a:effectLst/>
+        </p:spPr>
+        <p:style>
+          <a:lnRef idx="1">
+            <a:schemeClr val="accent1"/>
+          </a:lnRef>
+          <a:fillRef idx="3">
+            <a:schemeClr val="accent1"/>
+          </a:fillRef>
+          <a:effectRef idx="2">
+            <a:schemeClr val="accent1"/>
+          </a:effectRef>
+          <a:fontRef idx="minor">
+            <a:schemeClr val="lt1"/>
+          </a:fontRef>
+        </p:style>
+        <p:txBody>
+          <a:bodyPr rtlCol="0" anchor="ctr"/>
+          <a:lstStyle/>
+          <a:p>
+            <a:pPr algn="ctr"/>
+          </a:p>
+        </p:txBody>
+      </p:sp>
+      <p:sp>
+        <p:nvSpPr>
+          <p:cNvPr id="34" name="TextBox 33"/>
+          <p:cNvSpPr txBox="1"/>
+          <p:nvPr/>
+        </p:nvSpPr>
+        <p:spPr>
+          <a:xfrm>
+            <a:off x="9208008" y="3035808"/>
+            <a:ext cx="2377440" cy="274320"/>
+          </a:xfrm>
+          <a:prstGeom prst="rect">
+            <a:avLst/>
+          </a:prstGeom>
+          <a:noFill/>
+        </p:spPr>
+        <p:txBody>
+          <a:bodyPr wrap="square" anchor="t" lIns="0" rIns="0" tIns="0" bIns="0">
+            <a:spAutoFit/>
+          </a:bodyPr>
+          <a:lstStyle/>
+          <a:p>
+            <a:r>
+              <a:rPr sz="1100" b="0" i="0">
+                <a:solidFill>
+                  <a:srgbClr val="2B2B2B"/>
+                </a:solidFill>
+                <a:latin typeface="Calibri"/>
+              </a:rPr>
+              <a:t>Химия</a:t>
+            </a:r>
+          </a:p>
+        </p:txBody>
+      </p:sp>
+      <p:sp>
+        <p:nvSpPr>
+          <p:cNvPr id="35" name="Oval 34"/>
+          <p:cNvSpPr/>
+          <p:nvPr/>
+        </p:nvSpPr>
+        <p:spPr>
+          <a:xfrm>
+            <a:off x="8915400" y="3438144"/>
+            <a:ext cx="201168" cy="201168"/>
+          </a:xfrm>
+          <a:prstGeom prst="ellipse">
+            <a:avLst/>
+          </a:prstGeom>
+          <a:solidFill>
+            <a:srgbClr val="E08A1E"/>
+          </a:solidFill>
+          <a:ln>
+            <a:noFill/>
+          </a:ln>
+          <a:effectLst/>
+        </p:spPr>
+        <p:style>
+          <a:lnRef idx="1">
+            <a:schemeClr val="accent1"/>
+          </a:lnRef>
+          <a:fillRef idx="3">
+            <a:schemeClr val="accent1"/>
+          </a:fillRef>
+          <a:effectRef idx="2">
+            <a:schemeClr val="accent1"/>
+          </a:effectRef>
+          <a:fontRef idx="minor">
+            <a:schemeClr val="lt1"/>
+          </a:fontRef>
+        </p:style>
+        <p:txBody>
+          <a:bodyPr rtlCol="0" anchor="ctr"/>
+          <a:lstStyle/>
+          <a:p>
+            <a:pPr algn="ctr"/>
+          </a:p>
+        </p:txBody>
+      </p:sp>
+      <p:sp>
+        <p:nvSpPr>
+          <p:cNvPr id="36" name="TextBox 35"/>
+          <p:cNvSpPr txBox="1"/>
+          <p:nvPr/>
+        </p:nvSpPr>
+        <p:spPr>
+          <a:xfrm>
+            <a:off x="9208008" y="3419856"/>
+            <a:ext cx="2377440" cy="274320"/>
+          </a:xfrm>
+          <a:prstGeom prst="rect">
+            <a:avLst/>
+          </a:prstGeom>
+          <a:noFill/>
+        </p:spPr>
+        <p:txBody>
+          <a:bodyPr wrap="square" anchor="t" lIns="0" rIns="0" tIns="0" bIns="0">
+            <a:spAutoFit/>
+          </a:bodyPr>
+          <a:lstStyle/>
+          <a:p>
+            <a:r>
+              <a:rPr sz="1100" b="0" i="0">
+                <a:solidFill>
+                  <a:srgbClr val="2B2B2B"/>
+                </a:solidFill>
+                <a:latin typeface="Calibri"/>
+              </a:rPr>
+              <a:t>Финансы</a:t>
+            </a:r>
+          </a:p>
+        </p:txBody>
+      </p:sp>
+      <p:sp>
+        <p:nvSpPr>
+          <p:cNvPr id="37" name="Rounded Rectangle 36"/>
+          <p:cNvSpPr/>
+          <p:nvPr/>
+        </p:nvSpPr>
+        <p:spPr>
+          <a:xfrm>
+            <a:off x="8915400" y="3977639"/>
+            <a:ext cx="2697480" cy="2240280"/>
+          </a:xfrm>
+          <a:prstGeom prst="roundRect">
+            <a:avLst/>
+          </a:prstGeom>
+          <a:solidFill>
+            <a:srgbClr val="FFFFFF"/>
+          </a:solidFill>
+          <a:ln w="12700">
+            <a:solidFill>
+              <a:srgbClr val="D9E1F2"/>
+            </a:solidFill>
+          </a:ln>
+          <a:effectLst/>
+        </p:spPr>
+        <p:style>
+          <a:lnRef idx="1">
+            <a:schemeClr val="accent1"/>
+          </a:lnRef>
+          <a:fillRef idx="3">
+            <a:schemeClr val="accent1"/>
+          </a:fillRef>
+          <a:effectRef idx="2">
+            <a:schemeClr val="accent1"/>
+          </a:effectRef>
+          <a:fontRef idx="minor">
+            <a:schemeClr val="lt1"/>
+          </a:fontRef>
+        </p:style>
+        <p:txBody>
+          <a:bodyPr rtlCol="0" anchor="ctr" wrap="square" lIns="146304" rIns="128016" tIns="109728" bIns="73152"/>
+          <a:lstStyle/>
+          <a:p>
+            <a:pPr algn="ctr"/>
+            <a:r>
+              <a:rPr sz="1200" b="1" i="0">
+                <a:solidFill>
+                  <a:srgbClr val="1A3E8C"/>
+                </a:solidFill>
+                <a:latin typeface="Calibri"/>
+              </a:rPr>
+              <a:t>Как читать</a:t>
+            </a:r>
+          </a:p>
+          <a:p>
+            <a:pPr>
+              <a:spcBef>
+                <a:spcPts val="400"/>
+              </a:spcBef>
+            </a:pPr>
+            <a:r>
+              <a:rPr sz="980" b="0" i="0">
+                <a:solidFill>
+                  <a:srgbClr val="2B2B2B"/>
+                </a:solidFill>
+                <a:latin typeface="Calibri"/>
+              </a:rPr>
+              <a:t>Каждая точка — 1 кейс (ID из CSV)</a:t>
+            </a:r>
+          </a:p>
+          <a:p>
+            <a:pPr>
+              <a:spcBef>
+                <a:spcPts val="400"/>
+              </a:spcBef>
+            </a:pPr>
+            <a:r>
+              <a:rPr sz="980" b="0" i="0">
+                <a:solidFill>
+                  <a:srgbClr val="2B2B2B"/>
+                </a:solidFill>
+                <a:latin typeface="Calibri"/>
+              </a:rPr>
+              <a:t>Положение = баллы движка (X×Y)</a:t>
+            </a:r>
+          </a:p>
+          <a:p>
+            <a:pPr>
+              <a:spcBef>
+                <a:spcPts val="400"/>
+              </a:spcBef>
+            </a:pPr>
+            <a:r>
+              <a:rPr sz="980" b="0" i="0">
+                <a:solidFill>
+                  <a:srgbClr val="2B2B2B"/>
+                </a:solidFill>
+                <a:latin typeface="Calibri"/>
+              </a:rPr>
+              <a:t>Точки в одной ячейке разнесены для читаемости</a:t>
+            </a:r>
+          </a:p>
+          <a:p>
+            <a:pPr>
+              <a:spcBef>
+                <a:spcPts val="400"/>
+              </a:spcBef>
+            </a:pPr>
+            <a:r>
+              <a:rPr sz="980" b="0" i="0">
+                <a:solidFill>
+                  <a:srgbClr val="2B2B2B"/>
+                </a:solidFill>
+                <a:latin typeface="Calibri"/>
+              </a:rPr>
+              <a:t>Квадрант = вердикт приоритизации</a:t>
             </a:r>
           </a:p>
         </p:txBody>
@@ -4540,7 +6374,7 @@
                 </a:solidFill>
                 <a:latin typeface="Calibri"/>
               </a:rPr>
-              <a:t>2 / 10</a:t>
+              <a:t>2 / 11</a:t>
             </a:r>
           </a:p>
         </p:txBody>
@@ -5217,7 +7051,7 @@
                 </a:solidFill>
                 <a:latin typeface="Calibri"/>
               </a:rPr>
-              <a:t>3 / 10</a:t>
+              <a:t>3 / 11</a:t>
             </a:r>
           </a:p>
         </p:txBody>
@@ -6487,7 +8321,7 @@
                 </a:solidFill>
                 <a:latin typeface="Calibri"/>
               </a:rPr>
-              <a:t>4 / 10</a:t>
+              <a:t>4 / 11</a:t>
             </a:r>
           </a:p>
         </p:txBody>
@@ -7341,7 +9175,7 @@
                 </a:solidFill>
                 <a:latin typeface="Calibri"/>
               </a:rPr>
-              <a:t>5 / 10</a:t>
+              <a:t>5 / 11</a:t>
             </a:r>
           </a:p>
         </p:txBody>
@@ -8314,7 +10148,7 @@
                 </a:solidFill>
                 <a:latin typeface="Calibri"/>
               </a:rPr>
-              <a:t>6 / 10</a:t>
+              <a:t>6 / 11</a:t>
             </a:r>
           </a:p>
         </p:txBody>
@@ -9025,7 +10859,7 @@
                 </a:solidFill>
                 <a:latin typeface="Calibri"/>
               </a:rPr>
-              <a:t>7 / 10</a:t>
+              <a:t>7 / 11</a:t>
             </a:r>
           </a:p>
         </p:txBody>
@@ -10005,7 +11839,7 @@
                 </a:solidFill>
                 <a:latin typeface="Calibri"/>
               </a:rPr>
-              <a:t>8 / 10</a:t>
+              <a:t>8 / 11</a:t>
             </a:r>
           </a:p>
         </p:txBody>
@@ -10835,7 +12669,7 @@
                 </a:solidFill>
                 <a:latin typeface="Calibri"/>
               </a:rPr>
-              <a:t>9 / 10</a:t>
+              <a:t>9 / 11</a:t>
             </a:r>
           </a:p>
         </p:txBody>

</xml_diff>